<commit_message>
Clear name/number placeholders on closing slide
Co-Authored-By: Claude Sonnet 5.5 <noreply@anthropic.com>
Claude-Session: https://claude.ai/code/session_01TyFKmLJqyxNygHvjK9ydxU
</commit_message>
<xml_diff>
--- a/Makale1_Dinledigini_Anlama_Ozet.pptx
+++ b/Makale1_Dinledigini_Anlama_Ozet.pptx
@@ -5686,7 +5686,7 @@
               <a:rPr sz="2400" b="0">
                 <a:latin typeface="Times New Roman"/>
               </a:rPr>
-              <a:t>[Ad Soyad]</a:t>
+              <a:t/>
             </a:r>
           </a:p>
           <a:p>
@@ -5694,7 +5694,7 @@
               <a:rPr sz="2400" b="0">
                 <a:latin typeface="Times New Roman"/>
               </a:rPr>
-              <a:t>[Öğrenci No]</a:t>
+              <a:t/>
             </a:r>
           </a:p>
           <a:p>

</xml_diff>

<commit_message>
Makale1: orange cover, presenter names, full reference list
Co-Authored-By: Claude Sonnet 5.5 <noreply@anthropic.com>
Claude-Session: https://claude.ai/code/session_01TyFKmLJqyxNygHvjK9ydxU
</commit_message>
<xml_diff>
--- a/Makale1_Dinledigini_Anlama_Ozet.pptx
+++ b/Makale1_Dinledigini_Anlama_Ozet.pptx
@@ -26,7 +26,10 @@
     <p:sldId id="271" r:id="rId22"/>
     <p:sldId id="272" r:id="rId23"/>
     <p:sldId id="273" r:id="rId24"/>
-    <p:sldId id="274" r:id="rId25"/>
+    <p:sldId id="276" r:id="rId27"/>
+    <p:sldId id="277" r:id="rId28"/>
+    <p:sldId id="278" r:id="rId29"/>
+    <p:sldId id="279" r:id="rId30"/>
     <p:sldId id="275" r:id="rId26"/>
   </p:sldIdLst>
   <p:sldSz cx="9144000" cy="6858000" type="screen4x3"/>
@@ -3553,7 +3556,10 @@
           <a:lstStyle/>
           <a:p>
             <a:r>
-              <a:rPr sz="3400">
+              <a:rPr sz="3400" b="1">
+                <a:solidFill>
+                  <a:srgbClr val="E36C0A"/>
+                </a:solidFill>
                 <a:latin typeface="Times New Roman"/>
               </a:rPr>
               <a:t>Hafif Düzeyde Zihinsel Yetersizliği Olan Kaynaştırma Öğrencilerinin Dinlediğini Anlama Becerilerinin İncelenmesi</a:t>
@@ -3578,6 +3584,9 @@
           <a:p>
             <a:r>
               <a:rPr sz="2000" b="1">
+                <a:solidFill>
+                  <a:srgbClr val="E36C0A"/>
+                </a:solidFill>
                 <a:latin typeface="Times New Roman"/>
               </a:rPr>
               <a:t>İbrahim COŞKUN</a:t>
@@ -3586,6 +3595,9 @@
           <a:p>
             <a:r>
               <a:rPr sz="2000" b="1">
+                <a:solidFill>
+                  <a:srgbClr val="E36C0A"/>
+                </a:solidFill>
                 <a:latin typeface="Times New Roman"/>
               </a:rPr>
               <a:t>Gül ERDİN</a:t>
@@ -3621,6 +3633,49 @@
               <a:t>‹#›</a:t>
             </a:fld>
             <a:endParaRPr lang="tr-TR"/>
+          </a:p>
+        </p:txBody>
+      </p:sp>
+      <p:sp>
+        <p:nvSpPr>
+          <p:cNvPr id="7" name="Rectangle 6"/>
+          <p:cNvSpPr/>
+          <p:nvPr/>
+        </p:nvSpPr>
+        <p:spPr>
+          <a:xfrm>
+            <a:off x="685800" y="1750000"/>
+            <a:ext cx="7543800" cy="70000"/>
+          </a:xfrm>
+          <a:prstGeom prst="rect">
+            <a:avLst/>
+          </a:prstGeom>
+          <a:solidFill>
+            <a:srgbClr val="E36C0A"/>
+          </a:solidFill>
+          <a:ln>
+            <a:noFill/>
+          </a:ln>
+        </p:spPr>
+        <p:style>
+          <a:lnRef idx="1">
+            <a:schemeClr val="accent1"/>
+          </a:lnRef>
+          <a:fillRef idx="3">
+            <a:schemeClr val="accent1"/>
+          </a:fillRef>
+          <a:effectRef idx="2">
+            <a:schemeClr val="accent1"/>
+          </a:effectRef>
+          <a:fontRef idx="minor">
+            <a:schemeClr val="lt1"/>
+          </a:fontRef>
+        </p:style>
+        <p:txBody>
+          <a:bodyPr rtlCol="0" anchor="ctr"/>
+          <a:lstStyle/>
+          <a:p>
+            <a:pPr algn="ctr"/>
           </a:p>
         </p:txBody>
       </p:sp>
@@ -5335,180 +5390,6 @@
 </p:sld>
 </file>
 
-<file path=ppt/slides/slide19.xml><?xml version="1.0" encoding="utf-8"?>
-<p:sld xmlns:a="http://schemas.openxmlformats.org/drawingml/2006/main" xmlns:p="http://schemas.openxmlformats.org/presentationml/2006/main" xmlns:r="http://schemas.openxmlformats.org/officeDocument/2006/relationships">
-  <p:cSld>
-    <p:spTree>
-      <p:nvGrpSpPr>
-        <p:cNvPr id="1" name=""/>
-        <p:cNvGrpSpPr/>
-        <p:nvPr/>
-      </p:nvGrpSpPr>
-      <p:grpSpPr/>
-      <p:sp>
-        <p:nvSpPr>
-          <p:cNvPr id="2" name="Title 1"/>
-          <p:cNvSpPr>
-            <a:spLocks noGrp="1"/>
-          </p:cNvSpPr>
-          <p:nvPr>
-            <p:ph type="title"/>
-          </p:nvPr>
-        </p:nvSpPr>
-        <p:spPr/>
-        <p:txBody>
-          <a:bodyPr/>
-          <a:lstStyle/>
-          <a:p>
-            <a:r>
-              <a:rPr b="1">
-                <a:latin typeface="Times New Roman"/>
-              </a:rPr>
-              <a:t>Kaynakça (Seçme)</a:t>
-            </a:r>
-          </a:p>
-        </p:txBody>
-      </p:sp>
-      <p:sp>
-        <p:nvSpPr>
-          <p:cNvPr id="3" name="Content Placeholder 2"/>
-          <p:cNvSpPr>
-            <a:spLocks noGrp="1"/>
-          </p:cNvSpPr>
-          <p:nvPr>
-            <p:ph idx="1"/>
-          </p:nvPr>
-        </p:nvSpPr>
-        <p:spPr/>
-        <p:txBody>
-          <a:bodyPr wrap="square">
-            <a:noAutofit/>
-          </a:bodyPr>
-          <a:lstStyle/>
-          <a:p>
-            <a:pPr>
-              <a:spcAft>
-                <a:spcPts val="600"/>
-              </a:spcAft>
-            </a:pPr>
-            <a:r>
-              <a:rPr sz="1800" b="0">
-                <a:latin typeface="Times New Roman"/>
-              </a:rPr>
-              <a:t>AAMR (2002). Mental Retardation: Definition, Classification, and Systems of Supports (10. Baskı). Washington DC: AAMR.</a:t>
-            </a:r>
-          </a:p>
-          <a:p>
-            <a:pPr>
-              <a:spcAft>
-                <a:spcPts val="600"/>
-              </a:spcAft>
-            </a:pPr>
-            <a:r>
-              <a:rPr sz="1800" b="0">
-                <a:latin typeface="Times New Roman"/>
-              </a:rPr>
-              <a:t>Eripek, S. (2005). Zekâ Geriliği. Ankara: Kök Yayıncılık.</a:t>
-            </a:r>
-          </a:p>
-          <a:p>
-            <a:pPr>
-              <a:spcAft>
-                <a:spcPts val="600"/>
-              </a:spcAft>
-            </a:pPr>
-            <a:r>
-              <a:rPr sz="1800" b="0">
-                <a:latin typeface="Times New Roman"/>
-              </a:rPr>
-              <a:t>Graesser, A., Golding, J. M., &amp; Long, D. L. (1991). Narrative Representation and Comprehension. Handbook of Reading Research (Vol. II).</a:t>
-            </a:r>
-          </a:p>
-          <a:p>
-            <a:pPr>
-              <a:spcAft>
-                <a:spcPts val="600"/>
-              </a:spcAft>
-            </a:pPr>
-            <a:r>
-              <a:rPr sz="1800" b="0">
-                <a:latin typeface="Times New Roman"/>
-              </a:rPr>
-              <a:t>Kırcaali-İftar, G. (1998). Özel Eğitim. Eskişehir: Anadolu Üniversitesi Yayınları.</a:t>
-            </a:r>
-          </a:p>
-          <a:p>
-            <a:pPr>
-              <a:spcAft>
-                <a:spcPts val="600"/>
-              </a:spcAft>
-            </a:pPr>
-            <a:r>
-              <a:rPr sz="1800" b="0">
-                <a:latin typeface="Times New Roman"/>
-              </a:rPr>
-              <a:t>Sucuoğlu, B. (2010). Zihin Engelliler ve Eğitimleri. Ankara: Kök Yayıncılık.</a:t>
-            </a:r>
-          </a:p>
-          <a:p>
-            <a:pPr>
-              <a:spcAft>
-                <a:spcPts val="600"/>
-              </a:spcAft>
-            </a:pPr>
-            <a:r>
-              <a:rPr sz="1800" b="0">
-                <a:latin typeface="Times New Roman"/>
-              </a:rPr>
-              <a:t>Doğan, Y. (2012). Dinleme Eğitimi. Ankara: Pegem Akademi.</a:t>
-            </a:r>
-          </a:p>
-          <a:p>
-            <a:pPr>
-              <a:spcAft>
-                <a:spcPts val="600"/>
-              </a:spcAft>
-            </a:pPr>
-            <a:r>
-              <a:rPr sz="1800" b="0">
-                <a:latin typeface="Times New Roman"/>
-              </a:rPr>
-              <a:t>Creswell, J. W. (2007). Qualitative Inquiry and Research Design (2nd ed.). London: Sage.</a:t>
-            </a:r>
-          </a:p>
-        </p:txBody>
-      </p:sp>
-      <p:sp>
-        <p:nvSpPr>
-          <p:cNvPr id="6" name="Slide Number Placeholder 5"/>
-          <p:cNvSpPr>
-            <a:spLocks noGrp="1"/>
-          </p:cNvSpPr>
-          <p:nvPr>
-            <p:ph type="sldNum" sz="quarter" idx="12"/>
-          </p:nvPr>
-        </p:nvSpPr>
-        <p:spPr/>
-        <p:txBody>
-          <a:bodyPr/>
-          <a:lstStyle/>
-          <a:p>
-            <a:fld id="{F302176B-0E47-46AC-8F43-DAB4B8A37D06}" type="slidenum">
-              <a:rPr lang="tr-TR" smtClean="0"/>
-              <a:t>‹#›</a:t>
-            </a:fld>
-            <a:endParaRPr lang="tr-TR"/>
-          </a:p>
-        </p:txBody>
-      </p:sp>
-    </p:spTree>
-  </p:cSld>
-  <p:clrMapOvr>
-    <a:masterClrMapping/>
-  </p:clrMapOvr>
-</p:sld>
-</file>
-
 <file path=ppt/slides/slide2.xml><?xml version="1.0" encoding="utf-8"?>
 <p:sld xmlns:a="http://schemas.openxmlformats.org/drawingml/2006/main" xmlns:p="http://schemas.openxmlformats.org/presentationml/2006/main" xmlns:r="http://schemas.openxmlformats.org/officeDocument/2006/relationships">
   <p:cSld>
@@ -5620,6 +5501,40 @@
               <a:t>‹#›</a:t>
             </a:fld>
             <a:endParaRPr lang="tr-TR"/>
+          </a:p>
+        </p:txBody>
+      </p:sp>
+      <p:sp>
+        <p:nvSpPr>
+          <p:cNvPr id="7" name="TextBox 6"/>
+          <p:cNvSpPr txBox="1"/>
+          <p:nvPr/>
+        </p:nvSpPr>
+        <p:spPr>
+          <a:xfrm>
+            <a:off x="457200" y="6380000"/>
+            <a:ext cx="6500000" cy="380000"/>
+          </a:xfrm>
+          <a:prstGeom prst="rect">
+            <a:avLst/>
+          </a:prstGeom>
+          <a:noFill/>
+        </p:spPr>
+        <p:txBody>
+          <a:bodyPr wrap="none">
+            <a:spAutoFit/>
+          </a:bodyPr>
+          <a:lstStyle/>
+          <a:p>
+            <a:r>
+              <a:rPr sz="1600" b="1">
+                <a:solidFill>
+                  <a:srgbClr val="E36C0A"/>
+                </a:solidFill>
+                <a:latin typeface="Times New Roman"/>
+              </a:rPr>
+              <a:t>Sunan: Feyza BÜYÜKBEKTAŞ</a:t>
+            </a:r>
           </a:p>
         </p:txBody>
       </p:sp>
@@ -5755,6 +5670,968 @@
 </p:sld>
 </file>
 
+<file path=ppt/slides/slide21.xml><?xml version="1.0" encoding="utf-8"?>
+<p:sld xmlns:a="http://schemas.openxmlformats.org/drawingml/2006/main" xmlns:p="http://schemas.openxmlformats.org/presentationml/2006/main" xmlns:r="http://schemas.openxmlformats.org/officeDocument/2006/relationships">
+  <p:cSld>
+    <p:spTree>
+      <p:nvGrpSpPr>
+        <p:cNvPr id="1" name=""/>
+        <p:cNvGrpSpPr/>
+        <p:nvPr/>
+      </p:nvGrpSpPr>
+      <p:grpSpPr/>
+      <p:sp>
+        <p:nvSpPr>
+          <p:cNvPr id="2" name="Title 1"/>
+          <p:cNvSpPr>
+            <a:spLocks noGrp="1"/>
+          </p:cNvSpPr>
+          <p:nvPr>
+            <p:ph type="title"/>
+          </p:nvPr>
+        </p:nvSpPr>
+        <p:spPr/>
+        <p:txBody>
+          <a:bodyPr/>
+          <a:lstStyle/>
+          <a:p>
+            <a:r>
+              <a:rPr b="1">
+                <a:latin typeface="Times New Roman"/>
+              </a:rPr>
+              <a:t>Kaynakça (1/4)</a:t>
+            </a:r>
+          </a:p>
+        </p:txBody>
+      </p:sp>
+      <p:sp>
+        <p:nvSpPr>
+          <p:cNvPr id="3" name="Content Placeholder 2"/>
+          <p:cNvSpPr>
+            <a:spLocks noGrp="1"/>
+          </p:cNvSpPr>
+          <p:nvPr>
+            <p:ph idx="1"/>
+          </p:nvPr>
+        </p:nvSpPr>
+        <p:spPr/>
+        <p:txBody>
+          <a:bodyPr wrap="square">
+            <a:noAutofit/>
+          </a:bodyPr>
+          <a:lstStyle/>
+          <a:p>
+            <a:pPr marL="228600" indent="-228600">
+              <a:spcAft>
+                <a:spcPts val="500"/>
+              </a:spcAft>
+              <a:buNone/>
+            </a:pPr>
+            <a:r>
+              <a:rPr sz="1300" b="0">
+                <a:latin typeface="Times New Roman"/>
+              </a:rPr>
+              <a:t>AAMR, (2002). Mental Retardation: Definition, Classification, and Systems of Supports (10. Baskı). Washington DC: AAMR</a:t>
+            </a:r>
+          </a:p>
+          <a:p>
+            <a:pPr marL="228600" indent="-228600">
+              <a:spcAft>
+                <a:spcPts val="500"/>
+              </a:spcAft>
+              <a:buNone/>
+            </a:pPr>
+            <a:r>
+              <a:rPr sz="1300" b="0">
+                <a:latin typeface="Times New Roman"/>
+              </a:rPr>
+              <a:t>Akyol, H. (1999). Hikâye Haritası Yöntemiyle Metin Öğretimi. Milli Eğitim, 142. (Online): Web: http://yayim.meb.gov.tr/dergiler/medergi/15.htm (Erişim Tarihi: 13.11.2013)</a:t>
+            </a:r>
+          </a:p>
+          <a:p>
+            <a:pPr marL="228600" indent="-228600">
+              <a:spcAft>
+                <a:spcPts val="500"/>
+              </a:spcAft>
+              <a:buNone/>
+            </a:pPr>
+            <a:r>
+              <a:rPr sz="1300" b="0">
+                <a:latin typeface="Times New Roman"/>
+              </a:rPr>
+              <a:t>American Psychiatric Association. (2000). "Diagnostic criteria for 299.80 Asperger's Disorder (AD)". Diagnostic and Statistical Manual of Mental Disorders (4th ed., text revision bas.). ISBN 0-89042-025-4. (Erişim Tarihi: 17.09.2013)</a:t>
+            </a:r>
+          </a:p>
+          <a:p>
+            <a:pPr marL="228600" indent="-228600">
+              <a:spcAft>
+                <a:spcPts val="500"/>
+              </a:spcAft>
+              <a:buNone/>
+            </a:pPr>
+            <a:r>
+              <a:rPr sz="1300" b="0">
+                <a:latin typeface="Times New Roman"/>
+              </a:rPr>
+              <a:t>Baskin, J. H., Sperber, M.&amp;Price B. H. (2006). "Asperger Syndrome Revisited". Rev Neurol Dis 3 (1): 1–7.</a:t>
+            </a:r>
+          </a:p>
+          <a:p>
+            <a:pPr marL="228600" indent="-228600">
+              <a:spcAft>
+                <a:spcPts val="500"/>
+              </a:spcAft>
+              <a:buNone/>
+            </a:pPr>
+            <a:r>
+              <a:rPr sz="1300" b="0">
+                <a:latin typeface="Times New Roman"/>
+              </a:rPr>
+              <a:t>Başal, M. ve Batu, S. (2002). Zihin Özürlü Öğrencilere Okuma Yazma Öğretme Konusunda Alt Özel Sınıf Öğretmenlerinin Görüş ve Önerileri. Özel Eğitim Dergisi, 3(2), 85-98</a:t>
+            </a:r>
+          </a:p>
+          <a:p>
+            <a:pPr marL="228600" indent="-228600">
+              <a:spcAft>
+                <a:spcPts val="500"/>
+              </a:spcAft>
+              <a:buNone/>
+            </a:pPr>
+            <a:r>
+              <a:rPr sz="1300" b="0">
+                <a:latin typeface="Times New Roman"/>
+              </a:rPr>
+              <a:t>Bıyıklı, L. (1997). Özel Eğitim Gereksinimi Duyan Çocuklar. Milli Eğitim Sanat-Kültür Dergisi. Sayı: 136, s. 31-32</a:t>
+            </a:r>
+          </a:p>
+          <a:p>
+            <a:pPr marL="228600" indent="-228600">
+              <a:spcAft>
+                <a:spcPts val="500"/>
+              </a:spcAft>
+              <a:buNone/>
+            </a:pPr>
+            <a:r>
+              <a:rPr sz="1300" b="0">
+                <a:latin typeface="Times New Roman"/>
+              </a:rPr>
+              <a:t>Brent, R.&amp;Anderson, P. (1993). Devoloping Children`s Classroom Listening Strategies. Reading Teacher, 47, (2), pp. 122-126</a:t>
+            </a:r>
+          </a:p>
+          <a:p>
+            <a:pPr marL="228600" indent="-228600">
+              <a:spcAft>
+                <a:spcPts val="500"/>
+              </a:spcAft>
+              <a:buNone/>
+            </a:pPr>
+            <a:r>
+              <a:rPr sz="1300" b="0">
+                <a:latin typeface="Times New Roman"/>
+              </a:rPr>
+              <a:t>Chenfeld, M. B. (1978). Teaching Language Arts Creatively. Harcourt Brace Jovanovich Publishers. San Diego.</a:t>
+            </a:r>
+          </a:p>
+          <a:p>
+            <a:pPr marL="228600" indent="-228600">
+              <a:spcAft>
+                <a:spcPts val="500"/>
+              </a:spcAft>
+              <a:buNone/>
+            </a:pPr>
+            <a:r>
+              <a:rPr sz="1300" b="0">
+                <a:latin typeface="Times New Roman"/>
+              </a:rPr>
+              <a:t>Creswell, J. W. (2007). Qualitative Inquiry and Research Design: Choosing Among Five Traditions (Second Edition). London: Sage Publication</a:t>
+            </a:r>
+          </a:p>
+          <a:p>
+            <a:pPr marL="228600" indent="-228600">
+              <a:spcAft>
+                <a:spcPts val="500"/>
+              </a:spcAft>
+              <a:buNone/>
+            </a:pPr>
+            <a:r>
+              <a:rPr sz="1300" b="0">
+                <a:latin typeface="Times New Roman"/>
+              </a:rPr>
+              <a:t>Doğan, Y.(2012). Dinleme Eğitimi. Pegem Akademi. Ankara</a:t>
+            </a:r>
+          </a:p>
+          <a:p>
+            <a:pPr marL="228600" indent="-228600">
+              <a:spcAft>
+                <a:spcPts val="500"/>
+              </a:spcAft>
+              <a:buNone/>
+            </a:pPr>
+            <a:r>
+              <a:rPr sz="1300" b="0">
+                <a:latin typeface="Times New Roman"/>
+              </a:rPr>
+              <a:t>Ergin, A. ve BİROL, C. (2000). Eğitimde İletişim. Ankara: Anı Yayıncılık</a:t>
+            </a:r>
+          </a:p>
+        </p:txBody>
+      </p:sp>
+      <p:sp>
+        <p:nvSpPr>
+          <p:cNvPr id="6" name="Slide Number Placeholder 5"/>
+          <p:cNvSpPr>
+            <a:spLocks noGrp="1"/>
+          </p:cNvSpPr>
+          <p:nvPr>
+            <p:ph type="sldNum" sz="quarter" idx="12"/>
+          </p:nvPr>
+        </p:nvSpPr>
+        <p:spPr/>
+        <p:txBody>
+          <a:bodyPr/>
+          <a:lstStyle/>
+          <a:p>
+            <a:fld id="{F302176B-0E47-46AC-8F43-DAB4B8A37D06}" type="slidenum">
+              <a:rPr lang="tr-TR" smtClean="0"/>
+              <a:t>‹#›</a:t>
+            </a:fld>
+            <a:endParaRPr lang="tr-TR"/>
+          </a:p>
+        </p:txBody>
+      </p:sp>
+    </p:spTree>
+  </p:cSld>
+  <p:clrMapOvr>
+    <a:masterClrMapping/>
+  </p:clrMapOvr>
+</p:sld>
+</file>
+
+<file path=ppt/slides/slide22.xml><?xml version="1.0" encoding="utf-8"?>
+<p:sld xmlns:a="http://schemas.openxmlformats.org/drawingml/2006/main" xmlns:p="http://schemas.openxmlformats.org/presentationml/2006/main" xmlns:r="http://schemas.openxmlformats.org/officeDocument/2006/relationships">
+  <p:cSld>
+    <p:spTree>
+      <p:nvGrpSpPr>
+        <p:cNvPr id="1" name=""/>
+        <p:cNvGrpSpPr/>
+        <p:nvPr/>
+      </p:nvGrpSpPr>
+      <p:grpSpPr/>
+      <p:sp>
+        <p:nvSpPr>
+          <p:cNvPr id="2" name="Title 1"/>
+          <p:cNvSpPr>
+            <a:spLocks noGrp="1"/>
+          </p:cNvSpPr>
+          <p:nvPr>
+            <p:ph type="title"/>
+          </p:nvPr>
+        </p:nvSpPr>
+        <p:spPr/>
+        <p:txBody>
+          <a:bodyPr/>
+          <a:lstStyle/>
+          <a:p>
+            <a:r>
+              <a:rPr b="1">
+                <a:latin typeface="Times New Roman"/>
+              </a:rPr>
+              <a:t>Kaynakça (2/4)</a:t>
+            </a:r>
+          </a:p>
+        </p:txBody>
+      </p:sp>
+      <p:sp>
+        <p:nvSpPr>
+          <p:cNvPr id="3" name="Content Placeholder 2"/>
+          <p:cNvSpPr>
+            <a:spLocks noGrp="1"/>
+          </p:cNvSpPr>
+          <p:nvPr>
+            <p:ph idx="1"/>
+          </p:nvPr>
+        </p:nvSpPr>
+        <p:spPr/>
+        <p:txBody>
+          <a:bodyPr wrap="square">
+            <a:noAutofit/>
+          </a:bodyPr>
+          <a:lstStyle/>
+          <a:p>
+            <a:pPr marL="228600" indent="-228600">
+              <a:spcAft>
+                <a:spcPts val="500"/>
+              </a:spcAft>
+              <a:buNone/>
+            </a:pPr>
+            <a:r>
+              <a:rPr sz="1300" b="0">
+                <a:latin typeface="Times New Roman"/>
+              </a:rPr>
+              <a:t>Ergin, A. (2010). Eğitimde Etkili İletişim. Ankara: Anı Yayıncılık</a:t>
+            </a:r>
+          </a:p>
+          <a:p>
+            <a:pPr marL="228600" indent="-228600">
+              <a:spcAft>
+                <a:spcPts val="500"/>
+              </a:spcAft>
+              <a:buNone/>
+            </a:pPr>
+            <a:r>
+              <a:rPr sz="1300" b="0">
+                <a:latin typeface="Times New Roman"/>
+              </a:rPr>
+              <a:t>Eripek, S. (1998). Özel Eğitim. T.C. Anadolu Üniversitesi Yayınları</a:t>
+            </a:r>
+          </a:p>
+          <a:p>
+            <a:pPr marL="228600" indent="-228600">
+              <a:spcAft>
+                <a:spcPts val="500"/>
+              </a:spcAft>
+              <a:buNone/>
+            </a:pPr>
+            <a:r>
+              <a:rPr sz="1300" b="0">
+                <a:latin typeface="Times New Roman"/>
+              </a:rPr>
+              <a:t>Eripek, S. (2005). Zekâ Geriliği. Ankara: Kök Yayıncılık.</a:t>
+            </a:r>
+          </a:p>
+          <a:p>
+            <a:pPr marL="228600" indent="-228600">
+              <a:spcAft>
+                <a:spcPts val="500"/>
+              </a:spcAft>
+              <a:buNone/>
+            </a:pPr>
+            <a:r>
+              <a:rPr sz="1300" b="0">
+                <a:latin typeface="Times New Roman"/>
+              </a:rPr>
+              <a:t>Funk, H. D.&amp;Funk, G. D. (1989). Guidelines for Developing Listening Skills. The Reading Teacher, pp.660-663</a:t>
+            </a:r>
+          </a:p>
+          <a:p>
+            <a:pPr marL="228600" indent="-228600">
+              <a:spcAft>
+                <a:spcPts val="500"/>
+              </a:spcAft>
+              <a:buNone/>
+            </a:pPr>
+            <a:r>
+              <a:rPr sz="1300" b="0">
+                <a:latin typeface="Times New Roman"/>
+              </a:rPr>
+              <a:t>Gangi, J. M. (2004). Encountering Children's Literature. Pearson Education. Boston</a:t>
+            </a:r>
+          </a:p>
+          <a:p>
+            <a:pPr marL="228600" indent="-228600">
+              <a:spcAft>
+                <a:spcPts val="500"/>
+              </a:spcAft>
+              <a:buNone/>
+            </a:pPr>
+            <a:r>
+              <a:rPr sz="1300" b="0">
+                <a:latin typeface="Times New Roman"/>
+              </a:rPr>
+              <a:t>Graesser, A., Golding, J. M., &amp; Long, D. L. (1991). Narrative Representation and Comprehension. in R. Bar, M. L. Kamil, P. Mosenthal &amp; P. D. Pearson (Ed.), Handbook of Reading Research (Vol. II, pp. 171-205). White Plains, NY: Longman</a:t>
+            </a:r>
+          </a:p>
+          <a:p>
+            <a:pPr marL="228600" indent="-228600">
+              <a:spcAft>
+                <a:spcPts val="500"/>
+              </a:spcAft>
+              <a:buNone/>
+            </a:pPr>
+            <a:r>
+              <a:rPr sz="1300" b="0">
+                <a:latin typeface="Times New Roman"/>
+              </a:rPr>
+              <a:t>Hampleman, R. (1958). Comparoson of Listening and Reading Comprehension Ability of 4th and 6th Grade Pupils. Elementary English. XXXI, 49</a:t>
+            </a:r>
+          </a:p>
+          <a:p>
+            <a:pPr marL="228600" indent="-228600">
+              <a:spcAft>
+                <a:spcPts val="500"/>
+              </a:spcAft>
+              <a:buNone/>
+            </a:pPr>
+            <a:r>
+              <a:rPr sz="1300" b="0">
+                <a:latin typeface="Times New Roman"/>
+              </a:rPr>
+              <a:t>İftar, G. K., Birkan, B. ve Uysal, A. (1997). Zihin Özürlü Çocuklara Kavram Öğretimi. Eskişehir: Mesleki Eğitim Yayınları</a:t>
+            </a:r>
+          </a:p>
+          <a:p>
+            <a:pPr marL="228600" indent="-228600">
+              <a:spcAft>
+                <a:spcPts val="500"/>
+              </a:spcAft>
+              <a:buNone/>
+            </a:pPr>
+            <a:r>
+              <a:rPr sz="1300" b="0">
+                <a:latin typeface="Times New Roman"/>
+              </a:rPr>
+              <a:t>Jalongo, M. R. (1995). Promoting Active Listening in the Cossroom. Childhood Education, 72, 1, pp.13-18</a:t>
+            </a:r>
+          </a:p>
+          <a:p>
+            <a:pPr marL="228600" indent="-228600">
+              <a:spcAft>
+                <a:spcPts val="500"/>
+              </a:spcAft>
+              <a:buNone/>
+            </a:pPr>
+            <a:r>
+              <a:rPr sz="1300" b="0">
+                <a:latin typeface="Times New Roman"/>
+              </a:rPr>
+              <a:t>Johnson, K. O. (1951). The Effect of Classroom Training upon Listening Comprehension. The Journal of Communication. I, 58</a:t>
+            </a:r>
+          </a:p>
+          <a:p>
+            <a:pPr marL="228600" indent="-228600">
+              <a:spcAft>
+                <a:spcPts val="500"/>
+              </a:spcAft>
+              <a:buNone/>
+            </a:pPr>
+            <a:r>
+              <a:rPr sz="1300" b="0">
+                <a:latin typeface="Times New Roman"/>
+              </a:rPr>
+              <a:t>Klin, A. (2006). "Asperger's syndrome". Adolesc Med Clin 17 (3): 771–88.</a:t>
+            </a:r>
+          </a:p>
+        </p:txBody>
+      </p:sp>
+      <p:sp>
+        <p:nvSpPr>
+          <p:cNvPr id="6" name="Slide Number Placeholder 5"/>
+          <p:cNvSpPr>
+            <a:spLocks noGrp="1"/>
+          </p:cNvSpPr>
+          <p:nvPr>
+            <p:ph type="sldNum" sz="quarter" idx="12"/>
+          </p:nvPr>
+        </p:nvSpPr>
+        <p:spPr/>
+        <p:txBody>
+          <a:bodyPr/>
+          <a:lstStyle/>
+          <a:p>
+            <a:fld id="{F302176B-0E47-46AC-8F43-DAB4B8A37D06}" type="slidenum">
+              <a:rPr lang="tr-TR" smtClean="0"/>
+              <a:t>‹#›</a:t>
+            </a:fld>
+            <a:endParaRPr lang="tr-TR"/>
+          </a:p>
+        </p:txBody>
+      </p:sp>
+    </p:spTree>
+  </p:cSld>
+  <p:clrMapOvr>
+    <a:masterClrMapping/>
+  </p:clrMapOvr>
+</p:sld>
+</file>
+
+<file path=ppt/slides/slide23.xml><?xml version="1.0" encoding="utf-8"?>
+<p:sld xmlns:a="http://schemas.openxmlformats.org/drawingml/2006/main" xmlns:p="http://schemas.openxmlformats.org/presentationml/2006/main" xmlns:r="http://schemas.openxmlformats.org/officeDocument/2006/relationships">
+  <p:cSld>
+    <p:spTree>
+      <p:nvGrpSpPr>
+        <p:cNvPr id="1" name=""/>
+        <p:cNvGrpSpPr/>
+        <p:nvPr/>
+      </p:nvGrpSpPr>
+      <p:grpSpPr/>
+      <p:sp>
+        <p:nvSpPr>
+          <p:cNvPr id="2" name="Title 1"/>
+          <p:cNvSpPr>
+            <a:spLocks noGrp="1"/>
+          </p:cNvSpPr>
+          <p:nvPr>
+            <p:ph type="title"/>
+          </p:nvPr>
+        </p:nvSpPr>
+        <p:spPr/>
+        <p:txBody>
+          <a:bodyPr/>
+          <a:lstStyle/>
+          <a:p>
+            <a:r>
+              <a:rPr b="1">
+                <a:latin typeface="Times New Roman"/>
+              </a:rPr>
+              <a:t>Kaynakça (3/4)</a:t>
+            </a:r>
+          </a:p>
+        </p:txBody>
+      </p:sp>
+      <p:sp>
+        <p:nvSpPr>
+          <p:cNvPr id="3" name="Content Placeholder 2"/>
+          <p:cNvSpPr>
+            <a:spLocks noGrp="1"/>
+          </p:cNvSpPr>
+          <p:nvPr>
+            <p:ph idx="1"/>
+          </p:nvPr>
+        </p:nvSpPr>
+        <p:spPr/>
+        <p:txBody>
+          <a:bodyPr wrap="square">
+            <a:noAutofit/>
+          </a:bodyPr>
+          <a:lstStyle/>
+          <a:p>
+            <a:pPr marL="228600" indent="-228600">
+              <a:spcAft>
+                <a:spcPts val="500"/>
+              </a:spcAft>
+              <a:buNone/>
+            </a:pPr>
+            <a:r>
+              <a:rPr sz="1300" b="0">
+                <a:latin typeface="Times New Roman"/>
+              </a:rPr>
+              <a:t>Kilgo, J.&amp;Gorgiarla, R. (2005). Young Children with Special Needs. (Second Edition). USA: Thomson-Delmar Learning</a:t>
+            </a:r>
+          </a:p>
+          <a:p>
+            <a:pPr marL="228600" indent="-228600">
+              <a:spcAft>
+                <a:spcPts val="500"/>
+              </a:spcAft>
+              <a:buNone/>
+            </a:pPr>
+            <a:r>
+              <a:rPr sz="1300" b="0">
+                <a:latin typeface="Times New Roman"/>
+              </a:rPr>
+              <a:t>Kırcaali-İftar, G. (1998). Özel Eğitim. Eskişehir: T.C. Anadolu Üniversitesi Yayınları</a:t>
+            </a:r>
+          </a:p>
+          <a:p>
+            <a:pPr marL="228600" indent="-228600">
+              <a:spcAft>
+                <a:spcPts val="500"/>
+              </a:spcAft>
+              <a:buNone/>
+            </a:pPr>
+            <a:r>
+              <a:rPr sz="1300" b="0">
+                <a:latin typeface="Times New Roman"/>
+              </a:rPr>
+              <a:t>Kingen, S. (2000). Teaching Language Arts in Middle Schools. Mahwah, New Jersey: Lawrence Erlbaum Associates</a:t>
+            </a:r>
+          </a:p>
+          <a:p>
+            <a:pPr marL="228600" indent="-228600">
+              <a:spcAft>
+                <a:spcPts val="500"/>
+              </a:spcAft>
+              <a:buNone/>
+            </a:pPr>
+            <a:r>
+              <a:rPr sz="1300" b="0">
+                <a:latin typeface="Times New Roman"/>
+              </a:rPr>
+              <a:t>Kuz, T. (2001). Kaynaştırma Eğitimine Yönelik Tutumların İncelenmesi. Ankara: Başbakanlık Özürlüler idaresi Başkanlığı Yayınları</a:t>
+            </a:r>
+          </a:p>
+          <a:p>
+            <a:pPr marL="228600" indent="-228600">
+              <a:spcAft>
+                <a:spcPts val="500"/>
+              </a:spcAft>
+              <a:buNone/>
+            </a:pPr>
+            <a:r>
+              <a:rPr sz="1300" b="0">
+                <a:latin typeface="Times New Roman"/>
+              </a:rPr>
+              <a:t>Kuzu, T. S. (2004). Etkileşimsel Modele Uygun Okuma Öğretiminin Türkçe Bilgilendirici Metinleri Anlama Düzeyine Etkisi. Ankara Üniversitesi, Eğitim Bilimleri Fakültesi Dergisi, 3(1), 55-77</a:t>
+            </a:r>
+          </a:p>
+          <a:p>
+            <a:pPr marL="228600" indent="-228600">
+              <a:spcAft>
+                <a:spcPts val="500"/>
+              </a:spcAft>
+              <a:buNone/>
+            </a:pPr>
+            <a:r>
+              <a:rPr sz="1300" b="0">
+                <a:latin typeface="Times New Roman"/>
+              </a:rPr>
+              <a:t>Levis, R. B.&amp;Doorlag H. D. (1999). Teaching Special Students in General Education Classrooms. New Jersey, Prentice Hall</a:t>
+            </a:r>
+          </a:p>
+          <a:p>
+            <a:pPr marL="228600" indent="-228600">
+              <a:spcAft>
+                <a:spcPts val="500"/>
+              </a:spcAft>
+              <a:buNone/>
+            </a:pPr>
+            <a:r>
+              <a:rPr sz="1300" b="0">
+                <a:latin typeface="Times New Roman"/>
+              </a:rPr>
+              <a:t>Mağden, D. ve Avcı, N. (1997). Öğretmen Adaylarının Özürlü Öğrencilerin Kaynaştırılmasına İlişkin Görüşleri. 4. Ulusal Eğitim Bilimleri Kongresi. Eskişehir: Anadolu Üniversitesi Eğitim Fakültesi. 10-12 Eylül</a:t>
+            </a:r>
+          </a:p>
+          <a:p>
+            <a:pPr marL="228600" indent="-228600">
+              <a:spcAft>
+                <a:spcPts val="500"/>
+              </a:spcAft>
+              <a:buNone/>
+            </a:pPr>
+            <a:r>
+              <a:rPr sz="1300" b="0">
+                <a:latin typeface="Times New Roman"/>
+              </a:rPr>
+              <a:t>MEB. (2005). İlköğretim 1-5. Sınıf Programları Tanıtım El Kitabı. Ankara: Devlet Kitapları Müdürlüğü Basımevi</a:t>
+            </a:r>
+          </a:p>
+          <a:p>
+            <a:pPr marL="228600" indent="-228600">
+              <a:spcAft>
+                <a:spcPts val="500"/>
+              </a:spcAft>
+              <a:buNone/>
+            </a:pPr>
+            <a:r>
+              <a:rPr sz="1300" b="0">
+                <a:latin typeface="Times New Roman"/>
+              </a:rPr>
+              <a:t>MEB. (2006). Özel eğitim Hizmetleri Yönetmeliği, 31.05.2006 tarih ve 26184 Sayılı Resmî Gazete</a:t>
+            </a:r>
+          </a:p>
+          <a:p>
+            <a:pPr marL="228600" indent="-228600">
+              <a:spcAft>
+                <a:spcPts val="500"/>
+              </a:spcAft>
+              <a:buNone/>
+            </a:pPr>
+            <a:r>
+              <a:rPr sz="1300" b="0">
+                <a:latin typeface="Times New Roman"/>
+              </a:rPr>
+              <a:t>MEB. (2009). MEGEP. Çocuk Gelişimi ve Eğitimi. Zihinsel Engelliler. Ders Notları. Ankara: Devlet Kitapları Müdürlüğü Basımevi</a:t>
+            </a:r>
+          </a:p>
+          <a:p>
+            <a:pPr marL="228600" indent="-228600">
+              <a:spcAft>
+                <a:spcPts val="500"/>
+              </a:spcAft>
+              <a:buNone/>
+            </a:pPr>
+            <a:r>
+              <a:rPr sz="1300" b="0">
+                <a:latin typeface="Times New Roman"/>
+              </a:rPr>
+              <a:t>Merriam, S. B. (1998). Qualitative Researchand Case Study Applications in Education (Second Edition). San Francisco: Jossey-Bass Publishers</a:t>
+            </a:r>
+          </a:p>
+        </p:txBody>
+      </p:sp>
+      <p:sp>
+        <p:nvSpPr>
+          <p:cNvPr id="6" name="Slide Number Placeholder 5"/>
+          <p:cNvSpPr>
+            <a:spLocks noGrp="1"/>
+          </p:cNvSpPr>
+          <p:nvPr>
+            <p:ph type="sldNum" sz="quarter" idx="12"/>
+          </p:nvPr>
+        </p:nvSpPr>
+        <p:spPr/>
+        <p:txBody>
+          <a:bodyPr/>
+          <a:lstStyle/>
+          <a:p>
+            <a:fld id="{F302176B-0E47-46AC-8F43-DAB4B8A37D06}" type="slidenum">
+              <a:rPr lang="tr-TR" smtClean="0"/>
+              <a:t>‹#›</a:t>
+            </a:fld>
+            <a:endParaRPr lang="tr-TR"/>
+          </a:p>
+        </p:txBody>
+      </p:sp>
+    </p:spTree>
+  </p:cSld>
+  <p:clrMapOvr>
+    <a:masterClrMapping/>
+  </p:clrMapOvr>
+</p:sld>
+</file>
+
+<file path=ppt/slides/slide24.xml><?xml version="1.0" encoding="utf-8"?>
+<p:sld xmlns:a="http://schemas.openxmlformats.org/drawingml/2006/main" xmlns:p="http://schemas.openxmlformats.org/presentationml/2006/main" xmlns:r="http://schemas.openxmlformats.org/officeDocument/2006/relationships">
+  <p:cSld>
+    <p:spTree>
+      <p:nvGrpSpPr>
+        <p:cNvPr id="1" name=""/>
+        <p:cNvGrpSpPr/>
+        <p:nvPr/>
+      </p:nvGrpSpPr>
+      <p:grpSpPr/>
+      <p:sp>
+        <p:nvSpPr>
+          <p:cNvPr id="2" name="Title 1"/>
+          <p:cNvSpPr>
+            <a:spLocks noGrp="1"/>
+          </p:cNvSpPr>
+          <p:nvPr>
+            <p:ph type="title"/>
+          </p:nvPr>
+        </p:nvSpPr>
+        <p:spPr/>
+        <p:txBody>
+          <a:bodyPr/>
+          <a:lstStyle/>
+          <a:p>
+            <a:r>
+              <a:rPr b="1">
+                <a:latin typeface="Times New Roman"/>
+              </a:rPr>
+              <a:t>Kaynakça (4/4)</a:t>
+            </a:r>
+          </a:p>
+        </p:txBody>
+      </p:sp>
+      <p:sp>
+        <p:nvSpPr>
+          <p:cNvPr id="3" name="Content Placeholder 2"/>
+          <p:cNvSpPr>
+            <a:spLocks noGrp="1"/>
+          </p:cNvSpPr>
+          <p:nvPr>
+            <p:ph idx="1"/>
+          </p:nvPr>
+        </p:nvSpPr>
+        <p:spPr/>
+        <p:txBody>
+          <a:bodyPr wrap="square">
+            <a:noAutofit/>
+          </a:bodyPr>
+          <a:lstStyle/>
+          <a:p>
+            <a:pPr marL="228600" indent="-228600">
+              <a:spcAft>
+                <a:spcPts val="500"/>
+              </a:spcAft>
+              <a:buNone/>
+            </a:pPr>
+            <a:r>
+              <a:rPr sz="1300" b="0">
+                <a:latin typeface="Times New Roman"/>
+              </a:rPr>
+              <a:t>Ömür, M. (2006). Kulağımızın Göz Kapağı Yoktur, Cumhuriyet Bilim, S.990, s. 16-17</a:t>
+            </a:r>
+          </a:p>
+          <a:p>
+            <a:pPr marL="228600" indent="-228600">
+              <a:spcAft>
+                <a:spcPts val="500"/>
+              </a:spcAft>
+              <a:buNone/>
+            </a:pPr>
+            <a:r>
+              <a:rPr sz="1300" b="0">
+                <a:latin typeface="Times New Roman"/>
+              </a:rPr>
+              <a:t>Özbay, M. (2005). Bir Dil Becerisi Olarak Dinleme Eğitimi. Ankara: Akçağ Yayınları</a:t>
+            </a:r>
+          </a:p>
+          <a:p>
+            <a:pPr marL="228600" indent="-228600">
+              <a:spcAft>
+                <a:spcPts val="500"/>
+              </a:spcAft>
+              <a:buNone/>
+            </a:pPr>
+            <a:r>
+              <a:rPr sz="1300" b="0">
+                <a:latin typeface="Times New Roman"/>
+              </a:rPr>
+              <a:t>Özel Eğitim Hakkında Kanun Hükmünde Kararname ve Özel Eğitim Hizmetleri Yönetmeliği (2000). Ankara: Milli Eğitim Basımevi</a:t>
+            </a:r>
+          </a:p>
+          <a:p>
+            <a:pPr marL="228600" indent="-228600">
+              <a:spcAft>
+                <a:spcPts val="500"/>
+              </a:spcAft>
+              <a:buNone/>
+            </a:pPr>
+            <a:r>
+              <a:rPr sz="1300" b="0">
+                <a:latin typeface="Times New Roman"/>
+              </a:rPr>
+              <a:t>Özdemir, E. (1998). Eleştirel Okuma. Ankara: Ümit Yayıncılık</a:t>
+            </a:r>
+          </a:p>
+          <a:p>
+            <a:pPr marL="228600" indent="-228600">
+              <a:spcAft>
+                <a:spcPts val="500"/>
+              </a:spcAft>
+              <a:buNone/>
+            </a:pPr>
+            <a:r>
+              <a:rPr sz="1300" b="0">
+                <a:latin typeface="Times New Roman"/>
+              </a:rPr>
+              <a:t>Özgür, G. (2004). Engelli Çocuklar ve Eğitim-Özel Eğitim. Adana: Karhan Kitabevi</a:t>
+            </a:r>
+          </a:p>
+          <a:p>
+            <a:pPr marL="228600" indent="-228600">
+              <a:spcAft>
+                <a:spcPts val="500"/>
+              </a:spcAft>
+              <a:buNone/>
+            </a:pPr>
+            <a:r>
+              <a:rPr sz="1300" b="0">
+                <a:latin typeface="Times New Roman"/>
+              </a:rPr>
+              <a:t>Salend, S. J. (1998). Effective Mainstreaming: Creating inclusive classrooms. (3rd Edition). New Jersey: Merrill Prentice Hall</a:t>
+            </a:r>
+          </a:p>
+          <a:p>
+            <a:pPr marL="228600" indent="-228600">
+              <a:spcAft>
+                <a:spcPts val="500"/>
+              </a:spcAft>
+              <a:buNone/>
+            </a:pPr>
+            <a:r>
+              <a:rPr sz="1300" b="0">
+                <a:latin typeface="Times New Roman"/>
+              </a:rPr>
+              <a:t>Sucuoğlu, B. (2010). Zihin Engelliler ve Eğitimleri. Ankara: Kök Yayıncılık</a:t>
+            </a:r>
+          </a:p>
+          <a:p>
+            <a:pPr marL="228600" indent="-228600">
+              <a:spcAft>
+                <a:spcPts val="500"/>
+              </a:spcAft>
+              <a:buNone/>
+            </a:pPr>
+            <a:r>
+              <a:rPr sz="1300" b="0">
+                <a:latin typeface="Times New Roman"/>
+              </a:rPr>
+              <a:t>Şura Raporu. (1999). I. Özürlüler Şurası Çağdaş Toplum Çağdaş Yaşam ve Özürlüler. 29 Kasım-02 Aralık. Ankara: T.C. Başbakanlık Özürlüler İdaresi Başkanlığı Yayınları</a:t>
+            </a:r>
+          </a:p>
+          <a:p>
+            <a:pPr marL="228600" indent="-228600">
+              <a:spcAft>
+                <a:spcPts val="500"/>
+              </a:spcAft>
+              <a:buNone/>
+            </a:pPr>
+            <a:r>
+              <a:rPr sz="1300" b="0">
+                <a:latin typeface="Times New Roman"/>
+              </a:rPr>
+              <a:t>Tüfekçioğlu, Ü. (1997). İşitme Engelli Çocukların Okul Öncesi Dönemde Kaynaştırma Ortamında Eğitimleri. Milli Eğitim Kültür-Sanat Dergisi, Sayı: 136, S:58</a:t>
+            </a:r>
+          </a:p>
+          <a:p>
+            <a:pPr marL="228600" indent="-228600">
+              <a:spcAft>
+                <a:spcPts val="500"/>
+              </a:spcAft>
+              <a:buNone/>
+            </a:pPr>
+            <a:r>
+              <a:rPr sz="1300" b="0">
+                <a:latin typeface="Times New Roman"/>
+              </a:rPr>
+              <a:t>Quandt, J. I. (1983). Language Arts for Children. London: Prentice Hall Inc</a:t>
+            </a:r>
+          </a:p>
+          <a:p>
+            <a:pPr marL="228600" indent="-228600">
+              <a:spcAft>
+                <a:spcPts val="500"/>
+              </a:spcAft>
+              <a:buNone/>
+            </a:pPr>
+            <a:r>
+              <a:rPr sz="1300" b="0">
+                <a:latin typeface="Times New Roman"/>
+              </a:rPr>
+              <a:t>Weaver, C.&amp;Kintsch, W. (1991). Expository Texts. Handbook of Reading Research. Rebecca Barr, Michael Kamil ve diğer (Ed.) New York: Longman</a:t>
+            </a:r>
+          </a:p>
+          <a:p>
+            <a:pPr marL="228600" indent="-228600">
+              <a:spcAft>
+                <a:spcPts val="500"/>
+              </a:spcAft>
+              <a:buNone/>
+            </a:pPr>
+            <a:r>
+              <a:rPr sz="1300" b="0">
+                <a:latin typeface="Times New Roman"/>
+              </a:rPr>
+              <a:t>Westling, D. L.&amp;Fox, L. (2000). Teaching Students With Several Disabilities. (2nd Edition). USA: Printice Hall</a:t>
+            </a:r>
+          </a:p>
+        </p:txBody>
+      </p:sp>
+      <p:sp>
+        <p:nvSpPr>
+          <p:cNvPr id="6" name="Slide Number Placeholder 5"/>
+          <p:cNvSpPr>
+            <a:spLocks noGrp="1"/>
+          </p:cNvSpPr>
+          <p:nvPr>
+            <p:ph type="sldNum" sz="quarter" idx="12"/>
+          </p:nvPr>
+        </p:nvSpPr>
+        <p:spPr/>
+        <p:txBody>
+          <a:bodyPr/>
+          <a:lstStyle/>
+          <a:p>
+            <a:fld id="{F302176B-0E47-46AC-8F43-DAB4B8A37D06}" type="slidenum">
+              <a:rPr lang="tr-TR" smtClean="0"/>
+              <a:t>‹#›</a:t>
+            </a:fld>
+            <a:endParaRPr lang="tr-TR"/>
+          </a:p>
+        </p:txBody>
+      </p:sp>
+    </p:spTree>
+  </p:cSld>
+  <p:clrMapOvr>
+    <a:masterClrMapping/>
+  </p:clrMapOvr>
+</p:sld>
+</file>
+
 <file path=ppt/slides/slide3.xml><?xml version="1.0" encoding="utf-8"?>
 <p:sld xmlns:a="http://schemas.openxmlformats.org/drawingml/2006/main" xmlns:p="http://schemas.openxmlformats.org/presentationml/2006/main" xmlns:r="http://schemas.openxmlformats.org/officeDocument/2006/relationships">
   <p:cSld>
@@ -5879,6 +6756,40 @@
               <a:t>‹#›</a:t>
             </a:fld>
             <a:endParaRPr lang="tr-TR"/>
+          </a:p>
+        </p:txBody>
+      </p:sp>
+      <p:sp>
+        <p:nvSpPr>
+          <p:cNvPr id="7" name="TextBox 6"/>
+          <p:cNvSpPr txBox="1"/>
+          <p:nvPr/>
+        </p:nvSpPr>
+        <p:spPr>
+          <a:xfrm>
+            <a:off x="457200" y="6380000"/>
+            <a:ext cx="6500000" cy="380000"/>
+          </a:xfrm>
+          <a:prstGeom prst="rect">
+            <a:avLst/>
+          </a:prstGeom>
+          <a:noFill/>
+        </p:spPr>
+        <p:txBody>
+          <a:bodyPr wrap="none">
+            <a:spAutoFit/>
+          </a:bodyPr>
+          <a:lstStyle/>
+          <a:p>
+            <a:r>
+              <a:rPr sz="1600" b="1">
+                <a:solidFill>
+                  <a:srgbClr val="E36C0A"/>
+                </a:solidFill>
+                <a:latin typeface="Times New Roman"/>
+              </a:rPr>
+              <a:t>Sunan: Çiğdem TURAN</a:t>
+            </a:r>
           </a:p>
         </p:txBody>
       </p:sp>
@@ -6014,6 +6925,40 @@
               <a:t>‹#›</a:t>
             </a:fld>
             <a:endParaRPr lang="tr-TR"/>
+          </a:p>
+        </p:txBody>
+      </p:sp>
+      <p:sp>
+        <p:nvSpPr>
+          <p:cNvPr id="7" name="TextBox 6"/>
+          <p:cNvSpPr txBox="1"/>
+          <p:nvPr/>
+        </p:nvSpPr>
+        <p:spPr>
+          <a:xfrm>
+            <a:off x="457200" y="6380000"/>
+            <a:ext cx="6500000" cy="380000"/>
+          </a:xfrm>
+          <a:prstGeom prst="rect">
+            <a:avLst/>
+          </a:prstGeom>
+          <a:noFill/>
+        </p:spPr>
+        <p:txBody>
+          <a:bodyPr wrap="none">
+            <a:spAutoFit/>
+          </a:bodyPr>
+          <a:lstStyle/>
+          <a:p>
+            <a:r>
+              <a:rPr sz="1600" b="1">
+                <a:solidFill>
+                  <a:srgbClr val="E36C0A"/>
+                </a:solidFill>
+                <a:latin typeface="Times New Roman"/>
+              </a:rPr>
+              <a:t>Sunan: Derya YILMAZ YILDIZ</a:t>
+            </a:r>
           </a:p>
         </p:txBody>
       </p:sp>

</xml_diff>

<commit_message>
Makale1: put all presenter names on slide 2
Co-Authored-By: Claude Sonnet 5.5 <noreply@anthropic.com>
Claude-Session: https://claude.ai/code/session_01TyFKmLJqyxNygHvjK9ydxU
</commit_message>
<xml_diff>
--- a/Makale1_Dinledigini_Anlama_Ozet.pptx
+++ b/Makale1_Dinledigini_Anlama_Ozet.pptx
@@ -5390,6 +5390,243 @@
 </p:sld>
 </file>
 
+<file path=ppt/slides/slide19.xml><?xml version="1.0" encoding="utf-8"?>
+<p:sld xmlns:a="http://schemas.openxmlformats.org/drawingml/2006/main" xmlns:p="http://schemas.openxmlformats.org/presentationml/2006/main" xmlns:r="http://schemas.openxmlformats.org/officeDocument/2006/relationships">
+  <p:cSld>
+    <p:spTree>
+      <p:nvGrpSpPr>
+        <p:cNvPr id="1" name=""/>
+        <p:cNvGrpSpPr/>
+        <p:nvPr/>
+      </p:nvGrpSpPr>
+      <p:grpSpPr/>
+      <p:sp>
+        <p:nvSpPr>
+          <p:cNvPr id="2" name="Title 1"/>
+          <p:cNvSpPr>
+            <a:spLocks noGrp="1"/>
+          </p:cNvSpPr>
+          <p:nvPr>
+            <p:ph type="title"/>
+          </p:nvPr>
+        </p:nvSpPr>
+        <p:spPr/>
+        <p:txBody>
+          <a:bodyPr/>
+          <a:lstStyle/>
+          <a:p>
+            <a:r>
+              <a:rPr b="1">
+                <a:latin typeface="Times New Roman"/>
+              </a:rPr>
+              <a:t>Kaynakça (1/4)</a:t>
+            </a:r>
+          </a:p>
+        </p:txBody>
+      </p:sp>
+      <p:sp>
+        <p:nvSpPr>
+          <p:cNvPr id="3" name="Content Placeholder 2"/>
+          <p:cNvSpPr>
+            <a:spLocks noGrp="1"/>
+          </p:cNvSpPr>
+          <p:nvPr>
+            <p:ph idx="1"/>
+          </p:nvPr>
+        </p:nvSpPr>
+        <p:spPr/>
+        <p:txBody>
+          <a:bodyPr wrap="square">
+            <a:noAutofit/>
+          </a:bodyPr>
+          <a:lstStyle/>
+          <a:p>
+            <a:pPr marL="228600" indent="-228600">
+              <a:spcAft>
+                <a:spcPts val="500"/>
+              </a:spcAft>
+              <a:buNone/>
+            </a:pPr>
+            <a:r>
+              <a:rPr sz="1300" b="0">
+                <a:latin typeface="Times New Roman"/>
+              </a:rPr>
+              <a:t>AAMR, (2002). Mental Retardation: Definition, Classification, and Systems of Supports (10. Baskı). Washington DC: AAMR</a:t>
+            </a:r>
+          </a:p>
+          <a:p>
+            <a:pPr marL="228600" indent="-228600">
+              <a:spcAft>
+                <a:spcPts val="500"/>
+              </a:spcAft>
+              <a:buNone/>
+            </a:pPr>
+            <a:r>
+              <a:rPr sz="1300" b="0">
+                <a:latin typeface="Times New Roman"/>
+              </a:rPr>
+              <a:t>Akyol, H. (1999). Hikâye Haritası Yöntemiyle Metin Öğretimi. Milli Eğitim, 142. (Online): Web: http://yayim.meb.gov.tr/dergiler/medergi/15.htm (Erişim Tarihi: 13.11.2013)</a:t>
+            </a:r>
+          </a:p>
+          <a:p>
+            <a:pPr marL="228600" indent="-228600">
+              <a:spcAft>
+                <a:spcPts val="500"/>
+              </a:spcAft>
+              <a:buNone/>
+            </a:pPr>
+            <a:r>
+              <a:rPr sz="1300" b="0">
+                <a:latin typeface="Times New Roman"/>
+              </a:rPr>
+              <a:t>American Psychiatric Association. (2000). "Diagnostic criteria for 299.80 Asperger's Disorder (AD)". Diagnostic and Statistical Manual of Mental Disorders (4th ed., text revision bas.). ISBN 0-89042-025-4. (Erişim Tarihi: 17.09.2013)</a:t>
+            </a:r>
+          </a:p>
+          <a:p>
+            <a:pPr marL="228600" indent="-228600">
+              <a:spcAft>
+                <a:spcPts val="500"/>
+              </a:spcAft>
+              <a:buNone/>
+            </a:pPr>
+            <a:r>
+              <a:rPr sz="1300" b="0">
+                <a:latin typeface="Times New Roman"/>
+              </a:rPr>
+              <a:t>Baskin, J. H., Sperber, M.&amp;Price B. H. (2006). "Asperger Syndrome Revisited". Rev Neurol Dis 3 (1): 1–7.</a:t>
+            </a:r>
+          </a:p>
+          <a:p>
+            <a:pPr marL="228600" indent="-228600">
+              <a:spcAft>
+                <a:spcPts val="500"/>
+              </a:spcAft>
+              <a:buNone/>
+            </a:pPr>
+            <a:r>
+              <a:rPr sz="1300" b="0">
+                <a:latin typeface="Times New Roman"/>
+              </a:rPr>
+              <a:t>Başal, M. ve Batu, S. (2002). Zihin Özürlü Öğrencilere Okuma Yazma Öğretme Konusunda Alt Özel Sınıf Öğretmenlerinin Görüş ve Önerileri. Özel Eğitim Dergisi, 3(2), 85-98</a:t>
+            </a:r>
+          </a:p>
+          <a:p>
+            <a:pPr marL="228600" indent="-228600">
+              <a:spcAft>
+                <a:spcPts val="500"/>
+              </a:spcAft>
+              <a:buNone/>
+            </a:pPr>
+            <a:r>
+              <a:rPr sz="1300" b="0">
+                <a:latin typeface="Times New Roman"/>
+              </a:rPr>
+              <a:t>Bıyıklı, L. (1997). Özel Eğitim Gereksinimi Duyan Çocuklar. Milli Eğitim Sanat-Kültür Dergisi. Sayı: 136, s. 31-32</a:t>
+            </a:r>
+          </a:p>
+          <a:p>
+            <a:pPr marL="228600" indent="-228600">
+              <a:spcAft>
+                <a:spcPts val="500"/>
+              </a:spcAft>
+              <a:buNone/>
+            </a:pPr>
+            <a:r>
+              <a:rPr sz="1300" b="0">
+                <a:latin typeface="Times New Roman"/>
+              </a:rPr>
+              <a:t>Brent, R.&amp;Anderson, P. (1993). Devoloping Children`s Classroom Listening Strategies. Reading Teacher, 47, (2), pp. 122-126</a:t>
+            </a:r>
+          </a:p>
+          <a:p>
+            <a:pPr marL="228600" indent="-228600">
+              <a:spcAft>
+                <a:spcPts val="500"/>
+              </a:spcAft>
+              <a:buNone/>
+            </a:pPr>
+            <a:r>
+              <a:rPr sz="1300" b="0">
+                <a:latin typeface="Times New Roman"/>
+              </a:rPr>
+              <a:t>Chenfeld, M. B. (1978). Teaching Language Arts Creatively. Harcourt Brace Jovanovich Publishers. San Diego.</a:t>
+            </a:r>
+          </a:p>
+          <a:p>
+            <a:pPr marL="228600" indent="-228600">
+              <a:spcAft>
+                <a:spcPts val="500"/>
+              </a:spcAft>
+              <a:buNone/>
+            </a:pPr>
+            <a:r>
+              <a:rPr sz="1300" b="0">
+                <a:latin typeface="Times New Roman"/>
+              </a:rPr>
+              <a:t>Creswell, J. W. (2007). Qualitative Inquiry and Research Design: Choosing Among Five Traditions (Second Edition). London: Sage Publication</a:t>
+            </a:r>
+          </a:p>
+          <a:p>
+            <a:pPr marL="228600" indent="-228600">
+              <a:spcAft>
+                <a:spcPts val="500"/>
+              </a:spcAft>
+              <a:buNone/>
+            </a:pPr>
+            <a:r>
+              <a:rPr sz="1300" b="0">
+                <a:latin typeface="Times New Roman"/>
+              </a:rPr>
+              <a:t>Doğan, Y.(2012). Dinleme Eğitimi. Pegem Akademi. Ankara</a:t>
+            </a:r>
+          </a:p>
+          <a:p>
+            <a:pPr marL="228600" indent="-228600">
+              <a:spcAft>
+                <a:spcPts val="500"/>
+              </a:spcAft>
+              <a:buNone/>
+            </a:pPr>
+            <a:r>
+              <a:rPr sz="1300" b="0">
+                <a:latin typeface="Times New Roman"/>
+              </a:rPr>
+              <a:t>Ergin, A. ve BİROL, C. (2000). Eğitimde İletişim. Ankara: Anı Yayıncılık</a:t>
+            </a:r>
+          </a:p>
+        </p:txBody>
+      </p:sp>
+      <p:sp>
+        <p:nvSpPr>
+          <p:cNvPr id="6" name="Slide Number Placeholder 5"/>
+          <p:cNvSpPr>
+            <a:spLocks noGrp="1"/>
+          </p:cNvSpPr>
+          <p:nvPr>
+            <p:ph type="sldNum" sz="quarter" idx="12"/>
+          </p:nvPr>
+        </p:nvSpPr>
+        <p:spPr/>
+        <p:txBody>
+          <a:bodyPr/>
+          <a:lstStyle/>
+          <a:p>
+            <a:fld id="{F302176B-0E47-46AC-8F43-DAB4B8A37D06}" type="slidenum">
+              <a:rPr lang="tr-TR" smtClean="0"/>
+              <a:t>‹#›</a:t>
+            </a:fld>
+            <a:endParaRPr lang="tr-TR"/>
+          </a:p>
+        </p:txBody>
+      </p:sp>
+    </p:spTree>
+  </p:cSld>
+  <p:clrMapOvr>
+    <a:masterClrMapping/>
+  </p:clrMapOvr>
+</p:sld>
+</file>
+
 <file path=ppt/slides/slide2.xml><?xml version="1.0" encoding="utf-8"?>
 <p:sld xmlns:a="http://schemas.openxmlformats.org/drawingml/2006/main" xmlns:p="http://schemas.openxmlformats.org/presentationml/2006/main" xmlns:r="http://schemas.openxmlformats.org/officeDocument/2006/relationships">
   <p:cSld>
@@ -5512,8 +5749,8 @@
         </p:nvSpPr>
         <p:spPr>
           <a:xfrm>
-            <a:off x="457200" y="6380000"/>
-            <a:ext cx="6500000" cy="380000"/>
+            <a:off x="457200" y="6350000"/>
+            <a:ext cx="7620000" cy="380000"/>
           </a:xfrm>
           <a:prstGeom prst="rect">
             <a:avLst/>
@@ -5521,19 +5758,19 @@
           <a:noFill/>
         </p:spPr>
         <p:txBody>
-          <a:bodyPr wrap="none">
+          <a:bodyPr wrap="square">
             <a:spAutoFit/>
           </a:bodyPr>
           <a:lstStyle/>
           <a:p>
             <a:r>
-              <a:rPr sz="1600" b="1">
+              <a:rPr sz="1500" b="1">
                 <a:solidFill>
                   <a:srgbClr val="E36C0A"/>
                 </a:solidFill>
                 <a:latin typeface="Times New Roman"/>
               </a:rPr>
-              <a:t>Sunan: Feyza BÜYÜKBEKTAŞ</a:t>
+              <a:t>Sunanlar: Feyza BÜYÜKBEKTAŞ  |  Çiğdem TURAN  |  Derya YILMAZ YILDIZ</a:t>
             </a:r>
           </a:p>
         </p:txBody>
@@ -5570,7 +5807,14 @@
         <p:txBody>
           <a:bodyPr/>
           <a:lstStyle/>
-          <a:p/>
+          <a:p>
+            <a:r>
+              <a:rPr b="1">
+                <a:latin typeface="Times New Roman"/>
+              </a:rPr>
+              <a:t>Kaynakça (2/4)</a:t>
+            </a:r>
+          </a:p>
         </p:txBody>
       </p:sp>
       <p:sp>
@@ -5585,56 +5829,162 @@
         </p:nvSpPr>
         <p:spPr/>
         <p:txBody>
-          <a:bodyPr/>
-          <a:lstStyle/>
-          <a:p>
-            <a:r>
-              <a:rPr sz="2400" b="0">
-                <a:latin typeface="Times New Roman"/>
-              </a:rPr>
-              <a:t>HAZIRLAYAN :</a:t>
-            </a:r>
-          </a:p>
-          <a:p/>
-          <a:p>
-            <a:r>
-              <a:rPr sz="2400" b="0">
-                <a:latin typeface="Times New Roman"/>
-              </a:rPr>
-              <a:t/>
-            </a:r>
-          </a:p>
-          <a:p>
-            <a:r>
-              <a:rPr sz="2400" b="0">
-                <a:latin typeface="Times New Roman"/>
-              </a:rPr>
-              <a:t/>
-            </a:r>
-          </a:p>
-          <a:p>
-            <a:r>
-              <a:rPr sz="2400" b="0">
-                <a:latin typeface="Times New Roman"/>
-              </a:rPr>
-              <a:t>ÖZET MAKALE (TÜRKÇE)</a:t>
-            </a:r>
-          </a:p>
-          <a:p/>
-          <a:p>
-            <a:r>
-              <a:rPr sz="2400" b="1">
-                <a:latin typeface="Times New Roman"/>
-              </a:rPr>
-              <a:t>Akademik Bakış Dergisi, Sayı 41, Mart–Nisan 2014</a:t>
-            </a:r>
-          </a:p>
-          <a:p>
-            <a:r>
-              <a:rPr sz="2400" b="1">
-                <a:latin typeface="Times New Roman"/>
-              </a:rPr>
-              <a:t>Celalabat / Kırgızistan</a:t>
+          <a:bodyPr wrap="square">
+            <a:noAutofit/>
+          </a:bodyPr>
+          <a:lstStyle/>
+          <a:p>
+            <a:pPr marL="228600" indent="-228600">
+              <a:spcAft>
+                <a:spcPts val="500"/>
+              </a:spcAft>
+              <a:buNone/>
+            </a:pPr>
+            <a:r>
+              <a:rPr sz="1300" b="0">
+                <a:latin typeface="Times New Roman"/>
+              </a:rPr>
+              <a:t>Ergin, A. (2010). Eğitimde Etkili İletişim. Ankara: Anı Yayıncılık</a:t>
+            </a:r>
+          </a:p>
+          <a:p>
+            <a:pPr marL="228600" indent="-228600">
+              <a:spcAft>
+                <a:spcPts val="500"/>
+              </a:spcAft>
+              <a:buNone/>
+            </a:pPr>
+            <a:r>
+              <a:rPr sz="1300" b="0">
+                <a:latin typeface="Times New Roman"/>
+              </a:rPr>
+              <a:t>Eripek, S. (1998). Özel Eğitim. T.C. Anadolu Üniversitesi Yayınları</a:t>
+            </a:r>
+          </a:p>
+          <a:p>
+            <a:pPr marL="228600" indent="-228600">
+              <a:spcAft>
+                <a:spcPts val="500"/>
+              </a:spcAft>
+              <a:buNone/>
+            </a:pPr>
+            <a:r>
+              <a:rPr sz="1300" b="0">
+                <a:latin typeface="Times New Roman"/>
+              </a:rPr>
+              <a:t>Eripek, S. (2005). Zekâ Geriliği. Ankara: Kök Yayıncılık.</a:t>
+            </a:r>
+          </a:p>
+          <a:p>
+            <a:pPr marL="228600" indent="-228600">
+              <a:spcAft>
+                <a:spcPts val="500"/>
+              </a:spcAft>
+              <a:buNone/>
+            </a:pPr>
+            <a:r>
+              <a:rPr sz="1300" b="0">
+                <a:latin typeface="Times New Roman"/>
+              </a:rPr>
+              <a:t>Funk, H. D.&amp;Funk, G. D. (1989). Guidelines for Developing Listening Skills. The Reading Teacher, pp.660-663</a:t>
+            </a:r>
+          </a:p>
+          <a:p>
+            <a:pPr marL="228600" indent="-228600">
+              <a:spcAft>
+                <a:spcPts val="500"/>
+              </a:spcAft>
+              <a:buNone/>
+            </a:pPr>
+            <a:r>
+              <a:rPr sz="1300" b="0">
+                <a:latin typeface="Times New Roman"/>
+              </a:rPr>
+              <a:t>Gangi, J. M. (2004). Encountering Children's Literature. Pearson Education. Boston</a:t>
+            </a:r>
+          </a:p>
+          <a:p>
+            <a:pPr marL="228600" indent="-228600">
+              <a:spcAft>
+                <a:spcPts val="500"/>
+              </a:spcAft>
+              <a:buNone/>
+            </a:pPr>
+            <a:r>
+              <a:rPr sz="1300" b="0">
+                <a:latin typeface="Times New Roman"/>
+              </a:rPr>
+              <a:t>Graesser, A., Golding, J. M., &amp; Long, D. L. (1991). Narrative Representation and Comprehension. in R. Bar, M. L. Kamil, P. Mosenthal &amp; P. D. Pearson (Ed.), Handbook of Reading Research (Vol. II, pp. 171-205). White Plains, NY: Longman</a:t>
+            </a:r>
+          </a:p>
+          <a:p>
+            <a:pPr marL="228600" indent="-228600">
+              <a:spcAft>
+                <a:spcPts val="500"/>
+              </a:spcAft>
+              <a:buNone/>
+            </a:pPr>
+            <a:r>
+              <a:rPr sz="1300" b="0">
+                <a:latin typeface="Times New Roman"/>
+              </a:rPr>
+              <a:t>Hampleman, R. (1958). Comparoson of Listening and Reading Comprehension Ability of 4th and 6th Grade Pupils. Elementary English. XXXI, 49</a:t>
+            </a:r>
+          </a:p>
+          <a:p>
+            <a:pPr marL="228600" indent="-228600">
+              <a:spcAft>
+                <a:spcPts val="500"/>
+              </a:spcAft>
+              <a:buNone/>
+            </a:pPr>
+            <a:r>
+              <a:rPr sz="1300" b="0">
+                <a:latin typeface="Times New Roman"/>
+              </a:rPr>
+              <a:t>İftar, G. K., Birkan, B. ve Uysal, A. (1997). Zihin Özürlü Çocuklara Kavram Öğretimi. Eskişehir: Mesleki Eğitim Yayınları</a:t>
+            </a:r>
+          </a:p>
+          <a:p>
+            <a:pPr marL="228600" indent="-228600">
+              <a:spcAft>
+                <a:spcPts val="500"/>
+              </a:spcAft>
+              <a:buNone/>
+            </a:pPr>
+            <a:r>
+              <a:rPr sz="1300" b="0">
+                <a:latin typeface="Times New Roman"/>
+              </a:rPr>
+              <a:t>Jalongo, M. R. (1995). Promoting Active Listening in the Cossroom. Childhood Education, 72, 1, pp.13-18</a:t>
+            </a:r>
+          </a:p>
+          <a:p>
+            <a:pPr marL="228600" indent="-228600">
+              <a:spcAft>
+                <a:spcPts val="500"/>
+              </a:spcAft>
+              <a:buNone/>
+            </a:pPr>
+            <a:r>
+              <a:rPr sz="1300" b="0">
+                <a:latin typeface="Times New Roman"/>
+              </a:rPr>
+              <a:t>Johnson, K. O. (1951). The Effect of Classroom Training upon Listening Comprehension. The Journal of Communication. I, 58</a:t>
+            </a:r>
+          </a:p>
+          <a:p>
+            <a:pPr marL="228600" indent="-228600">
+              <a:spcAft>
+                <a:spcPts val="500"/>
+              </a:spcAft>
+              <a:buNone/>
+            </a:pPr>
+            <a:r>
+              <a:rPr sz="1300" b="0">
+                <a:latin typeface="Times New Roman"/>
+              </a:rPr>
+              <a:t>Klin, A. (2006). "Asperger's syndrome". Adolesc Med Clin 17 (3): 771–88.</a:t>
             </a:r>
           </a:p>
         </p:txBody>
@@ -5699,7 +6049,7 @@
               <a:rPr b="1">
                 <a:latin typeface="Times New Roman"/>
               </a:rPr>
-              <a:t>Kaynakça (1/4)</a:t>
+              <a:t>Kaynakça (3/4)</a:t>
             </a:r>
           </a:p>
         </p:txBody>
@@ -5731,7 +6081,7 @@
               <a:rPr sz="1300" b="0">
                 <a:latin typeface="Times New Roman"/>
               </a:rPr>
-              <a:t>AAMR, (2002). Mental Retardation: Definition, Classification, and Systems of Supports (10. Baskı). Washington DC: AAMR</a:t>
+              <a:t>Kilgo, J.&amp;Gorgiarla, R. (2005). Young Children with Special Needs. (Second Edition). USA: Thomson-Delmar Learning</a:t>
             </a:r>
           </a:p>
           <a:p>
@@ -5745,7 +6095,7 @@
               <a:rPr sz="1300" b="0">
                 <a:latin typeface="Times New Roman"/>
               </a:rPr>
-              <a:t>Akyol, H. (1999). Hikâye Haritası Yöntemiyle Metin Öğretimi. Milli Eğitim, 142. (Online): Web: http://yayim.meb.gov.tr/dergiler/medergi/15.htm (Erişim Tarihi: 13.11.2013)</a:t>
+              <a:t>Kırcaali-İftar, G. (1998). Özel Eğitim. Eskişehir: T.C. Anadolu Üniversitesi Yayınları</a:t>
             </a:r>
           </a:p>
           <a:p>
@@ -5759,7 +6109,7 @@
               <a:rPr sz="1300" b="0">
                 <a:latin typeface="Times New Roman"/>
               </a:rPr>
-              <a:t>American Psychiatric Association. (2000). "Diagnostic criteria for 299.80 Asperger's Disorder (AD)". Diagnostic and Statistical Manual of Mental Disorders (4th ed., text revision bas.). ISBN 0-89042-025-4. (Erişim Tarihi: 17.09.2013)</a:t>
+              <a:t>Kingen, S. (2000). Teaching Language Arts in Middle Schools. Mahwah, New Jersey: Lawrence Erlbaum Associates</a:t>
             </a:r>
           </a:p>
           <a:p>
@@ -5773,7 +6123,7 @@
               <a:rPr sz="1300" b="0">
                 <a:latin typeface="Times New Roman"/>
               </a:rPr>
-              <a:t>Baskin, J. H., Sperber, M.&amp;Price B. H. (2006). "Asperger Syndrome Revisited". Rev Neurol Dis 3 (1): 1–7.</a:t>
+              <a:t>Kuz, T. (2001). Kaynaştırma Eğitimine Yönelik Tutumların İncelenmesi. Ankara: Başbakanlık Özürlüler idaresi Başkanlığı Yayınları</a:t>
             </a:r>
           </a:p>
           <a:p>
@@ -5787,7 +6137,7 @@
               <a:rPr sz="1300" b="0">
                 <a:latin typeface="Times New Roman"/>
               </a:rPr>
-              <a:t>Başal, M. ve Batu, S. (2002). Zihin Özürlü Öğrencilere Okuma Yazma Öğretme Konusunda Alt Özel Sınıf Öğretmenlerinin Görüş ve Önerileri. Özel Eğitim Dergisi, 3(2), 85-98</a:t>
+              <a:t>Kuzu, T. S. (2004). Etkileşimsel Modele Uygun Okuma Öğretiminin Türkçe Bilgilendirici Metinleri Anlama Düzeyine Etkisi. Ankara Üniversitesi, Eğitim Bilimleri Fakültesi Dergisi, 3(1), 55-77</a:t>
             </a:r>
           </a:p>
           <a:p>
@@ -5801,7 +6151,7 @@
               <a:rPr sz="1300" b="0">
                 <a:latin typeface="Times New Roman"/>
               </a:rPr>
-              <a:t>Bıyıklı, L. (1997). Özel Eğitim Gereksinimi Duyan Çocuklar. Milli Eğitim Sanat-Kültür Dergisi. Sayı: 136, s. 31-32</a:t>
+              <a:t>Levis, R. B.&amp;Doorlag H. D. (1999). Teaching Special Students in General Education Classrooms. New Jersey, Prentice Hall</a:t>
             </a:r>
           </a:p>
           <a:p>
@@ -5815,7 +6165,7 @@
               <a:rPr sz="1300" b="0">
                 <a:latin typeface="Times New Roman"/>
               </a:rPr>
-              <a:t>Brent, R.&amp;Anderson, P. (1993). Devoloping Children`s Classroom Listening Strategies. Reading Teacher, 47, (2), pp. 122-126</a:t>
+              <a:t>Mağden, D. ve Avcı, N. (1997). Öğretmen Adaylarının Özürlü Öğrencilerin Kaynaştırılmasına İlişkin Görüşleri. 4. Ulusal Eğitim Bilimleri Kongresi. Eskişehir: Anadolu Üniversitesi Eğitim Fakültesi. 10-12 Eylül</a:t>
             </a:r>
           </a:p>
           <a:p>
@@ -5829,7 +6179,7 @@
               <a:rPr sz="1300" b="0">
                 <a:latin typeface="Times New Roman"/>
               </a:rPr>
-              <a:t>Chenfeld, M. B. (1978). Teaching Language Arts Creatively. Harcourt Brace Jovanovich Publishers. San Diego.</a:t>
+              <a:t>MEB. (2005). İlköğretim 1-5. Sınıf Programları Tanıtım El Kitabı. Ankara: Devlet Kitapları Müdürlüğü Basımevi</a:t>
             </a:r>
           </a:p>
           <a:p>
@@ -5843,7 +6193,7 @@
               <a:rPr sz="1300" b="0">
                 <a:latin typeface="Times New Roman"/>
               </a:rPr>
-              <a:t>Creswell, J. W. (2007). Qualitative Inquiry and Research Design: Choosing Among Five Traditions (Second Edition). London: Sage Publication</a:t>
+              <a:t>MEB. (2006). Özel eğitim Hizmetleri Yönetmeliği, 31.05.2006 tarih ve 26184 Sayılı Resmî Gazete</a:t>
             </a:r>
           </a:p>
           <a:p>
@@ -5857,7 +6207,7 @@
               <a:rPr sz="1300" b="0">
                 <a:latin typeface="Times New Roman"/>
               </a:rPr>
-              <a:t>Doğan, Y.(2012). Dinleme Eğitimi. Pegem Akademi. Ankara</a:t>
+              <a:t>MEB. (2009). MEGEP. Çocuk Gelişimi ve Eğitimi. Zihinsel Engelliler. Ders Notları. Ankara: Devlet Kitapları Müdürlüğü Basımevi</a:t>
             </a:r>
           </a:p>
           <a:p>
@@ -5871,7 +6221,7 @@
               <a:rPr sz="1300" b="0">
                 <a:latin typeface="Times New Roman"/>
               </a:rPr>
-              <a:t>Ergin, A. ve BİROL, C. (2000). Eğitimde İletişim. Ankara: Anı Yayıncılık</a:t>
+              <a:t>Merriam, S. B. (1998). Qualitative Researchand Case Study Applications in Education (Second Edition). San Francisco: Jossey-Bass Publishers</a:t>
             </a:r>
           </a:p>
         </p:txBody>
@@ -5936,7 +6286,7 @@
               <a:rPr b="1">
                 <a:latin typeface="Times New Roman"/>
               </a:rPr>
-              <a:t>Kaynakça (2/4)</a:t>
+              <a:t>Kaynakça (4/4)</a:t>
             </a:r>
           </a:p>
         </p:txBody>
@@ -5968,7 +6318,7 @@
               <a:rPr sz="1300" b="0">
                 <a:latin typeface="Times New Roman"/>
               </a:rPr>
-              <a:t>Ergin, A. (2010). Eğitimde Etkili İletişim. Ankara: Anı Yayıncılık</a:t>
+              <a:t>Ömür, M. (2006). Kulağımızın Göz Kapağı Yoktur, Cumhuriyet Bilim, S.990, s. 16-17</a:t>
             </a:r>
           </a:p>
           <a:p>
@@ -5982,7 +6332,7 @@
               <a:rPr sz="1300" b="0">
                 <a:latin typeface="Times New Roman"/>
               </a:rPr>
-              <a:t>Eripek, S. (1998). Özel Eğitim. T.C. Anadolu Üniversitesi Yayınları</a:t>
+              <a:t>Özbay, M. (2005). Bir Dil Becerisi Olarak Dinleme Eğitimi. Ankara: Akçağ Yayınları</a:t>
             </a:r>
           </a:p>
           <a:p>
@@ -5996,7 +6346,7 @@
               <a:rPr sz="1300" b="0">
                 <a:latin typeface="Times New Roman"/>
               </a:rPr>
-              <a:t>Eripek, S. (2005). Zekâ Geriliği. Ankara: Kök Yayıncılık.</a:t>
+              <a:t>Özel Eğitim Hakkında Kanun Hükmünde Kararname ve Özel Eğitim Hizmetleri Yönetmeliği (2000). Ankara: Milli Eğitim Basımevi</a:t>
             </a:r>
           </a:p>
           <a:p>
@@ -6010,7 +6360,7 @@
               <a:rPr sz="1300" b="0">
                 <a:latin typeface="Times New Roman"/>
               </a:rPr>
-              <a:t>Funk, H. D.&amp;Funk, G. D. (1989). Guidelines for Developing Listening Skills. The Reading Teacher, pp.660-663</a:t>
+              <a:t>Özdemir, E. (1998). Eleştirel Okuma. Ankara: Ümit Yayıncılık</a:t>
             </a:r>
           </a:p>
           <a:p>
@@ -6024,7 +6374,7 @@
               <a:rPr sz="1300" b="0">
                 <a:latin typeface="Times New Roman"/>
               </a:rPr>
-              <a:t>Gangi, J. M. (2004). Encountering Children's Literature. Pearson Education. Boston</a:t>
+              <a:t>Özgür, G. (2004). Engelli Çocuklar ve Eğitim-Özel Eğitim. Adana: Karhan Kitabevi</a:t>
             </a:r>
           </a:p>
           <a:p>
@@ -6038,7 +6388,7 @@
               <a:rPr sz="1300" b="0">
                 <a:latin typeface="Times New Roman"/>
               </a:rPr>
-              <a:t>Graesser, A., Golding, J. M., &amp; Long, D. L. (1991). Narrative Representation and Comprehension. in R. Bar, M. L. Kamil, P. Mosenthal &amp; P. D. Pearson (Ed.), Handbook of Reading Research (Vol. II, pp. 171-205). White Plains, NY: Longman</a:t>
+              <a:t>Salend, S. J. (1998). Effective Mainstreaming: Creating inclusive classrooms. (3rd Edition). New Jersey: Merrill Prentice Hall</a:t>
             </a:r>
           </a:p>
           <a:p>
@@ -6052,7 +6402,7 @@
               <a:rPr sz="1300" b="0">
                 <a:latin typeface="Times New Roman"/>
               </a:rPr>
-              <a:t>Hampleman, R. (1958). Comparoson of Listening and Reading Comprehension Ability of 4th and 6th Grade Pupils. Elementary English. XXXI, 49</a:t>
+              <a:t>Sucuoğlu, B. (2010). Zihin Engelliler ve Eğitimleri. Ankara: Kök Yayıncılık</a:t>
             </a:r>
           </a:p>
           <a:p>
@@ -6066,7 +6416,7 @@
               <a:rPr sz="1300" b="0">
                 <a:latin typeface="Times New Roman"/>
               </a:rPr>
-              <a:t>İftar, G. K., Birkan, B. ve Uysal, A. (1997). Zihin Özürlü Çocuklara Kavram Öğretimi. Eskişehir: Mesleki Eğitim Yayınları</a:t>
+              <a:t>Şura Raporu. (1999). I. Özürlüler Şurası Çağdaş Toplum Çağdaş Yaşam ve Özürlüler. 29 Kasım-02 Aralık. Ankara: T.C. Başbakanlık Özürlüler İdaresi Başkanlığı Yayınları</a:t>
             </a:r>
           </a:p>
           <a:p>
@@ -6080,7 +6430,7 @@
               <a:rPr sz="1300" b="0">
                 <a:latin typeface="Times New Roman"/>
               </a:rPr>
-              <a:t>Jalongo, M. R. (1995). Promoting Active Listening in the Cossroom. Childhood Education, 72, 1, pp.13-18</a:t>
+              <a:t>Tüfekçioğlu, Ü. (1997). İşitme Engelli Çocukların Okul Öncesi Dönemde Kaynaştırma Ortamında Eğitimleri. Milli Eğitim Kültür-Sanat Dergisi, Sayı: 136, S:58</a:t>
             </a:r>
           </a:p>
           <a:p>
@@ -6094,7 +6444,7 @@
               <a:rPr sz="1300" b="0">
                 <a:latin typeface="Times New Roman"/>
               </a:rPr>
-              <a:t>Johnson, K. O. (1951). The Effect of Classroom Training upon Listening Comprehension. The Journal of Communication. I, 58</a:t>
+              <a:t>Quandt, J. I. (1983). Language Arts for Children. London: Prentice Hall Inc</a:t>
             </a:r>
           </a:p>
           <a:p>
@@ -6108,7 +6458,21 @@
               <a:rPr sz="1300" b="0">
                 <a:latin typeface="Times New Roman"/>
               </a:rPr>
-              <a:t>Klin, A. (2006). "Asperger's syndrome". Adolesc Med Clin 17 (3): 771–88.</a:t>
+              <a:t>Weaver, C.&amp;Kintsch, W. (1991). Expository Texts. Handbook of Reading Research. Rebecca Barr, Michael Kamil ve diğer (Ed.) New York: Longman</a:t>
+            </a:r>
+          </a:p>
+          <a:p>
+            <a:pPr marL="228600" indent="-228600">
+              <a:spcAft>
+                <a:spcPts val="500"/>
+              </a:spcAft>
+              <a:buNone/>
+            </a:pPr>
+            <a:r>
+              <a:rPr sz="1300" b="0">
+                <a:latin typeface="Times New Roman"/>
+              </a:rPr>
+              <a:t>Westling, D. L.&amp;Fox, L. (2000). Teaching Students With Several Disabilities. (2nd Edition). USA: Printice Hall</a:t>
             </a:r>
           </a:p>
         </p:txBody>
@@ -6168,14 +6532,7 @@
         <p:txBody>
           <a:bodyPr/>
           <a:lstStyle/>
-          <a:p>
-            <a:r>
-              <a:rPr b="1">
-                <a:latin typeface="Times New Roman"/>
-              </a:rPr>
-              <a:t>Kaynakça (3/4)</a:t>
-            </a:r>
-          </a:p>
+          <a:p/>
         </p:txBody>
       </p:sp>
       <p:sp>
@@ -6190,413 +6547,56 @@
         </p:nvSpPr>
         <p:spPr/>
         <p:txBody>
-          <a:bodyPr wrap="square">
-            <a:noAutofit/>
-          </a:bodyPr>
-          <a:lstStyle/>
-          <a:p>
-            <a:pPr marL="228600" indent="-228600">
-              <a:spcAft>
-                <a:spcPts val="500"/>
-              </a:spcAft>
-              <a:buNone/>
-            </a:pPr>
-            <a:r>
-              <a:rPr sz="1300" b="0">
-                <a:latin typeface="Times New Roman"/>
-              </a:rPr>
-              <a:t>Kilgo, J.&amp;Gorgiarla, R. (2005). Young Children with Special Needs. (Second Edition). USA: Thomson-Delmar Learning</a:t>
-            </a:r>
-          </a:p>
-          <a:p>
-            <a:pPr marL="228600" indent="-228600">
-              <a:spcAft>
-                <a:spcPts val="500"/>
-              </a:spcAft>
-              <a:buNone/>
-            </a:pPr>
-            <a:r>
-              <a:rPr sz="1300" b="0">
-                <a:latin typeface="Times New Roman"/>
-              </a:rPr>
-              <a:t>Kırcaali-İftar, G. (1998). Özel Eğitim. Eskişehir: T.C. Anadolu Üniversitesi Yayınları</a:t>
-            </a:r>
-          </a:p>
-          <a:p>
-            <a:pPr marL="228600" indent="-228600">
-              <a:spcAft>
-                <a:spcPts val="500"/>
-              </a:spcAft>
-              <a:buNone/>
-            </a:pPr>
-            <a:r>
-              <a:rPr sz="1300" b="0">
-                <a:latin typeface="Times New Roman"/>
-              </a:rPr>
-              <a:t>Kingen, S. (2000). Teaching Language Arts in Middle Schools. Mahwah, New Jersey: Lawrence Erlbaum Associates</a:t>
-            </a:r>
-          </a:p>
-          <a:p>
-            <a:pPr marL="228600" indent="-228600">
-              <a:spcAft>
-                <a:spcPts val="500"/>
-              </a:spcAft>
-              <a:buNone/>
-            </a:pPr>
-            <a:r>
-              <a:rPr sz="1300" b="0">
-                <a:latin typeface="Times New Roman"/>
-              </a:rPr>
-              <a:t>Kuz, T. (2001). Kaynaştırma Eğitimine Yönelik Tutumların İncelenmesi. Ankara: Başbakanlık Özürlüler idaresi Başkanlığı Yayınları</a:t>
-            </a:r>
-          </a:p>
-          <a:p>
-            <a:pPr marL="228600" indent="-228600">
-              <a:spcAft>
-                <a:spcPts val="500"/>
-              </a:spcAft>
-              <a:buNone/>
-            </a:pPr>
-            <a:r>
-              <a:rPr sz="1300" b="0">
-                <a:latin typeface="Times New Roman"/>
-              </a:rPr>
-              <a:t>Kuzu, T. S. (2004). Etkileşimsel Modele Uygun Okuma Öğretiminin Türkçe Bilgilendirici Metinleri Anlama Düzeyine Etkisi. Ankara Üniversitesi, Eğitim Bilimleri Fakültesi Dergisi, 3(1), 55-77</a:t>
-            </a:r>
-          </a:p>
-          <a:p>
-            <a:pPr marL="228600" indent="-228600">
-              <a:spcAft>
-                <a:spcPts val="500"/>
-              </a:spcAft>
-              <a:buNone/>
-            </a:pPr>
-            <a:r>
-              <a:rPr sz="1300" b="0">
-                <a:latin typeface="Times New Roman"/>
-              </a:rPr>
-              <a:t>Levis, R. B.&amp;Doorlag H. D. (1999). Teaching Special Students in General Education Classrooms. New Jersey, Prentice Hall</a:t>
-            </a:r>
-          </a:p>
-          <a:p>
-            <a:pPr marL="228600" indent="-228600">
-              <a:spcAft>
-                <a:spcPts val="500"/>
-              </a:spcAft>
-              <a:buNone/>
-            </a:pPr>
-            <a:r>
-              <a:rPr sz="1300" b="0">
-                <a:latin typeface="Times New Roman"/>
-              </a:rPr>
-              <a:t>Mağden, D. ve Avcı, N. (1997). Öğretmen Adaylarının Özürlü Öğrencilerin Kaynaştırılmasına İlişkin Görüşleri. 4. Ulusal Eğitim Bilimleri Kongresi. Eskişehir: Anadolu Üniversitesi Eğitim Fakültesi. 10-12 Eylül</a:t>
-            </a:r>
-          </a:p>
-          <a:p>
-            <a:pPr marL="228600" indent="-228600">
-              <a:spcAft>
-                <a:spcPts val="500"/>
-              </a:spcAft>
-              <a:buNone/>
-            </a:pPr>
-            <a:r>
-              <a:rPr sz="1300" b="0">
-                <a:latin typeface="Times New Roman"/>
-              </a:rPr>
-              <a:t>MEB. (2005). İlköğretim 1-5. Sınıf Programları Tanıtım El Kitabı. Ankara: Devlet Kitapları Müdürlüğü Basımevi</a:t>
-            </a:r>
-          </a:p>
-          <a:p>
-            <a:pPr marL="228600" indent="-228600">
-              <a:spcAft>
-                <a:spcPts val="500"/>
-              </a:spcAft>
-              <a:buNone/>
-            </a:pPr>
-            <a:r>
-              <a:rPr sz="1300" b="0">
-                <a:latin typeface="Times New Roman"/>
-              </a:rPr>
-              <a:t>MEB. (2006). Özel eğitim Hizmetleri Yönetmeliği, 31.05.2006 tarih ve 26184 Sayılı Resmî Gazete</a:t>
-            </a:r>
-          </a:p>
-          <a:p>
-            <a:pPr marL="228600" indent="-228600">
-              <a:spcAft>
-                <a:spcPts val="500"/>
-              </a:spcAft>
-              <a:buNone/>
-            </a:pPr>
-            <a:r>
-              <a:rPr sz="1300" b="0">
-                <a:latin typeface="Times New Roman"/>
-              </a:rPr>
-              <a:t>MEB. (2009). MEGEP. Çocuk Gelişimi ve Eğitimi. Zihinsel Engelliler. Ders Notları. Ankara: Devlet Kitapları Müdürlüğü Basımevi</a:t>
-            </a:r>
-          </a:p>
-          <a:p>
-            <a:pPr marL="228600" indent="-228600">
-              <a:spcAft>
-                <a:spcPts val="500"/>
-              </a:spcAft>
-              <a:buNone/>
-            </a:pPr>
-            <a:r>
-              <a:rPr sz="1300" b="0">
-                <a:latin typeface="Times New Roman"/>
-              </a:rPr>
-              <a:t>Merriam, S. B. (1998). Qualitative Researchand Case Study Applications in Education (Second Edition). San Francisco: Jossey-Bass Publishers</a:t>
-            </a:r>
-          </a:p>
-        </p:txBody>
-      </p:sp>
-      <p:sp>
-        <p:nvSpPr>
-          <p:cNvPr id="6" name="Slide Number Placeholder 5"/>
-          <p:cNvSpPr>
-            <a:spLocks noGrp="1"/>
-          </p:cNvSpPr>
-          <p:nvPr>
-            <p:ph type="sldNum" sz="quarter" idx="12"/>
-          </p:nvPr>
-        </p:nvSpPr>
-        <p:spPr/>
-        <p:txBody>
-          <a:bodyPr/>
-          <a:lstStyle/>
-          <a:p>
-            <a:fld id="{F302176B-0E47-46AC-8F43-DAB4B8A37D06}" type="slidenum">
-              <a:rPr lang="tr-TR" smtClean="0"/>
-              <a:t>‹#›</a:t>
-            </a:fld>
-            <a:endParaRPr lang="tr-TR"/>
-          </a:p>
-        </p:txBody>
-      </p:sp>
-    </p:spTree>
-  </p:cSld>
-  <p:clrMapOvr>
-    <a:masterClrMapping/>
-  </p:clrMapOvr>
-</p:sld>
-</file>
-
-<file path=ppt/slides/slide24.xml><?xml version="1.0" encoding="utf-8"?>
-<p:sld xmlns:a="http://schemas.openxmlformats.org/drawingml/2006/main" xmlns:p="http://schemas.openxmlformats.org/presentationml/2006/main" xmlns:r="http://schemas.openxmlformats.org/officeDocument/2006/relationships">
-  <p:cSld>
-    <p:spTree>
-      <p:nvGrpSpPr>
-        <p:cNvPr id="1" name=""/>
-        <p:cNvGrpSpPr/>
-        <p:nvPr/>
-      </p:nvGrpSpPr>
-      <p:grpSpPr/>
-      <p:sp>
-        <p:nvSpPr>
-          <p:cNvPr id="2" name="Title 1"/>
-          <p:cNvSpPr>
-            <a:spLocks noGrp="1"/>
-          </p:cNvSpPr>
-          <p:nvPr>
-            <p:ph type="title"/>
-          </p:nvPr>
-        </p:nvSpPr>
-        <p:spPr/>
-        <p:txBody>
-          <a:bodyPr/>
-          <a:lstStyle/>
-          <a:p>
-            <a:r>
-              <a:rPr b="1">
-                <a:latin typeface="Times New Roman"/>
-              </a:rPr>
-              <a:t>Kaynakça (4/4)</a:t>
-            </a:r>
-          </a:p>
-        </p:txBody>
-      </p:sp>
-      <p:sp>
-        <p:nvSpPr>
-          <p:cNvPr id="3" name="Content Placeholder 2"/>
-          <p:cNvSpPr>
-            <a:spLocks noGrp="1"/>
-          </p:cNvSpPr>
-          <p:nvPr>
-            <p:ph idx="1"/>
-          </p:nvPr>
-        </p:nvSpPr>
-        <p:spPr/>
-        <p:txBody>
-          <a:bodyPr wrap="square">
-            <a:noAutofit/>
-          </a:bodyPr>
-          <a:lstStyle/>
-          <a:p>
-            <a:pPr marL="228600" indent="-228600">
-              <a:spcAft>
-                <a:spcPts val="500"/>
-              </a:spcAft>
-              <a:buNone/>
-            </a:pPr>
-            <a:r>
-              <a:rPr sz="1300" b="0">
-                <a:latin typeface="Times New Roman"/>
-              </a:rPr>
-              <a:t>Ömür, M. (2006). Kulağımızın Göz Kapağı Yoktur, Cumhuriyet Bilim, S.990, s. 16-17</a:t>
-            </a:r>
-          </a:p>
-          <a:p>
-            <a:pPr marL="228600" indent="-228600">
-              <a:spcAft>
-                <a:spcPts val="500"/>
-              </a:spcAft>
-              <a:buNone/>
-            </a:pPr>
-            <a:r>
-              <a:rPr sz="1300" b="0">
-                <a:latin typeface="Times New Roman"/>
-              </a:rPr>
-              <a:t>Özbay, M. (2005). Bir Dil Becerisi Olarak Dinleme Eğitimi. Ankara: Akçağ Yayınları</a:t>
-            </a:r>
-          </a:p>
-          <a:p>
-            <a:pPr marL="228600" indent="-228600">
-              <a:spcAft>
-                <a:spcPts val="500"/>
-              </a:spcAft>
-              <a:buNone/>
-            </a:pPr>
-            <a:r>
-              <a:rPr sz="1300" b="0">
-                <a:latin typeface="Times New Roman"/>
-              </a:rPr>
-              <a:t>Özel Eğitim Hakkında Kanun Hükmünde Kararname ve Özel Eğitim Hizmetleri Yönetmeliği (2000). Ankara: Milli Eğitim Basımevi</a:t>
-            </a:r>
-          </a:p>
-          <a:p>
-            <a:pPr marL="228600" indent="-228600">
-              <a:spcAft>
-                <a:spcPts val="500"/>
-              </a:spcAft>
-              <a:buNone/>
-            </a:pPr>
-            <a:r>
-              <a:rPr sz="1300" b="0">
-                <a:latin typeface="Times New Roman"/>
-              </a:rPr>
-              <a:t>Özdemir, E. (1998). Eleştirel Okuma. Ankara: Ümit Yayıncılık</a:t>
-            </a:r>
-          </a:p>
-          <a:p>
-            <a:pPr marL="228600" indent="-228600">
-              <a:spcAft>
-                <a:spcPts val="500"/>
-              </a:spcAft>
-              <a:buNone/>
-            </a:pPr>
-            <a:r>
-              <a:rPr sz="1300" b="0">
-                <a:latin typeface="Times New Roman"/>
-              </a:rPr>
-              <a:t>Özgür, G. (2004). Engelli Çocuklar ve Eğitim-Özel Eğitim. Adana: Karhan Kitabevi</a:t>
-            </a:r>
-          </a:p>
-          <a:p>
-            <a:pPr marL="228600" indent="-228600">
-              <a:spcAft>
-                <a:spcPts val="500"/>
-              </a:spcAft>
-              <a:buNone/>
-            </a:pPr>
-            <a:r>
-              <a:rPr sz="1300" b="0">
-                <a:latin typeface="Times New Roman"/>
-              </a:rPr>
-              <a:t>Salend, S. J. (1998). Effective Mainstreaming: Creating inclusive classrooms. (3rd Edition). New Jersey: Merrill Prentice Hall</a:t>
-            </a:r>
-          </a:p>
-          <a:p>
-            <a:pPr marL="228600" indent="-228600">
-              <a:spcAft>
-                <a:spcPts val="500"/>
-              </a:spcAft>
-              <a:buNone/>
-            </a:pPr>
-            <a:r>
-              <a:rPr sz="1300" b="0">
-                <a:latin typeface="Times New Roman"/>
-              </a:rPr>
-              <a:t>Sucuoğlu, B. (2010). Zihin Engelliler ve Eğitimleri. Ankara: Kök Yayıncılık</a:t>
-            </a:r>
-          </a:p>
-          <a:p>
-            <a:pPr marL="228600" indent="-228600">
-              <a:spcAft>
-                <a:spcPts val="500"/>
-              </a:spcAft>
-              <a:buNone/>
-            </a:pPr>
-            <a:r>
-              <a:rPr sz="1300" b="0">
-                <a:latin typeface="Times New Roman"/>
-              </a:rPr>
-              <a:t>Şura Raporu. (1999). I. Özürlüler Şurası Çağdaş Toplum Çağdaş Yaşam ve Özürlüler. 29 Kasım-02 Aralık. Ankara: T.C. Başbakanlık Özürlüler İdaresi Başkanlığı Yayınları</a:t>
-            </a:r>
-          </a:p>
-          <a:p>
-            <a:pPr marL="228600" indent="-228600">
-              <a:spcAft>
-                <a:spcPts val="500"/>
-              </a:spcAft>
-              <a:buNone/>
-            </a:pPr>
-            <a:r>
-              <a:rPr sz="1300" b="0">
-                <a:latin typeface="Times New Roman"/>
-              </a:rPr>
-              <a:t>Tüfekçioğlu, Ü. (1997). İşitme Engelli Çocukların Okul Öncesi Dönemde Kaynaştırma Ortamında Eğitimleri. Milli Eğitim Kültür-Sanat Dergisi, Sayı: 136, S:58</a:t>
-            </a:r>
-          </a:p>
-          <a:p>
-            <a:pPr marL="228600" indent="-228600">
-              <a:spcAft>
-                <a:spcPts val="500"/>
-              </a:spcAft>
-              <a:buNone/>
-            </a:pPr>
-            <a:r>
-              <a:rPr sz="1300" b="0">
-                <a:latin typeface="Times New Roman"/>
-              </a:rPr>
-              <a:t>Quandt, J. I. (1983). Language Arts for Children. London: Prentice Hall Inc</a:t>
-            </a:r>
-          </a:p>
-          <a:p>
-            <a:pPr marL="228600" indent="-228600">
-              <a:spcAft>
-                <a:spcPts val="500"/>
-              </a:spcAft>
-              <a:buNone/>
-            </a:pPr>
-            <a:r>
-              <a:rPr sz="1300" b="0">
-                <a:latin typeface="Times New Roman"/>
-              </a:rPr>
-              <a:t>Weaver, C.&amp;Kintsch, W. (1991). Expository Texts. Handbook of Reading Research. Rebecca Barr, Michael Kamil ve diğer (Ed.) New York: Longman</a:t>
-            </a:r>
-          </a:p>
-          <a:p>
-            <a:pPr marL="228600" indent="-228600">
-              <a:spcAft>
-                <a:spcPts val="500"/>
-              </a:spcAft>
-              <a:buNone/>
-            </a:pPr>
-            <a:r>
-              <a:rPr sz="1300" b="0">
-                <a:latin typeface="Times New Roman"/>
-              </a:rPr>
-              <a:t>Westling, D. L.&amp;Fox, L. (2000). Teaching Students With Several Disabilities. (2nd Edition). USA: Printice Hall</a:t>
+          <a:bodyPr/>
+          <a:lstStyle/>
+          <a:p>
+            <a:r>
+              <a:rPr sz="2400" b="0">
+                <a:latin typeface="Times New Roman"/>
+              </a:rPr>
+              <a:t>HAZIRLAYAN :</a:t>
+            </a:r>
+          </a:p>
+          <a:p/>
+          <a:p>
+            <a:r>
+              <a:rPr sz="2400" b="0">
+                <a:latin typeface="Times New Roman"/>
+              </a:rPr>
+              <a:t/>
+            </a:r>
+          </a:p>
+          <a:p>
+            <a:r>
+              <a:rPr sz="2400" b="0">
+                <a:latin typeface="Times New Roman"/>
+              </a:rPr>
+              <a:t/>
+            </a:r>
+          </a:p>
+          <a:p>
+            <a:r>
+              <a:rPr sz="2400" b="0">
+                <a:latin typeface="Times New Roman"/>
+              </a:rPr>
+              <a:t>ÖZET MAKALE (TÜRKÇE)</a:t>
+            </a:r>
+          </a:p>
+          <a:p/>
+          <a:p>
+            <a:r>
+              <a:rPr sz="2400" b="1">
+                <a:latin typeface="Times New Roman"/>
+              </a:rPr>
+              <a:t>Akademik Bakış Dergisi, Sayı 41, Mart–Nisan 2014</a:t>
+            </a:r>
+          </a:p>
+          <a:p>
+            <a:r>
+              <a:rPr sz="2400" b="1">
+                <a:latin typeface="Times New Roman"/>
+              </a:rPr>
+              <a:t>Celalabat / Kırgızistan</a:t>
             </a:r>
           </a:p>
         </p:txBody>
@@ -6759,40 +6759,6 @@
           </a:p>
         </p:txBody>
       </p:sp>
-      <p:sp>
-        <p:nvSpPr>
-          <p:cNvPr id="7" name="TextBox 6"/>
-          <p:cNvSpPr txBox="1"/>
-          <p:nvPr/>
-        </p:nvSpPr>
-        <p:spPr>
-          <a:xfrm>
-            <a:off x="457200" y="6380000"/>
-            <a:ext cx="6500000" cy="380000"/>
-          </a:xfrm>
-          <a:prstGeom prst="rect">
-            <a:avLst/>
-          </a:prstGeom>
-          <a:noFill/>
-        </p:spPr>
-        <p:txBody>
-          <a:bodyPr wrap="none">
-            <a:spAutoFit/>
-          </a:bodyPr>
-          <a:lstStyle/>
-          <a:p>
-            <a:r>
-              <a:rPr sz="1600" b="1">
-                <a:solidFill>
-                  <a:srgbClr val="E36C0A"/>
-                </a:solidFill>
-                <a:latin typeface="Times New Roman"/>
-              </a:rPr>
-              <a:t>Sunan: Çiğdem TURAN</a:t>
-            </a:r>
-          </a:p>
-        </p:txBody>
-      </p:sp>
     </p:spTree>
   </p:cSld>
   <p:clrMapOvr>
@@ -6925,40 +6891,6 @@
               <a:t>‹#›</a:t>
             </a:fld>
             <a:endParaRPr lang="tr-TR"/>
-          </a:p>
-        </p:txBody>
-      </p:sp>
-      <p:sp>
-        <p:nvSpPr>
-          <p:cNvPr id="7" name="TextBox 6"/>
-          <p:cNvSpPr txBox="1"/>
-          <p:nvPr/>
-        </p:nvSpPr>
-        <p:spPr>
-          <a:xfrm>
-            <a:off x="457200" y="6380000"/>
-            <a:ext cx="6500000" cy="380000"/>
-          </a:xfrm>
-          <a:prstGeom prst="rect">
-            <a:avLst/>
-          </a:prstGeom>
-          <a:noFill/>
-        </p:spPr>
-        <p:txBody>
-          <a:bodyPr wrap="none">
-            <a:spAutoFit/>
-          </a:bodyPr>
-          <a:lstStyle/>
-          <a:p>
-            <a:r>
-              <a:rPr sz="1600" b="1">
-                <a:solidFill>
-                  <a:srgbClr val="E36C0A"/>
-                </a:solidFill>
-                <a:latin typeface="Times New Roman"/>
-              </a:rPr>
-              <a:t>Sunan: Derya YILMAZ YILDIZ</a:t>
-            </a:r>
           </a:p>
         </p:txBody>
       </p:sp>

</xml_diff>

<commit_message>
Makale1: change olive-green theme accents to orange
Co-Authored-By: Claude Sonnet 5.5 <noreply@anthropic.com>
Claude-Session: https://claude.ai/code/session_01TyFKmLJqyxNygHvjK9ydxU
</commit_message>
<xml_diff>
--- a/Makale1_Dinledigini_Anlama_Ozet.pptx
+++ b/Makale1_Dinledigini_Anlama_Ozet.pptx
@@ -7610,13 +7610,13 @@
         <a:srgbClr val="DFDCB7"/>
       </a:lt2>
       <a:accent1>
-        <a:srgbClr val="A9A57C"/>
+        <a:srgbClr val="E36C0A"/>
       </a:accent1>
       <a:accent2>
         <a:srgbClr val="9CBEBD"/>
       </a:accent2>
       <a:accent3>
-        <a:srgbClr val="D2CB6C"/>
+        <a:srgbClr val="F4A259"/>
       </a:accent3>
       <a:accent4>
         <a:srgbClr val="95A39D"/>

</xml_diff>

<commit_message>
Makale1: move presenters to a new slide after the cover
Co-Authored-By: Claude Sonnet 5.5 <noreply@anthropic.com>
Claude-Session: https://claude.ai/code/session_01TyFKmLJqyxNygHvjK9ydxU
</commit_message>
<xml_diff>
--- a/Makale1_Dinledigini_Anlama_Ozet.pptx
+++ b/Makale1_Dinledigini_Anlama_Ozet.pptx
@@ -9,6 +9,7 @@
   </p:notesMasterIdLst>
   <p:sldIdLst>
     <p:sldId id="256" r:id="rId7"/>
+    <p:sldId id="280" r:id="rId25"/>
     <p:sldId id="257" r:id="rId8"/>
     <p:sldId id="258" r:id="rId9"/>
     <p:sldId id="259" r:id="rId10"/>
@@ -3845,7 +3846,7 @@
           <a:p>
             <a:fld id="{F302176B-0E47-46AC-8F43-DAB4B8A37D06}" type="slidenum">
               <a:rPr lang="tr-TR" smtClean="0"/>
-              <a:t>10</a:t>
+              <a:t>11</a:t>
             </a:fld>
             <a:endParaRPr lang="tr-TR"/>
           </a:p>
@@ -3979,7 +3980,7 @@
           <a:p>
             <a:fld id="{F302176B-0E47-46AC-8F43-DAB4B8A37D06}" type="slidenum">
               <a:rPr lang="tr-TR" smtClean="0"/>
-              <a:t>11</a:t>
+              <a:t>12</a:t>
             </a:fld>
             <a:endParaRPr lang="tr-TR"/>
           </a:p>
@@ -4145,7 +4146,7 @@
           <a:p>
             <a:fld id="{F302176B-0E47-46AC-8F43-DAB4B8A37D06}" type="slidenum">
               <a:rPr lang="tr-TR" smtClean="0"/>
-              <a:t>12</a:t>
+              <a:t>13</a:t>
             </a:fld>
             <a:endParaRPr lang="tr-TR"/>
           </a:p>
@@ -4671,7 +4672,7 @@
           <a:p>
             <a:fld id="{F302176B-0E47-46AC-8F43-DAB4B8A37D06}" type="slidenum">
               <a:rPr lang="tr-TR" smtClean="0"/>
-              <a:t>13</a:t>
+              <a:t>14</a:t>
             </a:fld>
             <a:endParaRPr lang="tr-TR"/>
           </a:p>
@@ -4818,7 +4819,7 @@
           <a:p>
             <a:fld id="{F302176B-0E47-46AC-8F43-DAB4B8A37D06}" type="slidenum">
               <a:rPr lang="tr-TR" smtClean="0"/>
-              <a:t>14</a:t>
+              <a:t>15</a:t>
             </a:fld>
             <a:endParaRPr lang="tr-TR"/>
           </a:p>
@@ -4971,7 +4972,7 @@
           <a:p>
             <a:fld id="{F302176B-0E47-46AC-8F43-DAB4B8A37D06}" type="slidenum">
               <a:rPr lang="tr-TR" smtClean="0"/>
-              <a:t>15</a:t>
+              <a:t>16</a:t>
             </a:fld>
             <a:endParaRPr lang="tr-TR"/>
           </a:p>
@@ -5093,7 +5094,7 @@
           <a:p>
             <a:fld id="{F302176B-0E47-46AC-8F43-DAB4B8A37D06}" type="slidenum">
               <a:rPr lang="tr-TR" smtClean="0"/>
-              <a:t>16</a:t>
+              <a:t>17</a:t>
             </a:fld>
             <a:endParaRPr lang="tr-TR"/>
           </a:p>
@@ -5228,7 +5229,7 @@
           <a:p>
             <a:fld id="{F302176B-0E47-46AC-8F43-DAB4B8A37D06}" type="slidenum">
               <a:rPr lang="tr-TR" smtClean="0"/>
-              <a:t>17</a:t>
+              <a:t>18</a:t>
             </a:fld>
             <a:endParaRPr lang="tr-TR"/>
           </a:p>
@@ -5376,7 +5377,7 @@
           <a:p>
             <a:fld id="{F302176B-0E47-46AC-8F43-DAB4B8A37D06}" type="slidenum">
               <a:rPr lang="tr-TR" smtClean="0"/>
-              <a:t>18</a:t>
+              <a:t>19</a:t>
             </a:fld>
             <a:endParaRPr lang="tr-TR"/>
           </a:p>
@@ -5613,7 +5614,7 @@
           <a:p>
             <a:fld id="{F302176B-0E47-46AC-8F43-DAB4B8A37D06}" type="slidenum">
               <a:rPr lang="tr-TR" smtClean="0"/>
-              <a:t>19</a:t>
+              <a:t>20</a:t>
             </a:fld>
             <a:endParaRPr lang="tr-TR"/>
           </a:p>
@@ -5735,43 +5736,9 @@
           <a:p>
             <a:fld id="{F302176B-0E47-46AC-8F43-DAB4B8A37D06}" type="slidenum">
               <a:rPr lang="tr-TR" smtClean="0"/>
-              <a:t>2</a:t>
+              <a:t>3</a:t>
             </a:fld>
             <a:endParaRPr lang="tr-TR"/>
-          </a:p>
-        </p:txBody>
-      </p:sp>
-      <p:sp>
-        <p:nvSpPr>
-          <p:cNvPr id="7" name="TextBox 6"/>
-          <p:cNvSpPr txBox="1"/>
-          <p:nvPr/>
-        </p:nvSpPr>
-        <p:spPr>
-          <a:xfrm>
-            <a:off x="457200" y="6350000"/>
-            <a:ext cx="7620000" cy="380000"/>
-          </a:xfrm>
-          <a:prstGeom prst="rect">
-            <a:avLst/>
-          </a:prstGeom>
-          <a:noFill/>
-        </p:spPr>
-        <p:txBody>
-          <a:bodyPr wrap="square">
-            <a:spAutoFit/>
-          </a:bodyPr>
-          <a:lstStyle/>
-          <a:p>
-            <a:r>
-              <a:rPr sz="1500" b="1">
-                <a:solidFill>
-                  <a:srgbClr val="E36C0A"/>
-                </a:solidFill>
-                <a:latin typeface="Times New Roman"/>
-              </a:rPr>
-              <a:t>Sunanlar: Feyza BÜYÜKBEKTAŞ  |  Çiğdem TURAN  |  Derya YILMAZ YILDIZ</a:t>
-            </a:r>
           </a:p>
         </p:txBody>
       </p:sp>
@@ -6006,7 +5973,7 @@
           <a:p>
             <a:fld id="{F302176B-0E47-46AC-8F43-DAB4B8A37D06}" type="slidenum">
               <a:rPr lang="tr-TR" smtClean="0"/>
-              <a:t>20</a:t>
+              <a:t>21</a:t>
             </a:fld>
             <a:endParaRPr lang="tr-TR"/>
           </a:p>
@@ -6243,7 +6210,7 @@
           <a:p>
             <a:fld id="{F302176B-0E47-46AC-8F43-DAB4B8A37D06}" type="slidenum">
               <a:rPr lang="tr-TR" smtClean="0"/>
-              <a:t>21</a:t>
+              <a:t>22</a:t>
             </a:fld>
             <a:endParaRPr lang="tr-TR"/>
           </a:p>
@@ -6494,7 +6461,7 @@
           <a:p>
             <a:fld id="{F302176B-0E47-46AC-8F43-DAB4B8A37D06}" type="slidenum">
               <a:rPr lang="tr-TR" smtClean="0"/>
-              <a:t>22</a:t>
+              <a:t>23</a:t>
             </a:fld>
             <a:endParaRPr lang="tr-TR"/>
           </a:p>
@@ -6618,7 +6585,129 @@
           <a:p>
             <a:fld id="{F302176B-0E47-46AC-8F43-DAB4B8A37D06}" type="slidenum">
               <a:rPr lang="tr-TR" smtClean="0"/>
-              <a:t>23</a:t>
+              <a:t>24</a:t>
+            </a:fld>
+            <a:endParaRPr lang="tr-TR"/>
+          </a:p>
+        </p:txBody>
+      </p:sp>
+    </p:spTree>
+  </p:cSld>
+  <p:clrMapOvr>
+    <a:masterClrMapping/>
+  </p:clrMapOvr>
+</p:sld>
+</file>
+
+<file path=ppt/slides/slide24.xml><?xml version="1.0" encoding="utf-8"?>
+<p:sld xmlns:a="http://schemas.openxmlformats.org/drawingml/2006/main" xmlns:p="http://schemas.openxmlformats.org/presentationml/2006/main" xmlns:r="http://schemas.openxmlformats.org/officeDocument/2006/relationships">
+  <p:cSld>
+    <p:spTree>
+      <p:nvGrpSpPr>
+        <p:cNvPr id="1" name=""/>
+        <p:cNvGrpSpPr/>
+        <p:nvPr/>
+      </p:nvGrpSpPr>
+      <p:grpSpPr/>
+      <p:sp>
+        <p:nvSpPr>
+          <p:cNvPr id="2" name="Title 1"/>
+          <p:cNvSpPr>
+            <a:spLocks noGrp="1"/>
+          </p:cNvSpPr>
+          <p:nvPr>
+            <p:ph type="title"/>
+          </p:nvPr>
+        </p:nvSpPr>
+        <p:spPr/>
+        <p:txBody>
+          <a:bodyPr/>
+          <a:lstStyle/>
+          <a:p>
+            <a:r>
+              <a:rPr b="1">
+                <a:latin typeface="Times New Roman"/>
+              </a:rPr>
+              <a:t>Sunanlar</a:t>
+            </a:r>
+          </a:p>
+        </p:txBody>
+      </p:sp>
+      <p:sp>
+        <p:nvSpPr>
+          <p:cNvPr id="3" name="Content Placeholder 2"/>
+          <p:cNvSpPr>
+            <a:spLocks noGrp="1"/>
+          </p:cNvSpPr>
+          <p:nvPr>
+            <p:ph idx="1"/>
+          </p:nvPr>
+        </p:nvSpPr>
+        <p:spPr/>
+        <p:txBody>
+          <a:bodyPr wrap="square">
+            <a:noAutofit/>
+          </a:bodyPr>
+          <a:lstStyle/>
+          <a:p>
+            <a:pPr>
+              <a:spcAft>
+                <a:spcPts val="600"/>
+              </a:spcAft>
+            </a:pPr>
+            <a:r>
+              <a:rPr sz="2700" b="0">
+                <a:latin typeface="Times New Roman"/>
+              </a:rPr>
+              <a:t>Feyza BÜYÜKBEKTAŞ</a:t>
+            </a:r>
+          </a:p>
+          <a:p>
+            <a:pPr>
+              <a:spcAft>
+                <a:spcPts val="600"/>
+              </a:spcAft>
+            </a:pPr>
+            <a:r>
+              <a:rPr sz="2700" b="0">
+                <a:latin typeface="Times New Roman"/>
+              </a:rPr>
+              <a:t>Çiğdem TURAN</a:t>
+            </a:r>
+          </a:p>
+          <a:p>
+            <a:pPr>
+              <a:spcAft>
+                <a:spcPts val="600"/>
+              </a:spcAft>
+            </a:pPr>
+            <a:r>
+              <a:rPr sz="2700" b="0">
+                <a:latin typeface="Times New Roman"/>
+              </a:rPr>
+              <a:t>Derya YILMAZ YILDIZ</a:t>
+            </a:r>
+          </a:p>
+        </p:txBody>
+      </p:sp>
+      <p:sp>
+        <p:nvSpPr>
+          <p:cNvPr id="6" name="Slide Number Placeholder 5"/>
+          <p:cNvSpPr>
+            <a:spLocks noGrp="1"/>
+          </p:cNvSpPr>
+          <p:nvPr>
+            <p:ph type="sldNum" sz="quarter" idx="12"/>
+          </p:nvPr>
+        </p:nvSpPr>
+        <p:spPr/>
+        <p:txBody>
+          <a:bodyPr/>
+          <a:lstStyle/>
+          <a:p>
+            <a:fld id="{F302176B-0E47-46AC-8F43-DAB4B8A37D06}" type="slidenum">
+              <a:rPr lang="tr-TR" smtClean="0"/>
+              <a:t>2</a:t>
             </a:fld>
             <a:endParaRPr lang="tr-TR"/>
           </a:p>
@@ -6753,7 +6842,7 @@
           <a:p>
             <a:fld id="{F302176B-0E47-46AC-8F43-DAB4B8A37D06}" type="slidenum">
               <a:rPr lang="tr-TR" smtClean="0"/>
-              <a:t>3</a:t>
+              <a:t>4</a:t>
             </a:fld>
             <a:endParaRPr lang="tr-TR"/>
           </a:p>
@@ -6888,7 +6977,7 @@
           <a:p>
             <a:fld id="{F302176B-0E47-46AC-8F43-DAB4B8A37D06}" type="slidenum">
               <a:rPr lang="tr-TR" smtClean="0"/>
-              <a:t>4</a:t>
+              <a:t>5</a:t>
             </a:fld>
             <a:endParaRPr lang="tr-TR"/>
           </a:p>
@@ -7023,7 +7112,7 @@
           <a:p>
             <a:fld id="{F302176B-0E47-46AC-8F43-DAB4B8A37D06}" type="slidenum">
               <a:rPr lang="tr-TR" smtClean="0"/>
-              <a:t>5</a:t>
+              <a:t>6</a:t>
             </a:fld>
             <a:endParaRPr lang="tr-TR"/>
           </a:p>
@@ -7158,7 +7247,7 @@
           <a:p>
             <a:fld id="{F302176B-0E47-46AC-8F43-DAB4B8A37D06}" type="slidenum">
               <a:rPr lang="tr-TR" smtClean="0"/>
-              <a:t>6</a:t>
+              <a:t>7</a:t>
             </a:fld>
             <a:endParaRPr lang="tr-TR"/>
           </a:p>
@@ -7298,7 +7387,7 @@
           <a:p>
             <a:fld id="{F302176B-0E47-46AC-8F43-DAB4B8A37D06}" type="slidenum">
               <a:rPr lang="tr-TR" smtClean="0"/>
-              <a:t>7</a:t>
+              <a:t>8</a:t>
             </a:fld>
             <a:endParaRPr lang="tr-TR"/>
           </a:p>
@@ -7439,7 +7528,7 @@
           <a:p>
             <a:fld id="{F302176B-0E47-46AC-8F43-DAB4B8A37D06}" type="slidenum">
               <a:rPr lang="tr-TR" smtClean="0"/>
-              <a:t>8</a:t>
+              <a:t>9</a:t>
             </a:fld>
             <a:endParaRPr lang="tr-TR"/>
           </a:p>
@@ -7579,7 +7668,7 @@
           <a:p>
             <a:fld id="{F302176B-0E47-46AC-8F43-DAB4B8A37D06}" type="slidenum">
               <a:rPr lang="tr-TR" smtClean="0"/>
-              <a:t>9</a:t>
+              <a:t>10</a:t>
             </a:fld>
             <a:endParaRPr lang="tr-TR"/>
           </a:p>

</xml_diff>

<commit_message>
Makale1 (text version): add article link to the last slide
Co-Authored-By: Claude Sonnet 5.5 <noreply@anthropic.com>
Claude-Session: https://claude.ai/code/session_01TyFKmLJqyxNygHvjK9ydxU
</commit_message>
<xml_diff>
--- a/Makale1_Dinledigini_Anlama_Ozet.pptx
+++ b/Makale1_Dinledigini_Anlama_Ozet.pptx
@@ -3717,7 +3717,7 @@
               <a:rPr b="1">
                 <a:latin typeface="Times New Roman"/>
               </a:rPr>
-              <a:t>Yöntem ve Katılımcılar</a:t>
+              <a:t>Amaç, Önem ve Sınırlılıklar</a:t>
             </a:r>
           </a:p>
         </p:txBody>
@@ -3748,13 +3748,13 @@
               <a:rPr sz="2500" b="1">
                 <a:latin typeface="Times New Roman"/>
               </a:rPr>
-              <a:t>Desen: </a:t>
+              <a:t>Amaç: </a:t>
             </a:r>
             <a:r>
               <a:rPr sz="2500" b="0">
                 <a:latin typeface="Times New Roman"/>
               </a:rPr>
-              <a:t>Nitel araştırma yöntemlerinden durum çalışması (Yıldırım ve Şimşek, 2006; Merriam, 1988).</a:t>
+              <a:t>Öğrencilerin dinlediğini anlama becerilerini ölçmek ve görsel ile işitsel materyal arasındaki etkileşimi belirlemek.</a:t>
             </a:r>
           </a:p>
           <a:p>
@@ -3767,13 +3767,13 @@
               <a:rPr sz="2500" b="1">
                 <a:latin typeface="Times New Roman"/>
               </a:rPr>
-              <a:t>G: </a:t>
+              <a:t>Önem: </a:t>
             </a:r>
             <a:r>
               <a:rPr sz="2500" b="0">
                 <a:latin typeface="Times New Roman"/>
               </a:rPr>
-              <a:t>10 yaşında, 4. sınıf, bireysel eğitim alıyor.</a:t>
+              <a:t>Sonuçlar, hafif düzeyde zihinsel engelli çocukların eğitim ortamı ve materyallerinin düzenlenmesine ve öğretmen yetiştirme programlarına fikir verebilir.</a:t>
             </a:r>
           </a:p>
           <a:p>
@@ -3786,45 +3786,13 @@
               <a:rPr sz="2500" b="1">
                 <a:latin typeface="Times New Roman"/>
               </a:rPr>
-              <a:t>B: </a:t>
+              <a:t>Sınırlılıklar: </a:t>
             </a:r>
             <a:r>
               <a:rPr sz="2500" b="0">
                 <a:latin typeface="Times New Roman"/>
               </a:rPr>
-              <a:t>12 yaşında, 7. sınıf, bireysel eğitim alıyor.</a:t>
-            </a:r>
-          </a:p>
-          <a:p>
-            <a:pPr>
-              <a:spcAft>
-                <a:spcPts val="600"/>
-              </a:spcAft>
-            </a:pPr>
-            <a:r>
-              <a:rPr sz="2500" b="1">
-                <a:latin typeface="Times New Roman"/>
-              </a:rPr>
-              <a:t>F: </a:t>
-            </a:r>
-            <a:r>
-              <a:rPr sz="2500" b="0">
-                <a:latin typeface="Times New Roman"/>
-              </a:rPr>
-              <a:t>11 yaşında, 6. sınıf, bireysel ve grup eğitimi alıyor; Asperger sendromu tanısı var.</a:t>
-            </a:r>
-          </a:p>
-          <a:p>
-            <a:pPr>
-              <a:spcAft>
-                <a:spcPts val="600"/>
-              </a:spcAft>
-            </a:pPr>
-            <a:r>
-              <a:rPr sz="2500" b="0">
-                <a:latin typeface="Times New Roman"/>
-              </a:rPr>
-              <a:t>Üçü de RAM değerlendirmesiyle destek eğitim programından yararlanmaktadır; sınıfta yalnızca araştırmacı ve öğrenci bulunmuştur.</a:t>
+              <a:t>İstanbul’da ilköğretime devam eden 11-12 yaşlarında, 50-70 arası zekâ bölümlü üç öğrenci; yalnızca işitsel ve görsel-işitsel materyaller.</a:t>
             </a:r>
           </a:p>
         </p:txBody>
@@ -3846,7 +3814,7 @@
           <a:p>
             <a:fld id="{F302176B-0E47-46AC-8F43-DAB4B8A37D06}" type="slidenum">
               <a:rPr lang="tr-TR" smtClean="0"/>
-              <a:t>11</a:t>
+              <a:t>10</a:t>
             </a:fld>
             <a:endParaRPr lang="tr-TR"/>
           </a:p>
@@ -3889,7 +3857,7 @@
               <a:rPr b="1">
                 <a:latin typeface="Times New Roman"/>
               </a:rPr>
-              <a:t>Veri Toplama Araçları</a:t>
+              <a:t>Yöntem ve Katılımcılar</a:t>
             </a:r>
           </a:p>
         </p:txBody>
@@ -3917,16 +3885,16 @@
               </a:spcAft>
             </a:pPr>
             <a:r>
-              <a:rPr sz="2400" b="1">
-                <a:latin typeface="Times New Roman"/>
-              </a:rPr>
-              <a:t>İşitsel materyal: </a:t>
-            </a:r>
-            <a:r>
-              <a:rPr sz="2400" b="0">
-                <a:latin typeface="Times New Roman"/>
-              </a:rPr>
-              <a:t>MEB onaylı Türkçe ders kitaplarından 1., 2., 3. sınıfa uygun 6 hikâye edici ve 6 bilgilendirici metin (ör. Kuşkucu Horoz, Üç Kelebek, Nasreddin Hoca Şenlikleri).</a:t>
+              <a:rPr sz="2500" b="1">
+                <a:latin typeface="Times New Roman"/>
+              </a:rPr>
+              <a:t>Desen: </a:t>
+            </a:r>
+            <a:r>
+              <a:rPr sz="2500" b="0">
+                <a:latin typeface="Times New Roman"/>
+              </a:rPr>
+              <a:t>Nitel araştırma yöntemlerinden durum çalışması (Yıldırım ve Şimşek, 2006; Merriam, 1988).</a:t>
             </a:r>
           </a:p>
           <a:p>
@@ -3936,16 +3904,16 @@
               </a:spcAft>
             </a:pPr>
             <a:r>
-              <a:rPr sz="2400" b="1">
-                <a:latin typeface="Times New Roman"/>
-              </a:rPr>
-              <a:t>Görsel-işitsel materyal: </a:t>
-            </a:r>
-            <a:r>
-              <a:rPr sz="2400" b="0">
-                <a:latin typeface="Times New Roman"/>
-              </a:rPr>
-              <a:t>Uzman görüşüyle seçilen çizgi filmler (Üçüzler Doktorda, Pak ile Pırpır, Rüya’nın Günlüğü) ve bilgi verici videolar (Bitkilerin Büyümesi, İlkyardım Eğitimi, Kek Nasıl Üretilir?).</a:t>
+              <a:rPr sz="2500" b="1">
+                <a:latin typeface="Times New Roman"/>
+              </a:rPr>
+              <a:t>G: </a:t>
+            </a:r>
+            <a:r>
+              <a:rPr sz="2500" b="0">
+                <a:latin typeface="Times New Roman"/>
+              </a:rPr>
+              <a:t>10 yaşında, 4. sınıf, bireysel eğitim alıyor.</a:t>
             </a:r>
           </a:p>
           <a:p>
@@ -3955,10 +3923,48 @@
               </a:spcAft>
             </a:pPr>
             <a:r>
-              <a:rPr sz="2400" b="0">
-                <a:latin typeface="Times New Roman"/>
-              </a:rPr>
-              <a:t>Metinler araştırmacı tarafından prozodik özelliklere uygun, bir kez ve tekrarsız okunmuş; videolar bir kez izletilmiştir.</a:t>
+              <a:rPr sz="2500" b="1">
+                <a:latin typeface="Times New Roman"/>
+              </a:rPr>
+              <a:t>B: </a:t>
+            </a:r>
+            <a:r>
+              <a:rPr sz="2500" b="0">
+                <a:latin typeface="Times New Roman"/>
+              </a:rPr>
+              <a:t>12 yaşında, 7. sınıf, bireysel eğitim alıyor.</a:t>
+            </a:r>
+          </a:p>
+          <a:p>
+            <a:pPr>
+              <a:spcAft>
+                <a:spcPts val="600"/>
+              </a:spcAft>
+            </a:pPr>
+            <a:r>
+              <a:rPr sz="2500" b="1">
+                <a:latin typeface="Times New Roman"/>
+              </a:rPr>
+              <a:t>F: </a:t>
+            </a:r>
+            <a:r>
+              <a:rPr sz="2500" b="0">
+                <a:latin typeface="Times New Roman"/>
+              </a:rPr>
+              <a:t>11 yaşında, 6. sınıf, bireysel ve grup eğitimi alıyor; Asperger sendromu tanısı var.</a:t>
+            </a:r>
+          </a:p>
+          <a:p>
+            <a:pPr>
+              <a:spcAft>
+                <a:spcPts val="600"/>
+              </a:spcAft>
+            </a:pPr>
+            <a:r>
+              <a:rPr sz="2500" b="0">
+                <a:latin typeface="Times New Roman"/>
+              </a:rPr>
+              <a:t>Üçü de RAM değerlendirmesiyle destek eğitim programından yararlanmaktadır; sınıfta yalnızca araştırmacı ve öğrenci bulunmuştur.</a:t>
             </a:r>
           </a:p>
         </p:txBody>
@@ -3980,7 +3986,7 @@
           <a:p>
             <a:fld id="{F302176B-0E47-46AC-8F43-DAB4B8A37D06}" type="slidenum">
               <a:rPr lang="tr-TR" smtClean="0"/>
-              <a:t>12</a:t>
+              <a:t>11</a:t>
             </a:fld>
             <a:endParaRPr lang="tr-TR"/>
           </a:p>
@@ -4023,7 +4029,7 @@
               <a:rPr b="1">
                 <a:latin typeface="Times New Roman"/>
               </a:rPr>
-              <a:t>Dinlediğini Anlama Testi ve Puanlama</a:t>
+              <a:t>Veri Toplama Araçları</a:t>
             </a:r>
           </a:p>
         </p:txBody>
@@ -4051,16 +4057,16 @@
               </a:spcAft>
             </a:pPr>
             <a:r>
-              <a:rPr sz="2000" b="1">
-                <a:latin typeface="Times New Roman"/>
-              </a:rPr>
-              <a:t>Test: </a:t>
-            </a:r>
-            <a:r>
-              <a:rPr sz="2000" b="0">
-                <a:latin typeface="Times New Roman"/>
-              </a:rPr>
-              <a:t>12 ayrı dinlediğini anlama testi geliştirilmiştir (alan yazın, uzman ve öğretmen görüşü alınarak).</a:t>
+              <a:rPr sz="2400" b="1">
+                <a:latin typeface="Times New Roman"/>
+              </a:rPr>
+              <a:t>İşitsel materyal: </a:t>
+            </a:r>
+            <a:r>
+              <a:rPr sz="2400" b="0">
+                <a:latin typeface="Times New Roman"/>
+              </a:rPr>
+              <a:t>MEB onaylı Türkçe ders kitaplarından 1., 2., 3. sınıfa uygun 6 hikâye edici ve 6 bilgilendirici metin (ör. Kuşkucu Horoz, Üç Kelebek, Nasreddin Hoca Şenlikleri).</a:t>
             </a:r>
           </a:p>
           <a:p>
@@ -4070,16 +4076,16 @@
               </a:spcAft>
             </a:pPr>
             <a:r>
-              <a:rPr sz="2000" b="1">
-                <a:latin typeface="Times New Roman"/>
-              </a:rPr>
-              <a:t>Bilgilendirici metin: </a:t>
-            </a:r>
-            <a:r>
-              <a:rPr sz="2000" b="0">
-                <a:latin typeface="Times New Roman"/>
-              </a:rPr>
-              <a:t>5N1K temelinde 8 soru; konu ve ana fikir 20’şer, diğer sorular 10’ar puan.</a:t>
+              <a:rPr sz="2400" b="1">
+                <a:latin typeface="Times New Roman"/>
+              </a:rPr>
+              <a:t>Görsel-işitsel materyal: </a:t>
+            </a:r>
+            <a:r>
+              <a:rPr sz="2400" b="0">
+                <a:latin typeface="Times New Roman"/>
+              </a:rPr>
+              <a:t>Uzman görüşüyle seçilen çizgi filmler (Üçüzler Doktorda, Pak ile Pırpır, Rüya’nın Günlüğü) ve bilgi verici videolar (Bitkilerin Büyümesi, İlkyardım Eğitimi, Kek Nasıl Üretilir?).</a:t>
             </a:r>
           </a:p>
           <a:p>
@@ -4089,42 +4095,10 @@
               </a:spcAft>
             </a:pPr>
             <a:r>
-              <a:rPr sz="2000" b="1">
-                <a:latin typeface="Times New Roman"/>
-              </a:rPr>
-              <a:t>Hikâye edici metin: </a:t>
-            </a:r>
-            <a:r>
-              <a:rPr sz="2000" b="0">
-                <a:latin typeface="Times New Roman"/>
-              </a:rPr>
-              <a:t>hikâye haritasına göre 8 soru; ana fikir 25, sonuç 15, diğer unsurlar 10’ar puan.</a:t>
-            </a:r>
-          </a:p>
-          <a:p>
-            <a:pPr>
-              <a:spcAft>
-                <a:spcPts val="600"/>
-              </a:spcAft>
-            </a:pPr>
-            <a:r>
-              <a:rPr sz="2000" b="0">
-                <a:latin typeface="Times New Roman"/>
-              </a:rPr>
-              <a:t>Sorular basit anlama (6 soru, 60 puan) ve derin anlama (2 soru, 40 puan) olarak ayrılmıştır; toplam 100 puandır.</a:t>
-            </a:r>
-          </a:p>
-          <a:p>
-            <a:pPr>
-              <a:spcAft>
-                <a:spcPts val="600"/>
-              </a:spcAft>
-            </a:pPr>
-            <a:r>
-              <a:rPr sz="2000" b="0">
-                <a:latin typeface="Times New Roman"/>
-              </a:rPr>
-              <a:t>Uygulama Aralık 2013’te her öğrenciyle ayrı ayrı, ders saatinde 2’şer metin/video olmak üzere toplam 6 ders saati yapılmış; önce hikâye edici, sonra bilgi verici materyal sunulmuştur. Cevaplar araştırmacı ve iki uzmanca puanlanmış, bulgular betimsel yorumlanmıştır.</a:t>
+              <a:rPr sz="2400" b="0">
+                <a:latin typeface="Times New Roman"/>
+              </a:rPr>
+              <a:t>Metinler araştırmacı tarafından prozodik özelliklere uygun, bir kez ve tekrarsız okunmuş; videolar bir kez izletilmiştir.</a:t>
             </a:r>
           </a:p>
         </p:txBody>
@@ -4146,7 +4120,7 @@
           <a:p>
             <a:fld id="{F302176B-0E47-46AC-8F43-DAB4B8A37D06}" type="slidenum">
               <a:rPr lang="tr-TR" smtClean="0"/>
-              <a:t>13</a:t>
+              <a:t>12</a:t>
             </a:fld>
             <a:endParaRPr lang="tr-TR"/>
           </a:p>
@@ -4161,6 +4135,172 @@
 </file>
 
 <file path=ppt/slides/slide13.xml><?xml version="1.0" encoding="utf-8"?>
+<p:sld xmlns:a="http://schemas.openxmlformats.org/drawingml/2006/main" xmlns:p="http://schemas.openxmlformats.org/presentationml/2006/main" xmlns:r="http://schemas.openxmlformats.org/officeDocument/2006/relationships">
+  <p:cSld>
+    <p:spTree>
+      <p:nvGrpSpPr>
+        <p:cNvPr id="1" name=""/>
+        <p:cNvGrpSpPr/>
+        <p:nvPr/>
+      </p:nvGrpSpPr>
+      <p:grpSpPr/>
+      <p:sp>
+        <p:nvSpPr>
+          <p:cNvPr id="2" name="Title 1"/>
+          <p:cNvSpPr>
+            <a:spLocks noGrp="1"/>
+          </p:cNvSpPr>
+          <p:nvPr>
+            <p:ph type="title"/>
+          </p:nvPr>
+        </p:nvSpPr>
+        <p:spPr/>
+        <p:txBody>
+          <a:bodyPr/>
+          <a:lstStyle/>
+          <a:p>
+            <a:r>
+              <a:rPr b="1">
+                <a:latin typeface="Times New Roman"/>
+              </a:rPr>
+              <a:t>Dinlediğini Anlama Testi ve Puanlama</a:t>
+            </a:r>
+          </a:p>
+        </p:txBody>
+      </p:sp>
+      <p:sp>
+        <p:nvSpPr>
+          <p:cNvPr id="3" name="Content Placeholder 2"/>
+          <p:cNvSpPr>
+            <a:spLocks noGrp="1"/>
+          </p:cNvSpPr>
+          <p:nvPr>
+            <p:ph idx="1"/>
+          </p:nvPr>
+        </p:nvSpPr>
+        <p:spPr/>
+        <p:txBody>
+          <a:bodyPr wrap="square">
+            <a:noAutofit/>
+          </a:bodyPr>
+          <a:lstStyle/>
+          <a:p>
+            <a:pPr>
+              <a:spcAft>
+                <a:spcPts val="600"/>
+              </a:spcAft>
+            </a:pPr>
+            <a:r>
+              <a:rPr sz="2000" b="1">
+                <a:latin typeface="Times New Roman"/>
+              </a:rPr>
+              <a:t>Test: </a:t>
+            </a:r>
+            <a:r>
+              <a:rPr sz="2000" b="0">
+                <a:latin typeface="Times New Roman"/>
+              </a:rPr>
+              <a:t>12 ayrı dinlediğini anlama testi geliştirilmiştir (alan yazın, uzman ve öğretmen görüşü alınarak).</a:t>
+            </a:r>
+          </a:p>
+          <a:p>
+            <a:pPr>
+              <a:spcAft>
+                <a:spcPts val="600"/>
+              </a:spcAft>
+            </a:pPr>
+            <a:r>
+              <a:rPr sz="2000" b="1">
+                <a:latin typeface="Times New Roman"/>
+              </a:rPr>
+              <a:t>Bilgilendirici metin: </a:t>
+            </a:r>
+            <a:r>
+              <a:rPr sz="2000" b="0">
+                <a:latin typeface="Times New Roman"/>
+              </a:rPr>
+              <a:t>5N1K temelinde 8 soru; konu ve ana fikir 20’şer, diğer sorular 10’ar puan.</a:t>
+            </a:r>
+          </a:p>
+          <a:p>
+            <a:pPr>
+              <a:spcAft>
+                <a:spcPts val="600"/>
+              </a:spcAft>
+            </a:pPr>
+            <a:r>
+              <a:rPr sz="2000" b="1">
+                <a:latin typeface="Times New Roman"/>
+              </a:rPr>
+              <a:t>Hikâye edici metin: </a:t>
+            </a:r>
+            <a:r>
+              <a:rPr sz="2000" b="0">
+                <a:latin typeface="Times New Roman"/>
+              </a:rPr>
+              <a:t>hikâye haritasına göre 8 soru; ana fikir 25, sonuç 15, diğer unsurlar 10’ar puan.</a:t>
+            </a:r>
+          </a:p>
+          <a:p>
+            <a:pPr>
+              <a:spcAft>
+                <a:spcPts val="600"/>
+              </a:spcAft>
+            </a:pPr>
+            <a:r>
+              <a:rPr sz="2000" b="0">
+                <a:latin typeface="Times New Roman"/>
+              </a:rPr>
+              <a:t>Sorular basit anlama (6 soru, 60 puan) ve derin anlama (2 soru, 40 puan) olarak ayrılmıştır; toplam 100 puandır.</a:t>
+            </a:r>
+          </a:p>
+          <a:p>
+            <a:pPr>
+              <a:spcAft>
+                <a:spcPts val="600"/>
+              </a:spcAft>
+            </a:pPr>
+            <a:r>
+              <a:rPr sz="2000" b="0">
+                <a:latin typeface="Times New Roman"/>
+              </a:rPr>
+              <a:t>Uygulama Aralık 2013’te her öğrenciyle ayrı ayrı, ders saatinde 2’şer metin/video olmak üzere toplam 6 ders saati yapılmış; önce hikâye edici, sonra bilgi verici materyal sunulmuştur. Cevaplar araştırmacı ve iki uzmanca puanlanmış, bulgular betimsel yorumlanmıştır.</a:t>
+            </a:r>
+          </a:p>
+        </p:txBody>
+      </p:sp>
+      <p:sp>
+        <p:nvSpPr>
+          <p:cNvPr id="6" name="Slide Number Placeholder 5"/>
+          <p:cNvSpPr>
+            <a:spLocks noGrp="1"/>
+          </p:cNvSpPr>
+          <p:nvPr>
+            <p:ph type="sldNum" sz="quarter" idx="12"/>
+          </p:nvPr>
+        </p:nvSpPr>
+        <p:spPr/>
+        <p:txBody>
+          <a:bodyPr/>
+          <a:lstStyle/>
+          <a:p>
+            <a:fld id="{F302176B-0E47-46AC-8F43-DAB4B8A37D06}" type="slidenum">
+              <a:rPr lang="tr-TR" smtClean="0"/>
+              <a:t>13</a:t>
+            </a:fld>
+            <a:endParaRPr lang="tr-TR"/>
+          </a:p>
+        </p:txBody>
+      </p:sp>
+    </p:spTree>
+  </p:cSld>
+  <p:clrMapOvr>
+    <a:masterClrMapping/>
+  </p:clrMapOvr>
+</p:sld>
+</file>
+
+<file path=ppt/slides/slide14.xml><?xml version="1.0" encoding="utf-8"?>
 <p:sld xmlns:a="http://schemas.openxmlformats.org/drawingml/2006/main" xmlns:p="http://schemas.openxmlformats.org/presentationml/2006/main" xmlns:r="http://schemas.openxmlformats.org/officeDocument/2006/relationships">
   <p:cSld>
     <p:spTree>
@@ -4686,153 +4826,6 @@
 </p:sld>
 </file>
 
-<file path=ppt/slides/slide14.xml><?xml version="1.0" encoding="utf-8"?>
-<p:sld xmlns:a="http://schemas.openxmlformats.org/drawingml/2006/main" xmlns:p="http://schemas.openxmlformats.org/presentationml/2006/main" xmlns:r="http://schemas.openxmlformats.org/officeDocument/2006/relationships">
-  <p:cSld>
-    <p:spTree>
-      <p:nvGrpSpPr>
-        <p:cNvPr id="1" name=""/>
-        <p:cNvGrpSpPr/>
-        <p:nvPr/>
-      </p:nvGrpSpPr>
-      <p:grpSpPr/>
-      <p:sp>
-        <p:nvSpPr>
-          <p:cNvPr id="2" name="Title 1"/>
-          <p:cNvSpPr>
-            <a:spLocks noGrp="1"/>
-          </p:cNvSpPr>
-          <p:nvPr>
-            <p:ph type="title"/>
-          </p:nvPr>
-        </p:nvSpPr>
-        <p:spPr/>
-        <p:txBody>
-          <a:bodyPr/>
-          <a:lstStyle/>
-          <a:p>
-            <a:r>
-              <a:rPr b="1">
-                <a:latin typeface="Times New Roman"/>
-              </a:rPr>
-              <a:t>Bulgular: İşitsel Materyal</a:t>
-            </a:r>
-          </a:p>
-        </p:txBody>
-      </p:sp>
-      <p:sp>
-        <p:nvSpPr>
-          <p:cNvPr id="3" name="Content Placeholder 2"/>
-          <p:cNvSpPr>
-            <a:spLocks noGrp="1"/>
-          </p:cNvSpPr>
-          <p:nvPr>
-            <p:ph idx="1"/>
-          </p:nvPr>
-        </p:nvSpPr>
-        <p:spPr/>
-        <p:txBody>
-          <a:bodyPr wrap="square">
-            <a:noAutofit/>
-          </a:bodyPr>
-          <a:lstStyle/>
-          <a:p>
-            <a:pPr>
-              <a:spcAft>
-                <a:spcPts val="600"/>
-              </a:spcAft>
-            </a:pPr>
-            <a:r>
-              <a:rPr sz="2500" b="1">
-                <a:latin typeface="Times New Roman"/>
-              </a:rPr>
-              <a:t>Hikâye edici metin: </a:t>
-            </a:r>
-            <a:r>
-              <a:rPr sz="2500" b="0">
-                <a:latin typeface="Times New Roman"/>
-              </a:rPr>
-              <a:t>G, B, F için 41,3 / 46,3 / 5,3. Sınıf düzeyi arttıkça başarı düşmüştür (ortalama 38,3 → 31,0 → 23,7).</a:t>
-            </a:r>
-          </a:p>
-          <a:p>
-            <a:pPr>
-              <a:spcAft>
-                <a:spcPts val="600"/>
-              </a:spcAft>
-            </a:pPr>
-            <a:r>
-              <a:rPr sz="2500" b="1">
-                <a:latin typeface="Times New Roman"/>
-              </a:rPr>
-              <a:t>Bilgi verici metin: </a:t>
-            </a:r>
-            <a:r>
-              <a:rPr sz="2500" b="0">
-                <a:latin typeface="Times New Roman"/>
-              </a:rPr>
-              <a:t>G, B, F için 7,7 / 19,3 / 0. Tüm sınıf düzeylerinde anlama başarısı düşüktür.</a:t>
-            </a:r>
-          </a:p>
-          <a:p>
-            <a:pPr>
-              <a:spcAft>
-                <a:spcPts val="600"/>
-              </a:spcAft>
-            </a:pPr>
-            <a:r>
-              <a:rPr sz="2500" b="0">
-                <a:latin typeface="Times New Roman"/>
-              </a:rPr>
-              <a:t>F’nin çok düşük puanları Asperger sendromunun sosyal etkileşim ve iletişim güçlüğüyle ilişkilendirilmiştir.</a:t>
-            </a:r>
-          </a:p>
-          <a:p>
-            <a:pPr>
-              <a:spcAft>
-                <a:spcPts val="600"/>
-              </a:spcAft>
-            </a:pPr>
-            <a:r>
-              <a:rPr sz="2500" b="0">
-                <a:latin typeface="Times New Roman"/>
-              </a:rPr>
-              <a:t>G’nin 3. sınıf bilgi verici metinde puanının artması metnin ilgi alanına girmesine bağlanmıştır.</a:t>
-            </a:r>
-          </a:p>
-        </p:txBody>
-      </p:sp>
-      <p:sp>
-        <p:nvSpPr>
-          <p:cNvPr id="6" name="Slide Number Placeholder 5"/>
-          <p:cNvSpPr>
-            <a:spLocks noGrp="1"/>
-          </p:cNvSpPr>
-          <p:nvPr>
-            <p:ph type="sldNum" sz="quarter" idx="12"/>
-          </p:nvPr>
-        </p:nvSpPr>
-        <p:spPr/>
-        <p:txBody>
-          <a:bodyPr/>
-          <a:lstStyle/>
-          <a:p>
-            <a:fld id="{F302176B-0E47-46AC-8F43-DAB4B8A37D06}" type="slidenum">
-              <a:rPr lang="tr-TR" smtClean="0"/>
-              <a:t>15</a:t>
-            </a:fld>
-            <a:endParaRPr lang="tr-TR"/>
-          </a:p>
-        </p:txBody>
-      </p:sp>
-    </p:spTree>
-  </p:cSld>
-  <p:clrMapOvr>
-    <a:masterClrMapping/>
-  </p:clrMapOvr>
-</p:sld>
-</file>
-
 <file path=ppt/slides/slide15.xml><?xml version="1.0" encoding="utf-8"?>
 <p:sld xmlns:a="http://schemas.openxmlformats.org/drawingml/2006/main" xmlns:p="http://schemas.openxmlformats.org/presentationml/2006/main" xmlns:r="http://schemas.openxmlformats.org/officeDocument/2006/relationships">
   <p:cSld>
@@ -4862,7 +4855,7 @@
               <a:rPr b="1">
                 <a:latin typeface="Times New Roman"/>
               </a:rPr>
-              <a:t>Bulgular: Görsel-İşitsel Materyal</a:t>
+              <a:t>Bulgular: İşitsel Materyal</a:t>
             </a:r>
           </a:p>
         </p:txBody>
@@ -4890,16 +4883,16 @@
               </a:spcAft>
             </a:pPr>
             <a:r>
-              <a:rPr sz="2000" b="1">
+              <a:rPr sz="2500" b="1">
                 <a:latin typeface="Times New Roman"/>
               </a:rPr>
               <a:t>Hikâye edici metin: </a:t>
             </a:r>
             <a:r>
-              <a:rPr sz="2000" b="0">
-                <a:latin typeface="Times New Roman"/>
-              </a:rPr>
-              <a:t>G, B, F için 65,7 / 60,7 / 19,7; sınıf düzeyi yükseldikçe ortalama 61,3 → 48 → 36,7’ye düşmüştür.</a:t>
+              <a:rPr sz="2500" b="0">
+                <a:latin typeface="Times New Roman"/>
+              </a:rPr>
+              <a:t>G, B, F için 41,3 / 46,3 / 5,3. Sınıf düzeyi arttıkça başarı düşmüştür (ortalama 38,3 → 31,0 → 23,7).</a:t>
             </a:r>
           </a:p>
           <a:p>
@@ -4909,16 +4902,16 @@
               </a:spcAft>
             </a:pPr>
             <a:r>
-              <a:rPr sz="2000" b="1">
+              <a:rPr sz="2500" b="1">
                 <a:latin typeface="Times New Roman"/>
               </a:rPr>
               <a:t>Bilgi verici metin: </a:t>
             </a:r>
             <a:r>
-              <a:rPr sz="2000" b="0">
-                <a:latin typeface="Times New Roman"/>
-              </a:rPr>
-              <a:t>G, B, F için 41 / 50,3 / 10; ortalama 43,3 → 34,7 → 23,3.</a:t>
+              <a:rPr sz="2500" b="0">
+                <a:latin typeface="Times New Roman"/>
+              </a:rPr>
+              <a:t>G, B, F için 7,7 / 19,3 / 0. Tüm sınıf düzeylerinde anlama başarısı düşüktür.</a:t>
             </a:r>
           </a:p>
           <a:p>
@@ -4928,16 +4921,10 @@
               </a:spcAft>
             </a:pPr>
             <a:r>
-              <a:rPr sz="2000" b="1">
-                <a:latin typeface="Times New Roman"/>
-              </a:rPr>
-              <a:t>Karşılaştırma: </a:t>
-            </a:r>
-            <a:r>
-              <a:rPr sz="2000" b="0">
-                <a:latin typeface="Times New Roman"/>
-              </a:rPr>
-              <a:t>Her iki metin türünde basit ve derin anlama çoğunlukla görsel-işitsel materyalle daha yüksektir; tek istisna B’nin hikâye metnindeki basit anlamasıdır (37,3 → 35,6).</a:t>
+              <a:rPr sz="2500" b="0">
+                <a:latin typeface="Times New Roman"/>
+              </a:rPr>
+              <a:t>F’nin çok düşük puanları Asperger sendromunun sosyal etkileşim ve iletişim güçlüğüyle ilişkilendirilmiştir.</a:t>
             </a:r>
           </a:p>
           <a:p>
@@ -4947,10 +4934,10 @@
               </a:spcAft>
             </a:pPr>
             <a:r>
-              <a:rPr sz="2000" b="0">
-                <a:latin typeface="Times New Roman"/>
-              </a:rPr>
-              <a:t>Derin anlama sorularında başarı düşük kalmış; F işitsel koşulda derin anlamada hiç puan alamamıştır.</a:t>
+              <a:rPr sz="2500" b="0">
+                <a:latin typeface="Times New Roman"/>
+              </a:rPr>
+              <a:t>G’nin 3. sınıf bilgi verici metinde puanının artması metnin ilgi alanına girmesine bağlanmıştır.</a:t>
             </a:r>
           </a:p>
         </p:txBody>
@@ -4972,7 +4959,7 @@
           <a:p>
             <a:fld id="{F302176B-0E47-46AC-8F43-DAB4B8A37D06}" type="slidenum">
               <a:rPr lang="tr-TR" smtClean="0"/>
-              <a:t>16</a:t>
+              <a:t>15</a:t>
             </a:fld>
             <a:endParaRPr lang="tr-TR"/>
           </a:p>
@@ -5015,7 +5002,7 @@
               <a:rPr b="1">
                 <a:latin typeface="Times New Roman"/>
               </a:rPr>
-              <a:t>Sonuç ve Tartışma (1)</a:t>
+              <a:t>Bulgular: Görsel-İşitsel Materyal</a:t>
             </a:r>
           </a:p>
         </p:txBody>
@@ -5043,10 +5030,16 @@
               </a:spcAft>
             </a:pPr>
             <a:r>
-              <a:rPr sz="2500" b="0">
-                <a:latin typeface="Times New Roman"/>
-              </a:rPr>
-              <a:t>Yalnız işitsel materyalle hikâye edici metinde anlama normal düzeydedir (G 41,3; B 46,3; F 5,3); bilgi verici metinde ise düşüktür (7,7 / 19,3 / 0).</a:t>
+              <a:rPr sz="2000" b="1">
+                <a:latin typeface="Times New Roman"/>
+              </a:rPr>
+              <a:t>Hikâye edici metin: </a:t>
+            </a:r>
+            <a:r>
+              <a:rPr sz="2000" b="0">
+                <a:latin typeface="Times New Roman"/>
+              </a:rPr>
+              <a:t>G, B, F için 65,7 / 60,7 / 19,7; sınıf düzeyi yükseldikçe ortalama 61,3 → 48 → 36,7’ye düşmüştür.</a:t>
             </a:r>
           </a:p>
           <a:p>
@@ -5056,10 +5049,16 @@
               </a:spcAft>
             </a:pPr>
             <a:r>
-              <a:rPr sz="2500" b="0">
-                <a:latin typeface="Times New Roman"/>
-              </a:rPr>
-              <a:t>Bulgu, hikâye edici türün anlaşılması ve hatırlanmasının kolaylığıyla (Graesser vd., 1991) ve bilgi vermeye dayalı metinlerin daha zor olduğu görüşüyle (Akyol, 2013) paralellik gösterir.</a:t>
+              <a:rPr sz="2000" b="1">
+                <a:latin typeface="Times New Roman"/>
+              </a:rPr>
+              <a:t>Bilgi verici metin: </a:t>
+            </a:r>
+            <a:r>
+              <a:rPr sz="2000" b="0">
+                <a:latin typeface="Times New Roman"/>
+              </a:rPr>
+              <a:t>G, B, F için 41 / 50,3 / 10; ortalama 43,3 → 34,7 → 23,3.</a:t>
             </a:r>
           </a:p>
           <a:p>
@@ -5069,10 +5068,29 @@
               </a:spcAft>
             </a:pPr>
             <a:r>
-              <a:rPr sz="2500" b="0">
-                <a:latin typeface="Times New Roman"/>
-              </a:rPr>
-              <a:t>İşitsel materyalin tek başına kullanılması anlama başarısını potansiyelin altında tutmaktadır; insanlar anlatılanların yalnızca %5-20’sini hatırlayabilmektedir (Açıkgöz, 2006).</a:t>
+              <a:rPr sz="2000" b="1">
+                <a:latin typeface="Times New Roman"/>
+              </a:rPr>
+              <a:t>Karşılaştırma: </a:t>
+            </a:r>
+            <a:r>
+              <a:rPr sz="2000" b="0">
+                <a:latin typeface="Times New Roman"/>
+              </a:rPr>
+              <a:t>Her iki metin türünde basit ve derin anlama çoğunlukla görsel-işitsel materyalle daha yüksektir; tek istisna B’nin hikâye metnindeki basit anlamasıdır (37,3 → 35,6).</a:t>
+            </a:r>
+          </a:p>
+          <a:p>
+            <a:pPr>
+              <a:spcAft>
+                <a:spcPts val="600"/>
+              </a:spcAft>
+            </a:pPr>
+            <a:r>
+              <a:rPr sz="2000" b="0">
+                <a:latin typeface="Times New Roman"/>
+              </a:rPr>
+              <a:t>Derin anlama sorularında başarı düşük kalmış; F işitsel koşulda derin anlamada hiç puan alamamıştır.</a:t>
             </a:r>
           </a:p>
         </p:txBody>
@@ -5094,7 +5112,7 @@
           <a:p>
             <a:fld id="{F302176B-0E47-46AC-8F43-DAB4B8A37D06}" type="slidenum">
               <a:rPr lang="tr-TR" smtClean="0"/>
-              <a:t>17</a:t>
+              <a:t>16</a:t>
             </a:fld>
             <a:endParaRPr lang="tr-TR"/>
           </a:p>
@@ -5137,7 +5155,7 @@
               <a:rPr b="1">
                 <a:latin typeface="Times New Roman"/>
               </a:rPr>
-              <a:t>Sonuç ve Tartışma (2)</a:t>
+              <a:t>Sonuç ve Tartışma (1)</a:t>
             </a:r>
           </a:p>
         </p:txBody>
@@ -5168,7 +5186,7 @@
               <a:rPr sz="2500" b="0">
                 <a:latin typeface="Times New Roman"/>
               </a:rPr>
-              <a:t>Hikâye edici metni görsel-işitsel materyalle dinlediklerinde anlama düzeyleri normaldir (65,7 / 60,7 / 19,7); bilgi verici metinde 41 / 50,3 / 10’dur.</a:t>
+              <a:t>Yalnız işitsel materyalle hikâye edici metinde anlama normal düzeydedir (G 41,3; B 46,3; F 5,3); bilgi verici metinde ise düşüktür (7,7 / 19,3 / 0).</a:t>
             </a:r>
           </a:p>
           <a:p>
@@ -5181,7 +5199,7 @@
               <a:rPr sz="2500" b="0">
                 <a:latin typeface="Times New Roman"/>
               </a:rPr>
-              <a:t>Görsel ve işitsel materyalin birlikte kullanılması, yalnız işitsel kullanıma göre anlama düzeyini artırmıştır (Ergin, 1998; Sönmez, 2005; Türkyılmaz, 2010; Winn, 1988).</a:t>
+              <a:t>Bulgu, hikâye edici türün anlaşılması ve hatırlanmasının kolaylığıyla (Graesser vd., 1991) ve bilgi vermeye dayalı metinlerin daha zor olduğu görüşüyle (Akyol, 2013) paralellik gösterir.</a:t>
             </a:r>
           </a:p>
           <a:p>
@@ -5194,20 +5212,7 @@
               <a:rPr sz="2500" b="0">
                 <a:latin typeface="Times New Roman"/>
               </a:rPr>
-              <a:t>Hikâye edici metinlerde anlama başarısı bilgilendirici metne göre daha yüksektir; bu bulgu işitsel ve görsel-işitsel koşulda aynıdır.</a:t>
-            </a:r>
-          </a:p>
-          <a:p>
-            <a:pPr>
-              <a:spcAft>
-                <a:spcPts val="600"/>
-              </a:spcAft>
-            </a:pPr>
-            <a:r>
-              <a:rPr sz="2500" b="0">
-                <a:latin typeface="Times New Roman"/>
-              </a:rPr>
-              <a:t>Sınıf düzeyi yükseldikçe anlama başarısı düşmüştür.</a:t>
+              <a:t>İşitsel materyalin tek başına kullanılması anlama başarısını potansiyelin altında tutmaktadır; insanlar anlatılanların yalnızca %5-20’sini hatırlayabilmektedir (Açıkgöz, 2006).</a:t>
             </a:r>
           </a:p>
         </p:txBody>
@@ -5229,7 +5234,7 @@
           <a:p>
             <a:fld id="{F302176B-0E47-46AC-8F43-DAB4B8A37D06}" type="slidenum">
               <a:rPr lang="tr-TR" smtClean="0"/>
-              <a:t>18</a:t>
+              <a:t>17</a:t>
             </a:fld>
             <a:endParaRPr lang="tr-TR"/>
           </a:p>
@@ -5272,7 +5277,7 @@
               <a:rPr b="1">
                 <a:latin typeface="Times New Roman"/>
               </a:rPr>
-              <a:t>Öneriler</a:t>
+              <a:t>Sonuç ve Tartışma (2)</a:t>
             </a:r>
           </a:p>
         </p:txBody>
@@ -5300,10 +5305,10 @@
               </a:spcAft>
             </a:pPr>
             <a:r>
-              <a:rPr sz="1900" b="0">
-                <a:latin typeface="Times New Roman"/>
-              </a:rPr>
-              <a:t>Dinleme anlama çalışmalarında ortam, öğrencinin dikkatini dağıtmayacak şekilde düzenlenmeli ve öğrencinin tam katılımı sağlanmalıdır.</a:t>
+              <a:rPr sz="2500" b="0">
+                <a:latin typeface="Times New Roman"/>
+              </a:rPr>
+              <a:t>Hikâye edici metni görsel-işitsel materyalle dinlediklerinde anlama düzeyleri normaldir (65,7 / 60,7 / 19,7); bilgi verici metinde 41 / 50,3 / 10’dur.</a:t>
             </a:r>
           </a:p>
           <a:p>
@@ -5313,10 +5318,10 @@
               </a:spcAft>
             </a:pPr>
             <a:r>
-              <a:rPr sz="1900" b="0">
-                <a:latin typeface="Times New Roman"/>
-              </a:rPr>
-              <a:t>Hikâye edici ve bilgi verici metin öğretiminde görsel-işitsel materyal kullanılmalıdır.</a:t>
+              <a:rPr sz="2500" b="0">
+                <a:latin typeface="Times New Roman"/>
+              </a:rPr>
+              <a:t>Görsel ve işitsel materyalin birlikte kullanılması, yalnız işitsel kullanıma göre anlama düzeyini artırmıştır (Ergin, 1998; Sönmez, 2005; Türkyılmaz, 2010; Winn, 1988).</a:t>
             </a:r>
           </a:p>
           <a:p>
@@ -5326,10 +5331,10 @@
               </a:spcAft>
             </a:pPr>
             <a:r>
-              <a:rPr sz="1900" b="0">
-                <a:latin typeface="Times New Roman"/>
-              </a:rPr>
-              <a:t>Kaynaştırma ortamındaki öğrencilerin anlama düzeyleri, akranlarla birlikte değil kendi düzeylerine uygun ölçme ve değerlendirmeyle belirlenmelidir.</a:t>
+              <a:rPr sz="2500" b="0">
+                <a:latin typeface="Times New Roman"/>
+              </a:rPr>
+              <a:t>Hikâye edici metinlerde anlama başarısı bilgilendirici metne göre daha yüksektir; bu bulgu işitsel ve görsel-işitsel koşulda aynıdır.</a:t>
             </a:r>
           </a:p>
           <a:p>
@@ -5339,23 +5344,10 @@
               </a:spcAft>
             </a:pPr>
             <a:r>
-              <a:rPr sz="1900" b="0">
-                <a:latin typeface="Times New Roman"/>
-              </a:rPr>
-              <a:t>Metinler öğrencinin gelişim düzeyine uygun seçilmeli; dinleme becerisi sınıf ve özel eğitim öğretmeninin iş birliğiyle geliştirilmelidir.</a:t>
-            </a:r>
-          </a:p>
-          <a:p>
-            <a:pPr>
-              <a:spcAft>
-                <a:spcPts val="600"/>
-              </a:spcAft>
-            </a:pPr>
-            <a:r>
-              <a:rPr sz="1900" b="0">
-                <a:latin typeface="Times New Roman"/>
-              </a:rPr>
-              <a:t>Benzer çalışmalar farklı yaş gruplarında yapılıp karşılaştırılabilir.</a:t>
+              <a:rPr sz="2500" b="0">
+                <a:latin typeface="Times New Roman"/>
+              </a:rPr>
+              <a:t>Sınıf düzeyi yükseldikçe anlama başarısı düşmüştür.</a:t>
             </a:r>
           </a:p>
         </p:txBody>
@@ -5377,7 +5369,7 @@
           <a:p>
             <a:fld id="{F302176B-0E47-46AC-8F43-DAB4B8A37D06}" type="slidenum">
               <a:rPr lang="tr-TR" smtClean="0"/>
-              <a:t>19</a:t>
+              <a:t>18</a:t>
             </a:fld>
             <a:endParaRPr lang="tr-TR"/>
           </a:p>
@@ -5420,7 +5412,7 @@
               <a:rPr b="1">
                 <a:latin typeface="Times New Roman"/>
               </a:rPr>
-              <a:t>Kaynakça (1/4)</a:t>
+              <a:t>Öneriler</a:t>
             </a:r>
           </a:p>
         </p:txBody>
@@ -5442,157 +5434,68 @@
           </a:bodyPr>
           <a:lstStyle/>
           <a:p>
-            <a:pPr marL="228600" indent="-228600">
-              <a:spcAft>
-                <a:spcPts val="500"/>
-              </a:spcAft>
-              <a:buNone/>
-            </a:pPr>
-            <a:r>
-              <a:rPr sz="1300" b="0">
-                <a:latin typeface="Times New Roman"/>
-              </a:rPr>
-              <a:t>AAMR, (2002). Mental Retardation: Definition, Classification, and Systems of Supports (10. Baskı). Washington DC: AAMR</a:t>
-            </a:r>
-          </a:p>
-          <a:p>
-            <a:pPr marL="228600" indent="-228600">
-              <a:spcAft>
-                <a:spcPts val="500"/>
-              </a:spcAft>
-              <a:buNone/>
-            </a:pPr>
-            <a:r>
-              <a:rPr sz="1300" b="0">
-                <a:latin typeface="Times New Roman"/>
-              </a:rPr>
-              <a:t>Akyol, H. (1999). Hikâye Haritası Yöntemiyle Metin Öğretimi. Milli Eğitim, 142. (Online): Web: http://yayim.meb.gov.tr/dergiler/medergi/15.htm (Erişim Tarihi: 13.11.2013)</a:t>
-            </a:r>
-          </a:p>
-          <a:p>
-            <a:pPr marL="228600" indent="-228600">
-              <a:spcAft>
-                <a:spcPts val="500"/>
-              </a:spcAft>
-              <a:buNone/>
-            </a:pPr>
-            <a:r>
-              <a:rPr sz="1300" b="0">
-                <a:latin typeface="Times New Roman"/>
-              </a:rPr>
-              <a:t>American Psychiatric Association. (2000). "Diagnostic criteria for 299.80 Asperger's Disorder (AD)". Diagnostic and Statistical Manual of Mental Disorders (4th ed., text revision bas.). ISBN 0-89042-025-4. (Erişim Tarihi: 17.09.2013)</a:t>
-            </a:r>
-          </a:p>
-          <a:p>
-            <a:pPr marL="228600" indent="-228600">
-              <a:spcAft>
-                <a:spcPts val="500"/>
-              </a:spcAft>
-              <a:buNone/>
-            </a:pPr>
-            <a:r>
-              <a:rPr sz="1300" b="0">
-                <a:latin typeface="Times New Roman"/>
-              </a:rPr>
-              <a:t>Baskin, J. H., Sperber, M.&amp;Price B. H. (2006). "Asperger Syndrome Revisited". Rev Neurol Dis 3 (1): 1–7.</a:t>
-            </a:r>
-          </a:p>
-          <a:p>
-            <a:pPr marL="228600" indent="-228600">
-              <a:spcAft>
-                <a:spcPts val="500"/>
-              </a:spcAft>
-              <a:buNone/>
-            </a:pPr>
-            <a:r>
-              <a:rPr sz="1300" b="0">
-                <a:latin typeface="Times New Roman"/>
-              </a:rPr>
-              <a:t>Başal, M. ve Batu, S. (2002). Zihin Özürlü Öğrencilere Okuma Yazma Öğretme Konusunda Alt Özel Sınıf Öğretmenlerinin Görüş ve Önerileri. Özel Eğitim Dergisi, 3(2), 85-98</a:t>
-            </a:r>
-          </a:p>
-          <a:p>
-            <a:pPr marL="228600" indent="-228600">
-              <a:spcAft>
-                <a:spcPts val="500"/>
-              </a:spcAft>
-              <a:buNone/>
-            </a:pPr>
-            <a:r>
-              <a:rPr sz="1300" b="0">
-                <a:latin typeface="Times New Roman"/>
-              </a:rPr>
-              <a:t>Bıyıklı, L. (1997). Özel Eğitim Gereksinimi Duyan Çocuklar. Milli Eğitim Sanat-Kültür Dergisi. Sayı: 136, s. 31-32</a:t>
-            </a:r>
-          </a:p>
-          <a:p>
-            <a:pPr marL="228600" indent="-228600">
-              <a:spcAft>
-                <a:spcPts val="500"/>
-              </a:spcAft>
-              <a:buNone/>
-            </a:pPr>
-            <a:r>
-              <a:rPr sz="1300" b="0">
-                <a:latin typeface="Times New Roman"/>
-              </a:rPr>
-              <a:t>Brent, R.&amp;Anderson, P. (1993). Devoloping Children`s Classroom Listening Strategies. Reading Teacher, 47, (2), pp. 122-126</a:t>
-            </a:r>
-          </a:p>
-          <a:p>
-            <a:pPr marL="228600" indent="-228600">
-              <a:spcAft>
-                <a:spcPts val="500"/>
-              </a:spcAft>
-              <a:buNone/>
-            </a:pPr>
-            <a:r>
-              <a:rPr sz="1300" b="0">
-                <a:latin typeface="Times New Roman"/>
-              </a:rPr>
-              <a:t>Chenfeld, M. B. (1978). Teaching Language Arts Creatively. Harcourt Brace Jovanovich Publishers. San Diego.</a:t>
-            </a:r>
-          </a:p>
-          <a:p>
-            <a:pPr marL="228600" indent="-228600">
-              <a:spcAft>
-                <a:spcPts val="500"/>
-              </a:spcAft>
-              <a:buNone/>
-            </a:pPr>
-            <a:r>
-              <a:rPr sz="1300" b="0">
-                <a:latin typeface="Times New Roman"/>
-              </a:rPr>
-              <a:t>Creswell, J. W. (2007). Qualitative Inquiry and Research Design: Choosing Among Five Traditions (Second Edition). London: Sage Publication</a:t>
-            </a:r>
-          </a:p>
-          <a:p>
-            <a:pPr marL="228600" indent="-228600">
-              <a:spcAft>
-                <a:spcPts val="500"/>
-              </a:spcAft>
-              <a:buNone/>
-            </a:pPr>
-            <a:r>
-              <a:rPr sz="1300" b="0">
-                <a:latin typeface="Times New Roman"/>
-              </a:rPr>
-              <a:t>Doğan, Y.(2012). Dinleme Eğitimi. Pegem Akademi. Ankara</a:t>
-            </a:r>
-          </a:p>
-          <a:p>
-            <a:pPr marL="228600" indent="-228600">
-              <a:spcAft>
-                <a:spcPts val="500"/>
-              </a:spcAft>
-              <a:buNone/>
-            </a:pPr>
-            <a:r>
-              <a:rPr sz="1300" b="0">
-                <a:latin typeface="Times New Roman"/>
-              </a:rPr>
-              <a:t>Ergin, A. ve BİROL, C. (2000). Eğitimde İletişim. Ankara: Anı Yayıncılık</a:t>
+            <a:pPr>
+              <a:spcAft>
+                <a:spcPts val="600"/>
+              </a:spcAft>
+            </a:pPr>
+            <a:r>
+              <a:rPr sz="1900" b="0">
+                <a:latin typeface="Times New Roman"/>
+              </a:rPr>
+              <a:t>Dinleme anlama çalışmalarında ortam, öğrencinin dikkatini dağıtmayacak şekilde düzenlenmeli ve öğrencinin tam katılımı sağlanmalıdır.</a:t>
+            </a:r>
+          </a:p>
+          <a:p>
+            <a:pPr>
+              <a:spcAft>
+                <a:spcPts val="600"/>
+              </a:spcAft>
+            </a:pPr>
+            <a:r>
+              <a:rPr sz="1900" b="0">
+                <a:latin typeface="Times New Roman"/>
+              </a:rPr>
+              <a:t>Hikâye edici ve bilgi verici metin öğretiminde görsel-işitsel materyal kullanılmalıdır.</a:t>
+            </a:r>
+          </a:p>
+          <a:p>
+            <a:pPr>
+              <a:spcAft>
+                <a:spcPts val="600"/>
+              </a:spcAft>
+            </a:pPr>
+            <a:r>
+              <a:rPr sz="1900" b="0">
+                <a:latin typeface="Times New Roman"/>
+              </a:rPr>
+              <a:t>Kaynaştırma ortamındaki öğrencilerin anlama düzeyleri, akranlarla birlikte değil kendi düzeylerine uygun ölçme ve değerlendirmeyle belirlenmelidir.</a:t>
+            </a:r>
+          </a:p>
+          <a:p>
+            <a:pPr>
+              <a:spcAft>
+                <a:spcPts val="600"/>
+              </a:spcAft>
+            </a:pPr>
+            <a:r>
+              <a:rPr sz="1900" b="0">
+                <a:latin typeface="Times New Roman"/>
+              </a:rPr>
+              <a:t>Metinler öğrencinin gelişim düzeyine uygun seçilmeli; dinleme becerisi sınıf ve özel eğitim öğretmeninin iş birliğiyle geliştirilmelidir.</a:t>
+            </a:r>
+          </a:p>
+          <a:p>
+            <a:pPr>
+              <a:spcAft>
+                <a:spcPts val="600"/>
+              </a:spcAft>
+            </a:pPr>
+            <a:r>
+              <a:rPr sz="1900" b="0">
+                <a:latin typeface="Times New Roman"/>
+              </a:rPr>
+              <a:t>Benzer çalışmalar farklı yaş gruplarında yapılıp karşılaştırılabilir.</a:t>
             </a:r>
           </a:p>
         </p:txBody>
@@ -5614,7 +5517,7 @@
           <a:p>
             <a:fld id="{F302176B-0E47-46AC-8F43-DAB4B8A37D06}" type="slidenum">
               <a:rPr lang="tr-TR" smtClean="0"/>
-              <a:t>20</a:t>
+              <a:t>19</a:t>
             </a:fld>
             <a:endParaRPr lang="tr-TR"/>
           </a:p>
@@ -5657,7 +5560,7 @@
               <a:rPr b="1">
                 <a:latin typeface="Times New Roman"/>
               </a:rPr>
-              <a:t>Öz</a:t>
+              <a:t>Sunanlar</a:t>
             </a:r>
           </a:p>
         </p:txBody>
@@ -5685,10 +5588,10 @@
               </a:spcAft>
             </a:pPr>
             <a:r>
-              <a:rPr sz="2500" b="0">
-                <a:latin typeface="Times New Roman"/>
-              </a:rPr>
-              <a:t>Amaç: Hafif düzeyde zihinsel yetersizliği olan kaynaştırma öğrencilerinin hikâye ve bilgilendirici metinleri işitsel ya da görsel-işitsel materyalle dinlediklerinde anlama düzeylerini ölçmek.</a:t>
+              <a:rPr sz="2700" b="0">
+                <a:latin typeface="Times New Roman"/>
+              </a:rPr>
+              <a:t>Feyza BÜYÜKBEKTAŞ</a:t>
             </a:r>
           </a:p>
           <a:p>
@@ -5698,10 +5601,10 @@
               </a:spcAft>
             </a:pPr>
             <a:r>
-              <a:rPr sz="2500" b="0">
-                <a:latin typeface="Times New Roman"/>
-              </a:rPr>
-              <a:t>Katılımcılar: Farklı okullara devam eden, zekâ bölümü 50-70 arasında üç öğrenci.</a:t>
+              <a:rPr sz="2700" b="0">
+                <a:latin typeface="Times New Roman"/>
+              </a:rPr>
+              <a:t>Çiğdem TURAN</a:t>
             </a:r>
           </a:p>
           <a:p>
@@ -5711,10 +5614,10 @@
               </a:spcAft>
             </a:pPr>
             <a:r>
-              <a:rPr sz="2500" b="0">
-                <a:latin typeface="Times New Roman"/>
-              </a:rPr>
-              <a:t>Desen: Nitel araştırma, durum çalışması; uygulama özel eğitim ve rehabilitasyon merkezinde bireysel yapılmıştır.</a:t>
+              <a:rPr sz="2700" b="0">
+                <a:latin typeface="Times New Roman"/>
+              </a:rPr>
+              <a:t>Derya YILMAZ YILDIZ</a:t>
             </a:r>
           </a:p>
         </p:txBody>
@@ -5736,7 +5639,7 @@
           <a:p>
             <a:fld id="{F302176B-0E47-46AC-8F43-DAB4B8A37D06}" type="slidenum">
               <a:rPr lang="tr-TR" smtClean="0"/>
-              <a:t>3</a:t>
+              <a:t>2</a:t>
             </a:fld>
             <a:endParaRPr lang="tr-TR"/>
           </a:p>
@@ -5779,7 +5682,7 @@
               <a:rPr b="1">
                 <a:latin typeface="Times New Roman"/>
               </a:rPr>
-              <a:t>Kaynakça (2/4)</a:t>
+              <a:t>Kaynakça (1/4)</a:t>
             </a:r>
           </a:p>
         </p:txBody>
@@ -5811,7 +5714,7 @@
               <a:rPr sz="1300" b="0">
                 <a:latin typeface="Times New Roman"/>
               </a:rPr>
-              <a:t>Ergin, A. (2010). Eğitimde Etkili İletişim. Ankara: Anı Yayıncılık</a:t>
+              <a:t>AAMR, (2002). Mental Retardation: Definition, Classification, and Systems of Supports (10. Baskı). Washington DC: AAMR</a:t>
             </a:r>
           </a:p>
           <a:p>
@@ -5825,7 +5728,7 @@
               <a:rPr sz="1300" b="0">
                 <a:latin typeface="Times New Roman"/>
               </a:rPr>
-              <a:t>Eripek, S. (1998). Özel Eğitim. T.C. Anadolu Üniversitesi Yayınları</a:t>
+              <a:t>Akyol, H. (1999). Hikâye Haritası Yöntemiyle Metin Öğretimi. Milli Eğitim, 142. (Online): Web: http://yayim.meb.gov.tr/dergiler/medergi/15.htm (Erişim Tarihi: 13.11.2013)</a:t>
             </a:r>
           </a:p>
           <a:p>
@@ -5839,7 +5742,7 @@
               <a:rPr sz="1300" b="0">
                 <a:latin typeface="Times New Roman"/>
               </a:rPr>
-              <a:t>Eripek, S. (2005). Zekâ Geriliği. Ankara: Kök Yayıncılık.</a:t>
+              <a:t>American Psychiatric Association. (2000). "Diagnostic criteria for 299.80 Asperger's Disorder (AD)". Diagnostic and Statistical Manual of Mental Disorders (4th ed., text revision bas.). ISBN 0-89042-025-4. (Erişim Tarihi: 17.09.2013)</a:t>
             </a:r>
           </a:p>
           <a:p>
@@ -5853,7 +5756,7 @@
               <a:rPr sz="1300" b="0">
                 <a:latin typeface="Times New Roman"/>
               </a:rPr>
-              <a:t>Funk, H. D.&amp;Funk, G. D. (1989). Guidelines for Developing Listening Skills. The Reading Teacher, pp.660-663</a:t>
+              <a:t>Baskin, J. H., Sperber, M.&amp;Price B. H. (2006). "Asperger Syndrome Revisited". Rev Neurol Dis 3 (1): 1–7.</a:t>
             </a:r>
           </a:p>
           <a:p>
@@ -5867,7 +5770,7 @@
               <a:rPr sz="1300" b="0">
                 <a:latin typeface="Times New Roman"/>
               </a:rPr>
-              <a:t>Gangi, J. M. (2004). Encountering Children's Literature. Pearson Education. Boston</a:t>
+              <a:t>Başal, M. ve Batu, S. (2002). Zihin Özürlü Öğrencilere Okuma Yazma Öğretme Konusunda Alt Özel Sınıf Öğretmenlerinin Görüş ve Önerileri. Özel Eğitim Dergisi, 3(2), 85-98</a:t>
             </a:r>
           </a:p>
           <a:p>
@@ -5881,7 +5784,7 @@
               <a:rPr sz="1300" b="0">
                 <a:latin typeface="Times New Roman"/>
               </a:rPr>
-              <a:t>Graesser, A., Golding, J. M., &amp; Long, D. L. (1991). Narrative Representation and Comprehension. in R. Bar, M. L. Kamil, P. Mosenthal &amp; P. D. Pearson (Ed.), Handbook of Reading Research (Vol. II, pp. 171-205). White Plains, NY: Longman</a:t>
+              <a:t>Bıyıklı, L. (1997). Özel Eğitim Gereksinimi Duyan Çocuklar. Milli Eğitim Sanat-Kültür Dergisi. Sayı: 136, s. 31-32</a:t>
             </a:r>
           </a:p>
           <a:p>
@@ -5895,7 +5798,7 @@
               <a:rPr sz="1300" b="0">
                 <a:latin typeface="Times New Roman"/>
               </a:rPr>
-              <a:t>Hampleman, R. (1958). Comparoson of Listening and Reading Comprehension Ability of 4th and 6th Grade Pupils. Elementary English. XXXI, 49</a:t>
+              <a:t>Brent, R.&amp;Anderson, P. (1993). Devoloping Children`s Classroom Listening Strategies. Reading Teacher, 47, (2), pp. 122-126</a:t>
             </a:r>
           </a:p>
           <a:p>
@@ -5909,7 +5812,7 @@
               <a:rPr sz="1300" b="0">
                 <a:latin typeface="Times New Roman"/>
               </a:rPr>
-              <a:t>İftar, G. K., Birkan, B. ve Uysal, A. (1997). Zihin Özürlü Çocuklara Kavram Öğretimi. Eskişehir: Mesleki Eğitim Yayınları</a:t>
+              <a:t>Chenfeld, M. B. (1978). Teaching Language Arts Creatively. Harcourt Brace Jovanovich Publishers. San Diego.</a:t>
             </a:r>
           </a:p>
           <a:p>
@@ -5923,7 +5826,7 @@
               <a:rPr sz="1300" b="0">
                 <a:latin typeface="Times New Roman"/>
               </a:rPr>
-              <a:t>Jalongo, M. R. (1995). Promoting Active Listening in the Cossroom. Childhood Education, 72, 1, pp.13-18</a:t>
+              <a:t>Creswell, J. W. (2007). Qualitative Inquiry and Research Design: Choosing Among Five Traditions (Second Edition). London: Sage Publication</a:t>
             </a:r>
           </a:p>
           <a:p>
@@ -5937,7 +5840,7 @@
               <a:rPr sz="1300" b="0">
                 <a:latin typeface="Times New Roman"/>
               </a:rPr>
-              <a:t>Johnson, K. O. (1951). The Effect of Classroom Training upon Listening Comprehension. The Journal of Communication. I, 58</a:t>
+              <a:t>Doğan, Y.(2012). Dinleme Eğitimi. Pegem Akademi. Ankara</a:t>
             </a:r>
           </a:p>
           <a:p>
@@ -5951,7 +5854,7 @@
               <a:rPr sz="1300" b="0">
                 <a:latin typeface="Times New Roman"/>
               </a:rPr>
-              <a:t>Klin, A. (2006). "Asperger's syndrome". Adolesc Med Clin 17 (3): 771–88.</a:t>
+              <a:t>Ergin, A. ve BİROL, C. (2000). Eğitimde İletişim. Ankara: Anı Yayıncılık</a:t>
             </a:r>
           </a:p>
         </p:txBody>
@@ -5973,7 +5876,7 @@
           <a:p>
             <a:fld id="{F302176B-0E47-46AC-8F43-DAB4B8A37D06}" type="slidenum">
               <a:rPr lang="tr-TR" smtClean="0"/>
-              <a:t>21</a:t>
+              <a:t>20</a:t>
             </a:fld>
             <a:endParaRPr lang="tr-TR"/>
           </a:p>
@@ -6016,7 +5919,7 @@
               <a:rPr b="1">
                 <a:latin typeface="Times New Roman"/>
               </a:rPr>
-              <a:t>Kaynakça (3/4)</a:t>
+              <a:t>Kaynakça (2/4)</a:t>
             </a:r>
           </a:p>
         </p:txBody>
@@ -6048,7 +5951,7 @@
               <a:rPr sz="1300" b="0">
                 <a:latin typeface="Times New Roman"/>
               </a:rPr>
-              <a:t>Kilgo, J.&amp;Gorgiarla, R. (2005). Young Children with Special Needs. (Second Edition). USA: Thomson-Delmar Learning</a:t>
+              <a:t>Ergin, A. (2010). Eğitimde Etkili İletişim. Ankara: Anı Yayıncılık</a:t>
             </a:r>
           </a:p>
           <a:p>
@@ -6062,7 +5965,7 @@
               <a:rPr sz="1300" b="0">
                 <a:latin typeface="Times New Roman"/>
               </a:rPr>
-              <a:t>Kırcaali-İftar, G. (1998). Özel Eğitim. Eskişehir: T.C. Anadolu Üniversitesi Yayınları</a:t>
+              <a:t>Eripek, S. (1998). Özel Eğitim. T.C. Anadolu Üniversitesi Yayınları</a:t>
             </a:r>
           </a:p>
           <a:p>
@@ -6076,7 +5979,7 @@
               <a:rPr sz="1300" b="0">
                 <a:latin typeface="Times New Roman"/>
               </a:rPr>
-              <a:t>Kingen, S. (2000). Teaching Language Arts in Middle Schools. Mahwah, New Jersey: Lawrence Erlbaum Associates</a:t>
+              <a:t>Eripek, S. (2005). Zekâ Geriliği. Ankara: Kök Yayıncılık.</a:t>
             </a:r>
           </a:p>
           <a:p>
@@ -6090,7 +5993,7 @@
               <a:rPr sz="1300" b="0">
                 <a:latin typeface="Times New Roman"/>
               </a:rPr>
-              <a:t>Kuz, T. (2001). Kaynaştırma Eğitimine Yönelik Tutumların İncelenmesi. Ankara: Başbakanlık Özürlüler idaresi Başkanlığı Yayınları</a:t>
+              <a:t>Funk, H. D.&amp;Funk, G. D. (1989). Guidelines for Developing Listening Skills. The Reading Teacher, pp.660-663</a:t>
             </a:r>
           </a:p>
           <a:p>
@@ -6104,7 +6007,7 @@
               <a:rPr sz="1300" b="0">
                 <a:latin typeface="Times New Roman"/>
               </a:rPr>
-              <a:t>Kuzu, T. S. (2004). Etkileşimsel Modele Uygun Okuma Öğretiminin Türkçe Bilgilendirici Metinleri Anlama Düzeyine Etkisi. Ankara Üniversitesi, Eğitim Bilimleri Fakültesi Dergisi, 3(1), 55-77</a:t>
+              <a:t>Gangi, J. M. (2004). Encountering Children's Literature. Pearson Education. Boston</a:t>
             </a:r>
           </a:p>
           <a:p>
@@ -6118,7 +6021,7 @@
               <a:rPr sz="1300" b="0">
                 <a:latin typeface="Times New Roman"/>
               </a:rPr>
-              <a:t>Levis, R. B.&amp;Doorlag H. D. (1999). Teaching Special Students in General Education Classrooms. New Jersey, Prentice Hall</a:t>
+              <a:t>Graesser, A., Golding, J. M., &amp; Long, D. L. (1991). Narrative Representation and Comprehension. in R. Bar, M. L. Kamil, P. Mosenthal &amp; P. D. Pearson (Ed.), Handbook of Reading Research (Vol. II, pp. 171-205). White Plains, NY: Longman</a:t>
             </a:r>
           </a:p>
           <a:p>
@@ -6132,7 +6035,7 @@
               <a:rPr sz="1300" b="0">
                 <a:latin typeface="Times New Roman"/>
               </a:rPr>
-              <a:t>Mağden, D. ve Avcı, N. (1997). Öğretmen Adaylarının Özürlü Öğrencilerin Kaynaştırılmasına İlişkin Görüşleri. 4. Ulusal Eğitim Bilimleri Kongresi. Eskişehir: Anadolu Üniversitesi Eğitim Fakültesi. 10-12 Eylül</a:t>
+              <a:t>Hampleman, R. (1958). Comparoson of Listening and Reading Comprehension Ability of 4th and 6th Grade Pupils. Elementary English. XXXI, 49</a:t>
             </a:r>
           </a:p>
           <a:p>
@@ -6146,7 +6049,7 @@
               <a:rPr sz="1300" b="0">
                 <a:latin typeface="Times New Roman"/>
               </a:rPr>
-              <a:t>MEB. (2005). İlköğretim 1-5. Sınıf Programları Tanıtım El Kitabı. Ankara: Devlet Kitapları Müdürlüğü Basımevi</a:t>
+              <a:t>İftar, G. K., Birkan, B. ve Uysal, A. (1997). Zihin Özürlü Çocuklara Kavram Öğretimi. Eskişehir: Mesleki Eğitim Yayınları</a:t>
             </a:r>
           </a:p>
           <a:p>
@@ -6160,7 +6063,7 @@
               <a:rPr sz="1300" b="0">
                 <a:latin typeface="Times New Roman"/>
               </a:rPr>
-              <a:t>MEB. (2006). Özel eğitim Hizmetleri Yönetmeliği, 31.05.2006 tarih ve 26184 Sayılı Resmî Gazete</a:t>
+              <a:t>Jalongo, M. R. (1995). Promoting Active Listening in the Cossroom. Childhood Education, 72, 1, pp.13-18</a:t>
             </a:r>
           </a:p>
           <a:p>
@@ -6174,7 +6077,7 @@
               <a:rPr sz="1300" b="0">
                 <a:latin typeface="Times New Roman"/>
               </a:rPr>
-              <a:t>MEB. (2009). MEGEP. Çocuk Gelişimi ve Eğitimi. Zihinsel Engelliler. Ders Notları. Ankara: Devlet Kitapları Müdürlüğü Basımevi</a:t>
+              <a:t>Johnson, K. O. (1951). The Effect of Classroom Training upon Listening Comprehension. The Journal of Communication. I, 58</a:t>
             </a:r>
           </a:p>
           <a:p>
@@ -6188,7 +6091,7 @@
               <a:rPr sz="1300" b="0">
                 <a:latin typeface="Times New Roman"/>
               </a:rPr>
-              <a:t>Merriam, S. B. (1998). Qualitative Researchand Case Study Applications in Education (Second Edition). San Francisco: Jossey-Bass Publishers</a:t>
+              <a:t>Klin, A. (2006). "Asperger's syndrome". Adolesc Med Clin 17 (3): 771–88.</a:t>
             </a:r>
           </a:p>
         </p:txBody>
@@ -6210,7 +6113,7 @@
           <a:p>
             <a:fld id="{F302176B-0E47-46AC-8F43-DAB4B8A37D06}" type="slidenum">
               <a:rPr lang="tr-TR" smtClean="0"/>
-              <a:t>22</a:t>
+              <a:t>21</a:t>
             </a:fld>
             <a:endParaRPr lang="tr-TR"/>
           </a:p>
@@ -6253,7 +6156,7 @@
               <a:rPr b="1">
                 <a:latin typeface="Times New Roman"/>
               </a:rPr>
-              <a:t>Kaynakça (4/4)</a:t>
+              <a:t>Kaynakça (3/4)</a:t>
             </a:r>
           </a:p>
         </p:txBody>
@@ -6285,7 +6188,7 @@
               <a:rPr sz="1300" b="0">
                 <a:latin typeface="Times New Roman"/>
               </a:rPr>
-              <a:t>Ömür, M. (2006). Kulağımızın Göz Kapağı Yoktur, Cumhuriyet Bilim, S.990, s. 16-17</a:t>
+              <a:t>Kilgo, J.&amp;Gorgiarla, R. (2005). Young Children with Special Needs. (Second Edition). USA: Thomson-Delmar Learning</a:t>
             </a:r>
           </a:p>
           <a:p>
@@ -6299,7 +6202,7 @@
               <a:rPr sz="1300" b="0">
                 <a:latin typeface="Times New Roman"/>
               </a:rPr>
-              <a:t>Özbay, M. (2005). Bir Dil Becerisi Olarak Dinleme Eğitimi. Ankara: Akçağ Yayınları</a:t>
+              <a:t>Kırcaali-İftar, G. (1998). Özel Eğitim. Eskişehir: T.C. Anadolu Üniversitesi Yayınları</a:t>
             </a:r>
           </a:p>
           <a:p>
@@ -6313,7 +6216,7 @@
               <a:rPr sz="1300" b="0">
                 <a:latin typeface="Times New Roman"/>
               </a:rPr>
-              <a:t>Özel Eğitim Hakkında Kanun Hükmünde Kararname ve Özel Eğitim Hizmetleri Yönetmeliği (2000). Ankara: Milli Eğitim Basımevi</a:t>
+              <a:t>Kingen, S. (2000). Teaching Language Arts in Middle Schools. Mahwah, New Jersey: Lawrence Erlbaum Associates</a:t>
             </a:r>
           </a:p>
           <a:p>
@@ -6327,7 +6230,7 @@
               <a:rPr sz="1300" b="0">
                 <a:latin typeface="Times New Roman"/>
               </a:rPr>
-              <a:t>Özdemir, E. (1998). Eleştirel Okuma. Ankara: Ümit Yayıncılık</a:t>
+              <a:t>Kuz, T. (2001). Kaynaştırma Eğitimine Yönelik Tutumların İncelenmesi. Ankara: Başbakanlık Özürlüler idaresi Başkanlığı Yayınları</a:t>
             </a:r>
           </a:p>
           <a:p>
@@ -6341,7 +6244,7 @@
               <a:rPr sz="1300" b="0">
                 <a:latin typeface="Times New Roman"/>
               </a:rPr>
-              <a:t>Özgür, G. (2004). Engelli Çocuklar ve Eğitim-Özel Eğitim. Adana: Karhan Kitabevi</a:t>
+              <a:t>Kuzu, T. S. (2004). Etkileşimsel Modele Uygun Okuma Öğretiminin Türkçe Bilgilendirici Metinleri Anlama Düzeyine Etkisi. Ankara Üniversitesi, Eğitim Bilimleri Fakültesi Dergisi, 3(1), 55-77</a:t>
             </a:r>
           </a:p>
           <a:p>
@@ -6355,7 +6258,7 @@
               <a:rPr sz="1300" b="0">
                 <a:latin typeface="Times New Roman"/>
               </a:rPr>
-              <a:t>Salend, S. J. (1998). Effective Mainstreaming: Creating inclusive classrooms. (3rd Edition). New Jersey: Merrill Prentice Hall</a:t>
+              <a:t>Levis, R. B.&amp;Doorlag H. D. (1999). Teaching Special Students in General Education Classrooms. New Jersey, Prentice Hall</a:t>
             </a:r>
           </a:p>
           <a:p>
@@ -6369,7 +6272,7 @@
               <a:rPr sz="1300" b="0">
                 <a:latin typeface="Times New Roman"/>
               </a:rPr>
-              <a:t>Sucuoğlu, B. (2010). Zihin Engelliler ve Eğitimleri. Ankara: Kök Yayıncılık</a:t>
+              <a:t>Mağden, D. ve Avcı, N. (1997). Öğretmen Adaylarının Özürlü Öğrencilerin Kaynaştırılmasına İlişkin Görüşleri. 4. Ulusal Eğitim Bilimleri Kongresi. Eskişehir: Anadolu Üniversitesi Eğitim Fakültesi. 10-12 Eylül</a:t>
             </a:r>
           </a:p>
           <a:p>
@@ -6383,7 +6286,7 @@
               <a:rPr sz="1300" b="0">
                 <a:latin typeface="Times New Roman"/>
               </a:rPr>
-              <a:t>Şura Raporu. (1999). I. Özürlüler Şurası Çağdaş Toplum Çağdaş Yaşam ve Özürlüler. 29 Kasım-02 Aralık. Ankara: T.C. Başbakanlık Özürlüler İdaresi Başkanlığı Yayınları</a:t>
+              <a:t>MEB. (2005). İlköğretim 1-5. Sınıf Programları Tanıtım El Kitabı. Ankara: Devlet Kitapları Müdürlüğü Basımevi</a:t>
             </a:r>
           </a:p>
           <a:p>
@@ -6397,7 +6300,7 @@
               <a:rPr sz="1300" b="0">
                 <a:latin typeface="Times New Roman"/>
               </a:rPr>
-              <a:t>Tüfekçioğlu, Ü. (1997). İşitme Engelli Çocukların Okul Öncesi Dönemde Kaynaştırma Ortamında Eğitimleri. Milli Eğitim Kültür-Sanat Dergisi, Sayı: 136, S:58</a:t>
+              <a:t>MEB. (2006). Özel eğitim Hizmetleri Yönetmeliği, 31.05.2006 tarih ve 26184 Sayılı Resmî Gazete</a:t>
             </a:r>
           </a:p>
           <a:p>
@@ -6411,7 +6314,7 @@
               <a:rPr sz="1300" b="0">
                 <a:latin typeface="Times New Roman"/>
               </a:rPr>
-              <a:t>Quandt, J. I. (1983). Language Arts for Children. London: Prentice Hall Inc</a:t>
+              <a:t>MEB. (2009). MEGEP. Çocuk Gelişimi ve Eğitimi. Zihinsel Engelliler. Ders Notları. Ankara: Devlet Kitapları Müdürlüğü Basımevi</a:t>
             </a:r>
           </a:p>
           <a:p>
@@ -6425,21 +6328,7 @@
               <a:rPr sz="1300" b="0">
                 <a:latin typeface="Times New Roman"/>
               </a:rPr>
-              <a:t>Weaver, C.&amp;Kintsch, W. (1991). Expository Texts. Handbook of Reading Research. Rebecca Barr, Michael Kamil ve diğer (Ed.) New York: Longman</a:t>
-            </a:r>
-          </a:p>
-          <a:p>
-            <a:pPr marL="228600" indent="-228600">
-              <a:spcAft>
-                <a:spcPts val="500"/>
-              </a:spcAft>
-              <a:buNone/>
-            </a:pPr>
-            <a:r>
-              <a:rPr sz="1300" b="0">
-                <a:latin typeface="Times New Roman"/>
-              </a:rPr>
-              <a:t>Westling, D. L.&amp;Fox, L. (2000). Teaching Students With Several Disabilities. (2nd Edition). USA: Printice Hall</a:t>
+              <a:t>Merriam, S. B. (1998). Qualitative Researchand Case Study Applications in Education (Second Edition). San Francisco: Jossey-Bass Publishers</a:t>
             </a:r>
           </a:p>
         </p:txBody>
@@ -6461,7 +6350,7 @@
           <a:p>
             <a:fld id="{F302176B-0E47-46AC-8F43-DAB4B8A37D06}" type="slidenum">
               <a:rPr lang="tr-TR" smtClean="0"/>
-              <a:t>23</a:t>
+              <a:t>22</a:t>
             </a:fld>
             <a:endParaRPr lang="tr-TR"/>
           </a:p>
@@ -6499,7 +6388,14 @@
         <p:txBody>
           <a:bodyPr/>
           <a:lstStyle/>
-          <a:p/>
+          <a:p>
+            <a:r>
+              <a:rPr b="1">
+                <a:latin typeface="Times New Roman"/>
+              </a:rPr>
+              <a:t>Kaynakça (4/4)</a:t>
+            </a:r>
+          </a:p>
         </p:txBody>
       </p:sp>
       <p:sp>
@@ -6514,56 +6410,176 @@
         </p:nvSpPr>
         <p:spPr/>
         <p:txBody>
-          <a:bodyPr/>
-          <a:lstStyle/>
-          <a:p>
-            <a:r>
-              <a:rPr sz="2400" b="0">
-                <a:latin typeface="Times New Roman"/>
-              </a:rPr>
-              <a:t>HAZIRLAYAN :</a:t>
-            </a:r>
-          </a:p>
-          <a:p/>
-          <a:p>
-            <a:r>
-              <a:rPr sz="2400" b="0">
-                <a:latin typeface="Times New Roman"/>
-              </a:rPr>
-              <a:t/>
-            </a:r>
-          </a:p>
-          <a:p>
-            <a:r>
-              <a:rPr sz="2400" b="0">
-                <a:latin typeface="Times New Roman"/>
-              </a:rPr>
-              <a:t/>
-            </a:r>
-          </a:p>
-          <a:p>
-            <a:r>
-              <a:rPr sz="2400" b="0">
-                <a:latin typeface="Times New Roman"/>
-              </a:rPr>
-              <a:t>ÖZET MAKALE (TÜRKÇE)</a:t>
-            </a:r>
-          </a:p>
-          <a:p/>
-          <a:p>
-            <a:r>
-              <a:rPr sz="2400" b="1">
-                <a:latin typeface="Times New Roman"/>
-              </a:rPr>
-              <a:t>Akademik Bakış Dergisi, Sayı 41, Mart–Nisan 2014</a:t>
-            </a:r>
-          </a:p>
-          <a:p>
-            <a:r>
-              <a:rPr sz="2400" b="1">
-                <a:latin typeface="Times New Roman"/>
-              </a:rPr>
-              <a:t>Celalabat / Kırgızistan</a:t>
+          <a:bodyPr wrap="square">
+            <a:noAutofit/>
+          </a:bodyPr>
+          <a:lstStyle/>
+          <a:p>
+            <a:pPr marL="228600" indent="-228600">
+              <a:spcAft>
+                <a:spcPts val="500"/>
+              </a:spcAft>
+              <a:buNone/>
+            </a:pPr>
+            <a:r>
+              <a:rPr sz="1300" b="0">
+                <a:latin typeface="Times New Roman"/>
+              </a:rPr>
+              <a:t>Ömür, M. (2006). Kulağımızın Göz Kapağı Yoktur, Cumhuriyet Bilim, S.990, s. 16-17</a:t>
+            </a:r>
+          </a:p>
+          <a:p>
+            <a:pPr marL="228600" indent="-228600">
+              <a:spcAft>
+                <a:spcPts val="500"/>
+              </a:spcAft>
+              <a:buNone/>
+            </a:pPr>
+            <a:r>
+              <a:rPr sz="1300" b="0">
+                <a:latin typeface="Times New Roman"/>
+              </a:rPr>
+              <a:t>Özbay, M. (2005). Bir Dil Becerisi Olarak Dinleme Eğitimi. Ankara: Akçağ Yayınları</a:t>
+            </a:r>
+          </a:p>
+          <a:p>
+            <a:pPr marL="228600" indent="-228600">
+              <a:spcAft>
+                <a:spcPts val="500"/>
+              </a:spcAft>
+              <a:buNone/>
+            </a:pPr>
+            <a:r>
+              <a:rPr sz="1300" b="0">
+                <a:latin typeface="Times New Roman"/>
+              </a:rPr>
+              <a:t>Özel Eğitim Hakkında Kanun Hükmünde Kararname ve Özel Eğitim Hizmetleri Yönetmeliği (2000). Ankara: Milli Eğitim Basımevi</a:t>
+            </a:r>
+          </a:p>
+          <a:p>
+            <a:pPr marL="228600" indent="-228600">
+              <a:spcAft>
+                <a:spcPts val="500"/>
+              </a:spcAft>
+              <a:buNone/>
+            </a:pPr>
+            <a:r>
+              <a:rPr sz="1300" b="0">
+                <a:latin typeface="Times New Roman"/>
+              </a:rPr>
+              <a:t>Özdemir, E. (1998). Eleştirel Okuma. Ankara: Ümit Yayıncılık</a:t>
+            </a:r>
+          </a:p>
+          <a:p>
+            <a:pPr marL="228600" indent="-228600">
+              <a:spcAft>
+                <a:spcPts val="500"/>
+              </a:spcAft>
+              <a:buNone/>
+            </a:pPr>
+            <a:r>
+              <a:rPr sz="1300" b="0">
+                <a:latin typeface="Times New Roman"/>
+              </a:rPr>
+              <a:t>Özgür, G. (2004). Engelli Çocuklar ve Eğitim-Özel Eğitim. Adana: Karhan Kitabevi</a:t>
+            </a:r>
+          </a:p>
+          <a:p>
+            <a:pPr marL="228600" indent="-228600">
+              <a:spcAft>
+                <a:spcPts val="500"/>
+              </a:spcAft>
+              <a:buNone/>
+            </a:pPr>
+            <a:r>
+              <a:rPr sz="1300" b="0">
+                <a:latin typeface="Times New Roman"/>
+              </a:rPr>
+              <a:t>Salend, S. J. (1998). Effective Mainstreaming: Creating inclusive classrooms. (3rd Edition). New Jersey: Merrill Prentice Hall</a:t>
+            </a:r>
+          </a:p>
+          <a:p>
+            <a:pPr marL="228600" indent="-228600">
+              <a:spcAft>
+                <a:spcPts val="500"/>
+              </a:spcAft>
+              <a:buNone/>
+            </a:pPr>
+            <a:r>
+              <a:rPr sz="1300" b="0">
+                <a:latin typeface="Times New Roman"/>
+              </a:rPr>
+              <a:t>Sucuoğlu, B. (2010). Zihin Engelliler ve Eğitimleri. Ankara: Kök Yayıncılık</a:t>
+            </a:r>
+          </a:p>
+          <a:p>
+            <a:pPr marL="228600" indent="-228600">
+              <a:spcAft>
+                <a:spcPts val="500"/>
+              </a:spcAft>
+              <a:buNone/>
+            </a:pPr>
+            <a:r>
+              <a:rPr sz="1300" b="0">
+                <a:latin typeface="Times New Roman"/>
+              </a:rPr>
+              <a:t>Şura Raporu. (1999). I. Özürlüler Şurası Çağdaş Toplum Çağdaş Yaşam ve Özürlüler. 29 Kasım-02 Aralık. Ankara: T.C. Başbakanlık Özürlüler İdaresi Başkanlığı Yayınları</a:t>
+            </a:r>
+          </a:p>
+          <a:p>
+            <a:pPr marL="228600" indent="-228600">
+              <a:spcAft>
+                <a:spcPts val="500"/>
+              </a:spcAft>
+              <a:buNone/>
+            </a:pPr>
+            <a:r>
+              <a:rPr sz="1300" b="0">
+                <a:latin typeface="Times New Roman"/>
+              </a:rPr>
+              <a:t>Tüfekçioğlu, Ü. (1997). İşitme Engelli Çocukların Okul Öncesi Dönemde Kaynaştırma Ortamında Eğitimleri. Milli Eğitim Kültür-Sanat Dergisi, Sayı: 136, S:58</a:t>
+            </a:r>
+          </a:p>
+          <a:p>
+            <a:pPr marL="228600" indent="-228600">
+              <a:spcAft>
+                <a:spcPts val="500"/>
+              </a:spcAft>
+              <a:buNone/>
+            </a:pPr>
+            <a:r>
+              <a:rPr sz="1300" b="0">
+                <a:latin typeface="Times New Roman"/>
+              </a:rPr>
+              <a:t>Quandt, J. I. (1983). Language Arts for Children. London: Prentice Hall Inc</a:t>
+            </a:r>
+          </a:p>
+          <a:p>
+            <a:pPr marL="228600" indent="-228600">
+              <a:spcAft>
+                <a:spcPts val="500"/>
+              </a:spcAft>
+              <a:buNone/>
+            </a:pPr>
+            <a:r>
+              <a:rPr sz="1300" b="0">
+                <a:latin typeface="Times New Roman"/>
+              </a:rPr>
+              <a:t>Weaver, C.&amp;Kintsch, W. (1991). Expository Texts. Handbook of Reading Research. Rebecca Barr, Michael Kamil ve diğer (Ed.) New York: Longman</a:t>
+            </a:r>
+          </a:p>
+          <a:p>
+            <a:pPr marL="228600" indent="-228600">
+              <a:spcAft>
+                <a:spcPts val="500"/>
+              </a:spcAft>
+              <a:buNone/>
+            </a:pPr>
+            <a:r>
+              <a:rPr sz="1300" b="0">
+                <a:latin typeface="Times New Roman"/>
+              </a:rPr>
+              <a:t>Westling, D. L.&amp;Fox, L. (2000). Teaching Students With Several Disabilities. (2nd Edition). USA: Printice Hall</a:t>
             </a:r>
           </a:p>
         </p:txBody>
@@ -6585,7 +6601,7 @@
           <a:p>
             <a:fld id="{F302176B-0E47-46AC-8F43-DAB4B8A37D06}" type="slidenum">
               <a:rPr lang="tr-TR" smtClean="0"/>
-              <a:t>24</a:t>
+              <a:t>23</a:t>
             </a:fld>
             <a:endParaRPr lang="tr-TR"/>
           </a:p>
@@ -6623,14 +6639,7 @@
         <p:txBody>
           <a:bodyPr/>
           <a:lstStyle/>
-          <a:p>
-            <a:r>
-              <a:rPr b="1">
-                <a:latin typeface="Times New Roman"/>
-              </a:rPr>
-              <a:t>Sunanlar</a:t>
-            </a:r>
-          </a:p>
+          <a:p/>
         </p:txBody>
       </p:sp>
       <p:sp>
@@ -6645,47 +6654,56 @@
         </p:nvSpPr>
         <p:spPr/>
         <p:txBody>
-          <a:bodyPr wrap="square">
-            <a:noAutofit/>
-          </a:bodyPr>
-          <a:lstStyle/>
-          <a:p>
-            <a:pPr>
-              <a:spcAft>
-                <a:spcPts val="600"/>
-              </a:spcAft>
-            </a:pPr>
-            <a:r>
-              <a:rPr sz="2700" b="0">
-                <a:latin typeface="Times New Roman"/>
-              </a:rPr>
-              <a:t>Feyza BÜYÜKBEKTAŞ</a:t>
-            </a:r>
-          </a:p>
-          <a:p>
-            <a:pPr>
-              <a:spcAft>
-                <a:spcPts val="600"/>
-              </a:spcAft>
-            </a:pPr>
-            <a:r>
-              <a:rPr sz="2700" b="0">
-                <a:latin typeface="Times New Roman"/>
-              </a:rPr>
-              <a:t>Çiğdem TURAN</a:t>
-            </a:r>
-          </a:p>
-          <a:p>
-            <a:pPr>
-              <a:spcAft>
-                <a:spcPts val="600"/>
-              </a:spcAft>
-            </a:pPr>
-            <a:r>
-              <a:rPr sz="2700" b="0">
-                <a:latin typeface="Times New Roman"/>
-              </a:rPr>
-              <a:t>Derya YILMAZ YILDIZ</a:t>
+          <a:bodyPr/>
+          <a:lstStyle/>
+          <a:p>
+            <a:r>
+              <a:rPr sz="2400" b="0">
+                <a:latin typeface="Times New Roman"/>
+              </a:rPr>
+              <a:t>HAZIRLAYAN :</a:t>
+            </a:r>
+          </a:p>
+          <a:p/>
+          <a:p>
+            <a:r>
+              <a:rPr sz="2400" b="0">
+                <a:latin typeface="Times New Roman"/>
+              </a:rPr>
+              <a:t/>
+            </a:r>
+          </a:p>
+          <a:p>
+            <a:r>
+              <a:rPr sz="2400" b="0">
+                <a:latin typeface="Times New Roman"/>
+              </a:rPr>
+              <a:t/>
+            </a:r>
+          </a:p>
+          <a:p>
+            <a:r>
+              <a:rPr sz="2400" b="0">
+                <a:latin typeface="Times New Roman"/>
+              </a:rPr>
+              <a:t>ÖZET MAKALE (TÜRKÇE)</a:t>
+            </a:r>
+          </a:p>
+          <a:p/>
+          <a:p>
+            <a:r>
+              <a:rPr sz="2400" b="1">
+                <a:latin typeface="Times New Roman"/>
+              </a:rPr>
+              <a:t>Akademik Bakış Dergisi, Sayı 41, Mart–Nisan 2014</a:t>
+            </a:r>
+          </a:p>
+          <a:p>
+            <a:r>
+              <a:rPr sz="2400" b="1">
+                <a:latin typeface="Times New Roman"/>
+              </a:rPr>
+              <a:t>Celalabat / Kırgızistan</a:t>
             </a:r>
           </a:p>
         </p:txBody>
@@ -6707,9 +6725,76 @@
           <a:p>
             <a:fld id="{F302176B-0E47-46AC-8F43-DAB4B8A37D06}" type="slidenum">
               <a:rPr lang="tr-TR" smtClean="0"/>
-              <a:t>2</a:t>
+              <a:t>24</a:t>
             </a:fld>
             <a:endParaRPr lang="tr-TR"/>
+          </a:p>
+        </p:txBody>
+      </p:sp>
+      <p:sp>
+        <p:nvSpPr>
+          <p:cNvPr id="7" name="Rounded Rectangle 6">
+            <a:hlinkClick r:id="rId2"/>
+          </p:cNvPr>
+          <p:cNvSpPr/>
+          <p:nvPr/>
+        </p:nvSpPr>
+        <p:spPr>
+          <a:xfrm>
+            <a:off x="457200" y="5257800"/>
+            <a:ext cx="7543800" cy="1005840"/>
+          </a:xfrm>
+          <a:prstGeom prst="roundRect">
+            <a:avLst>
+              <a:gd name="adj" fmla="val 20000"/>
+            </a:avLst>
+          </a:prstGeom>
+          <a:solidFill>
+            <a:srgbClr val="FFF1E0"/>
+          </a:solidFill>
+          <a:ln w="38100">
+            <a:solidFill>
+              <a:srgbClr val="E36C0A"/>
+            </a:solidFill>
+          </a:ln>
+          <a:effectLst/>
+        </p:spPr>
+        <p:style>
+          <a:lnRef idx="1">
+            <a:schemeClr val="accent1"/>
+          </a:lnRef>
+          <a:fillRef idx="3">
+            <a:schemeClr val="accent1"/>
+          </a:fillRef>
+          <a:effectRef idx="2">
+            <a:schemeClr val="accent1"/>
+          </a:effectRef>
+          <a:fontRef idx="minor">
+            <a:schemeClr val="lt1"/>
+          </a:fontRef>
+        </p:style>
+        <p:txBody>
+          <a:bodyPr rtlCol="0" anchor="ctr" wrap="square"/>
+          <a:lstStyle/>
+          <a:p>
+            <a:pPr algn="ctr"/>
+            <a:r>
+              <a:rPr sz="2200" b="1">
+                <a:latin typeface="Times New Roman"/>
+                <a:hlinkClick r:id="rId2"/>
+              </a:rPr>
+              <a:t>Makalenin tamamına buradan ulaşabilirsiniz</a:t>
+            </a:r>
+          </a:p>
+          <a:p>
+            <a:pPr algn="ctr"/>
+            <a:r>
+              <a:rPr sz="1600" b="0">
+                <a:latin typeface="Times New Roman"/>
+                <a:hlinkClick r:id="rId2"/>
+              </a:rPr>
+              <a:t>dergipark.org.tr  ›  Makaleyi açmak için tıklayın</a:t>
+            </a:r>
           </a:p>
         </p:txBody>
       </p:sp>
@@ -6781,7 +6866,7 @@
               <a:rPr sz="2500" b="0">
                 <a:latin typeface="Times New Roman"/>
               </a:rPr>
-              <a:t>Aralık 2013’te her öğrenciyle toplam 6 ders saati çalışılmış; 1., 2. ve 3. sınıf düzeyine uygun hikâye edici ve bilgilendirici metin/video kullanılmıştır.</a:t>
+              <a:t>Amaç: Hafif düzeyde zihinsel yetersizliği olan kaynaştırma öğrencilerinin hikâye ve bilgilendirici metinleri işitsel ya da görsel-işitsel materyalle dinlediklerinde anlama düzeylerini ölçmek.</a:t>
             </a:r>
           </a:p>
           <a:p>
@@ -6794,7 +6879,7 @@
               <a:rPr sz="2500" b="0">
                 <a:latin typeface="Times New Roman"/>
               </a:rPr>
-              <a:t>Ölçme: 5N1K ve hikâye haritası temelli dinlediğini anlama testi.</a:t>
+              <a:t>Katılımcılar: Farklı okullara devam eden, zekâ bölümü 50-70 arasında üç öğrenci.</a:t>
             </a:r>
           </a:p>
           <a:p>
@@ -6807,20 +6892,7 @@
               <a:rPr sz="2500" b="0">
                 <a:latin typeface="Times New Roman"/>
               </a:rPr>
-              <a:t>Bulgu: Görsel ve işitsel materyal birlikte kullanıldığında anlama, yalnız işitsel materyale göre daha yüksektir; hikâye edici metinde başarı bilgilendirici metne göre daha yüksektir.</a:t>
-            </a:r>
-          </a:p>
-          <a:p>
-            <a:pPr>
-              <a:spcAft>
-                <a:spcPts val="600"/>
-              </a:spcAft>
-            </a:pPr>
-            <a:r>
-              <a:rPr sz="2500" b="0">
-                <a:latin typeface="Times New Roman"/>
-              </a:rPr>
-              <a:t>Anahtar sözcükler: Zihin engelliler, kaynaştırma eğitimi, dinleme anlama öğretimi.</a:t>
+              <a:t>Desen: Nitel araştırma, durum çalışması; uygulama özel eğitim ve rehabilitasyon merkezinde bireysel yapılmıştır.</a:t>
             </a:r>
           </a:p>
         </p:txBody>
@@ -6842,7 +6914,7 @@
           <a:p>
             <a:fld id="{F302176B-0E47-46AC-8F43-DAB4B8A37D06}" type="slidenum">
               <a:rPr lang="tr-TR" smtClean="0"/>
-              <a:t>4</a:t>
+              <a:t>3</a:t>
             </a:fld>
             <a:endParaRPr lang="tr-TR"/>
           </a:p>
@@ -6885,7 +6957,7 @@
               <a:rPr b="1">
                 <a:latin typeface="Times New Roman"/>
               </a:rPr>
-              <a:t>Giriş: Zihinsel Yetersizlik</a:t>
+              <a:t>Öz</a:t>
             </a:r>
           </a:p>
         </p:txBody>
@@ -6916,7 +6988,7 @@
               <a:rPr sz="2500" b="0">
                 <a:latin typeface="Times New Roman"/>
               </a:rPr>
-              <a:t>Zihinsel yetersizlik: zihinsel işlevlerde ve kavramsal, sosyal, pratik uyumsal becerilerde belirgin sınırlılık; 18 yaşından önce başlar (AAMR, 2002).</a:t>
+              <a:t>Aralık 2013’te her öğrenciyle toplam 6 ders saati çalışılmış; 1., 2. ve 3. sınıf düzeyine uygun hikâye edici ve bilgilendirici metin/video kullanılmıştır.</a:t>
             </a:r>
           </a:p>
           <a:p>
@@ -6929,7 +7001,7 @@
               <a:rPr sz="2500" b="0">
                 <a:latin typeface="Times New Roman"/>
               </a:rPr>
-              <a:t>Zekâ bölümüne göre hafif (50/55-70), orta, ağır ve çok ağır olarak sınıflandırılır.</a:t>
+              <a:t>Ölçme: 5N1K ve hikâye haritası temelli dinlediğini anlama testi.</a:t>
             </a:r>
           </a:p>
           <a:p>
@@ -6942,7 +7014,7 @@
               <a:rPr sz="2500" b="0">
                 <a:latin typeface="Times New Roman"/>
               </a:rPr>
-              <a:t>Hafif düzeydeki öğrenciler zihinsel engellilerin yaklaşık %85’ini oluşturur (Salend, 1998).</a:t>
+              <a:t>Bulgu: Görsel ve işitsel materyal birlikte kullanıldığında anlama, yalnız işitsel materyale göre daha yüksektir; hikâye edici metinde başarı bilgilendirici metne göre daha yüksektir.</a:t>
             </a:r>
           </a:p>
           <a:p>
@@ -6955,7 +7027,7 @@
               <a:rPr sz="2500" b="0">
                 <a:latin typeface="Times New Roman"/>
               </a:rPr>
-              <a:t>Soyut kavramları geç kavrar, genelleme yapmakta zorlanır; akademik beceriler yaklaşık 6. sınıf düzeyine ulaşır (Eripek, 2005; Sucuoğlu, 2010).</a:t>
+              <a:t>Anahtar sözcükler: Zihin engelliler, kaynaştırma eğitimi, dinleme anlama öğretimi.</a:t>
             </a:r>
           </a:p>
         </p:txBody>
@@ -6977,7 +7049,7 @@
           <a:p>
             <a:fld id="{F302176B-0E47-46AC-8F43-DAB4B8A37D06}" type="slidenum">
               <a:rPr lang="tr-TR" smtClean="0"/>
-              <a:t>5</a:t>
+              <a:t>4</a:t>
             </a:fld>
             <a:endParaRPr lang="tr-TR"/>
           </a:p>
@@ -7020,7 +7092,7 @@
               <a:rPr b="1">
                 <a:latin typeface="Times New Roman"/>
               </a:rPr>
-              <a:t>Giriş: Kaynaştırma Eğitimi</a:t>
+              <a:t>Giriş: Zihinsel Yetersizlik</a:t>
             </a:r>
           </a:p>
         </p:txBody>
@@ -7051,7 +7123,7 @@
               <a:rPr sz="2500" b="0">
                 <a:latin typeface="Times New Roman"/>
               </a:rPr>
-              <a:t>Kaynaştırma: engelli öğrencilerin, özel eğitim desteğiyle engelsiz akranlarıyla normal okul ve sınıflarda eğitim almasıdır (Tüfekçioğlu, 1997).</a:t>
+              <a:t>Zihinsel yetersizlik: zihinsel işlevlerde ve kavramsal, sosyal, pratik uyumsal becerilerde belirgin sınırlılık; 18 yaşından önce başlar (AAMR, 2002).</a:t>
             </a:r>
           </a:p>
           <a:p>
@@ -7064,7 +7136,7 @@
               <a:rPr sz="2500" b="0">
                 <a:latin typeface="Times New Roman"/>
               </a:rPr>
-              <a:t>Amaçlar: damgalamayı silmek, engelli çocuğun sosyal statüsünü yükseltmek, daha iyi ve ucuz bir öğrenme çevresi yaratmak.</a:t>
+              <a:t>Zekâ bölümüne göre hafif (50/55-70), orta, ağır ve çok ağır olarak sınıflandırılır.</a:t>
             </a:r>
           </a:p>
           <a:p>
@@ -7077,7 +7149,7 @@
               <a:rPr sz="2500" b="0">
                 <a:latin typeface="Times New Roman"/>
               </a:rPr>
-              <a:t>En az kısıtlayıcı ortam ilkesine göre kaynaştırma, eğitim ortamları içinde en üst basamaktır (Kırcaali-İftar, 1998).</a:t>
+              <a:t>Hafif düzeydeki öğrenciler zihinsel engellilerin yaklaşık %85’ini oluşturur (Salend, 1998).</a:t>
             </a:r>
           </a:p>
           <a:p>
@@ -7090,7 +7162,7 @@
               <a:rPr sz="2500" b="0">
                 <a:latin typeface="Times New Roman"/>
               </a:rPr>
-              <a:t>Türkiye’de kaynaştırma uygulamaları 1985’ten sonra başlamıştır (Kuz, 2001).</a:t>
+              <a:t>Soyut kavramları geç kavrar, genelleme yapmakta zorlanır; akademik beceriler yaklaşık 6. sınıf düzeyine ulaşır (Eripek, 2005; Sucuoğlu, 2010).</a:t>
             </a:r>
           </a:p>
         </p:txBody>
@@ -7112,7 +7184,7 @@
           <a:p>
             <a:fld id="{F302176B-0E47-46AC-8F43-DAB4B8A37D06}" type="slidenum">
               <a:rPr lang="tr-TR" smtClean="0"/>
-              <a:t>6</a:t>
+              <a:t>5</a:t>
             </a:fld>
             <a:endParaRPr lang="tr-TR"/>
           </a:p>
@@ -7155,7 +7227,7 @@
               <a:rPr b="1">
                 <a:latin typeface="Times New Roman"/>
               </a:rPr>
-              <a:t>Giriş: Dinleme Becerisi</a:t>
+              <a:t>Giriş: Kaynaştırma Eğitimi</a:t>
             </a:r>
           </a:p>
         </p:txBody>
@@ -7183,10 +7255,10 @@
               </a:spcAft>
             </a:pPr>
             <a:r>
-              <a:rPr sz="2400" b="0">
-                <a:latin typeface="Times New Roman"/>
-              </a:rPr>
-              <a:t>Dinleme: sözlü iletişimde mesajı anlama ve cevap verme etkinliğidir; insanın kazandığı ilk dil becerisidir (Ömür, 2006).</a:t>
+              <a:rPr sz="2500" b="0">
+                <a:latin typeface="Times New Roman"/>
+              </a:rPr>
+              <a:t>Kaynaştırma: engelli öğrencilerin, özel eğitim desteğiyle engelsiz akranlarıyla normal okul ve sınıflarda eğitim almasıdır (Tüfekçioğlu, 1997).</a:t>
             </a:r>
           </a:p>
           <a:p>
@@ -7196,10 +7268,10 @@
               </a:spcAft>
             </a:pPr>
             <a:r>
-              <a:rPr sz="2400" b="0">
-                <a:latin typeface="Times New Roman"/>
-              </a:rPr>
-              <a:t>Dinleme tek başına gelişir, öğretilemez gibi yaygın görüşlere rağmen bu iddia araştırmayla doğrulanmamıştır (Funk ve Funk, 1989).</a:t>
+              <a:rPr sz="2500" b="0">
+                <a:latin typeface="Times New Roman"/>
+              </a:rPr>
+              <a:t>Amaçlar: damgalamayı silmek, engelli çocuğun sosyal statüsünü yükseltmek, daha iyi ve ucuz bir öğrenme çevresi yaratmak.</a:t>
             </a:r>
           </a:p>
           <a:p>
@@ -7209,10 +7281,10 @@
               </a:spcAft>
             </a:pPr>
             <a:r>
-              <a:rPr sz="2400" b="0">
-                <a:latin typeface="Times New Roman"/>
-              </a:rPr>
-              <a:t>İlköğretim öğrencileri zayıf dinleyicidir; nedenleri arasında dinleme eğitimine yeterince yer verilmemesi ve evde dinleme etkileşiminin azlığı vardır (Brent ve Anderson, 1993).</a:t>
+              <a:rPr sz="2500" b="0">
+                <a:latin typeface="Times New Roman"/>
+              </a:rPr>
+              <a:t>En az kısıtlayıcı ortam ilkesine göre kaynaştırma, eğitim ortamları içinde en üst basamaktır (Kırcaali-İftar, 1998).</a:t>
             </a:r>
           </a:p>
           <a:p>
@@ -7222,10 +7294,10 @@
               </a:spcAft>
             </a:pPr>
             <a:r>
-              <a:rPr sz="2400" b="0">
-                <a:latin typeface="Times New Roman"/>
-              </a:rPr>
-              <a:t>Dinleme eğitiminde görsel öğeler, hikâye haritası, düşünce şeması gibi teknikler başarıyı artırır (Winn, 1988).</a:t>
+              <a:rPr sz="2500" b="0">
+                <a:latin typeface="Times New Roman"/>
+              </a:rPr>
+              <a:t>Türkiye’de kaynaştırma uygulamaları 1985’ten sonra başlamıştır (Kuz, 2001).</a:t>
             </a:r>
           </a:p>
         </p:txBody>
@@ -7247,7 +7319,7 @@
           <a:p>
             <a:fld id="{F302176B-0E47-46AC-8F43-DAB4B8A37D06}" type="slidenum">
               <a:rPr lang="tr-TR" smtClean="0"/>
-              <a:t>7</a:t>
+              <a:t>6</a:t>
             </a:fld>
             <a:endParaRPr lang="tr-TR"/>
           </a:p>
@@ -7290,7 +7362,7 @@
               <a:rPr b="1">
                 <a:latin typeface="Times New Roman"/>
               </a:rPr>
-              <a:t>Giriş: Metin Türleri</a:t>
+              <a:t>Giriş: Dinleme Becerisi</a:t>
             </a:r>
           </a:p>
         </p:txBody>
@@ -7318,16 +7390,10 @@
               </a:spcAft>
             </a:pPr>
             <a:r>
-              <a:rPr sz="2500" b="1">
-                <a:latin typeface="Times New Roman"/>
-              </a:rPr>
-              <a:t>Hikâye edici metin: </a:t>
-            </a:r>
-            <a:r>
-              <a:rPr sz="2500" b="0">
-                <a:latin typeface="Times New Roman"/>
-              </a:rPr>
-              <a:t>sahne, karakter, olay, problem çözme, sonuç, ana fikir ve tepki aşamalarını içerir; okul öncesi dönemden beri tanıdık bir yapıdır, anlamak ve hatırlamak daha kolaydır (Graesser vd., 1991).</a:t>
+              <a:rPr sz="2400" b="0">
+                <a:latin typeface="Times New Roman"/>
+              </a:rPr>
+              <a:t>Dinleme: sözlü iletişimde mesajı anlama ve cevap verme etkinliğidir; insanın kazandığı ilk dil becerisidir (Ömür, 2006).</a:t>
             </a:r>
           </a:p>
           <a:p>
@@ -7337,16 +7403,10 @@
               </a:spcAft>
             </a:pPr>
             <a:r>
-              <a:rPr sz="2500" b="1">
-                <a:latin typeface="Times New Roman"/>
-              </a:rPr>
-              <a:t>Bilgi verici metin: </a:t>
-            </a:r>
-            <a:r>
-              <a:rPr sz="2500" b="0">
-                <a:latin typeface="Times New Roman"/>
-              </a:rPr>
-              <a:t>amacı bilgi aktarmaktır; anlatım düzdür, yaratıcılık ve kurgusallık yoktur, gerçek dünyadaki durumları anlatır (Özdemir, 1998).</a:t>
+              <a:rPr sz="2400" b="0">
+                <a:latin typeface="Times New Roman"/>
+              </a:rPr>
+              <a:t>Dinleme tek başına gelişir, öğretilemez gibi yaygın görüşlere rağmen bu iddia araştırmayla doğrulanmamıştır (Funk ve Funk, 1989).</a:t>
             </a:r>
           </a:p>
           <a:p>
@@ -7356,16 +7416,23 @@
               </a:spcAft>
             </a:pPr>
             <a:r>
-              <a:rPr sz="2500" b="1">
-                <a:latin typeface="Times New Roman"/>
-              </a:rPr>
-              <a:t>Bilgilendirici metin anlama: </a:t>
-            </a:r>
-            <a:r>
-              <a:rPr sz="2500" b="0">
-                <a:latin typeface="Times New Roman"/>
-              </a:rPr>
-              <a:t>5N1K (kim, ne, ne zaman, nerede, nasıl, niçin), ana fikir ve yardımcı fikirlerin bulunması (Alperen, 1999).</a:t>
+              <a:rPr sz="2400" b="0">
+                <a:latin typeface="Times New Roman"/>
+              </a:rPr>
+              <a:t>İlköğretim öğrencileri zayıf dinleyicidir; nedenleri arasında dinleme eğitimine yeterince yer verilmemesi ve evde dinleme etkileşiminin azlığı vardır (Brent ve Anderson, 1993).</a:t>
+            </a:r>
+          </a:p>
+          <a:p>
+            <a:pPr>
+              <a:spcAft>
+                <a:spcPts val="600"/>
+              </a:spcAft>
+            </a:pPr>
+            <a:r>
+              <a:rPr sz="2400" b="0">
+                <a:latin typeface="Times New Roman"/>
+              </a:rPr>
+              <a:t>Dinleme eğitiminde görsel öğeler, hikâye haritası, düşünce şeması gibi teknikler başarıyı artırır (Winn, 1988).</a:t>
             </a:r>
           </a:p>
         </p:txBody>
@@ -7387,7 +7454,7 @@
           <a:p>
             <a:fld id="{F302176B-0E47-46AC-8F43-DAB4B8A37D06}" type="slidenum">
               <a:rPr lang="tr-TR" smtClean="0"/>
-              <a:t>8</a:t>
+              <a:t>7</a:t>
             </a:fld>
             <a:endParaRPr lang="tr-TR"/>
           </a:p>
@@ -7430,7 +7497,7 @@
               <a:rPr b="1">
                 <a:latin typeface="Times New Roman"/>
               </a:rPr>
-              <a:t>Problem ve Alt Problemler</a:t>
+              <a:t>Giriş: Metin Türleri</a:t>
             </a:r>
           </a:p>
         </p:txBody>
@@ -7458,16 +7525,16 @@
               </a:spcAft>
             </a:pPr>
             <a:r>
-              <a:rPr sz="2400" b="1">
-                <a:latin typeface="Times New Roman"/>
-              </a:rPr>
-              <a:t>Ana problem: </a:t>
-            </a:r>
-            <a:r>
-              <a:rPr sz="2400" b="0">
-                <a:latin typeface="Times New Roman"/>
-              </a:rPr>
-              <a:t>Hafif düzeyde zihinsel yetersizliği olan kaynaştırma öğrencilerinin dinlediğini anlama becerileri nasıldır?</a:t>
+              <a:rPr sz="2500" b="1">
+                <a:latin typeface="Times New Roman"/>
+              </a:rPr>
+              <a:t>Hikâye edici metin: </a:t>
+            </a:r>
+            <a:r>
+              <a:rPr sz="2500" b="0">
+                <a:latin typeface="Times New Roman"/>
+              </a:rPr>
+              <a:t>sahne, karakter, olay, problem çözme, sonuç, ana fikir ve tepki aşamalarını içerir; okul öncesi dönemden beri tanıdık bir yapıdır, anlamak ve hatırlamak daha kolaydır (Graesser vd., 1991).</a:t>
             </a:r>
           </a:p>
           <a:p>
@@ -7477,10 +7544,16 @@
               </a:spcAft>
             </a:pPr>
             <a:r>
-              <a:rPr sz="2400" b="0">
-                <a:latin typeface="Times New Roman"/>
-              </a:rPr>
-              <a:t>Alt problemler: öğrencilerin (1) hikâyeyi ve (2) bilgilendirici metni yalnızca işitsel materyalle; (3) hikâyeyi ve (4) bilgilendirici metni görsel-işitsel materyalle dinlediklerinde anlama düzeyleri nasıldır?</a:t>
+              <a:rPr sz="2500" b="1">
+                <a:latin typeface="Times New Roman"/>
+              </a:rPr>
+              <a:t>Bilgi verici metin: </a:t>
+            </a:r>
+            <a:r>
+              <a:rPr sz="2500" b="0">
+                <a:latin typeface="Times New Roman"/>
+              </a:rPr>
+              <a:t>amacı bilgi aktarmaktır; anlatım düzdür, yaratıcılık ve kurgusallık yoktur, gerçek dünyadaki durumları anlatır (Özdemir, 1998).</a:t>
             </a:r>
           </a:p>
           <a:p>
@@ -7490,23 +7563,16 @@
               </a:spcAft>
             </a:pPr>
             <a:r>
-              <a:rPr sz="2400" b="0">
-                <a:latin typeface="Times New Roman"/>
-              </a:rPr>
-              <a:t>(5) İşitsel ve görsel-işitsel materyal kullanımının anlamaya etkisi nedir?</a:t>
-            </a:r>
-          </a:p>
-          <a:p>
-            <a:pPr>
-              <a:spcAft>
-                <a:spcPts val="600"/>
-              </a:spcAft>
-            </a:pPr>
-            <a:r>
-              <a:rPr sz="2400" b="0">
-                <a:latin typeface="Times New Roman"/>
-              </a:rPr>
-              <a:t>(6) Hikâye edici ve bilgi verici metin türlerinin anlamaya etkisi nedir?</a:t>
+              <a:rPr sz="2500" b="1">
+                <a:latin typeface="Times New Roman"/>
+              </a:rPr>
+              <a:t>Bilgilendirici metin anlama: </a:t>
+            </a:r>
+            <a:r>
+              <a:rPr sz="2500" b="0">
+                <a:latin typeface="Times New Roman"/>
+              </a:rPr>
+              <a:t>5N1K (kim, ne, ne zaman, nerede, nasıl, niçin), ana fikir ve yardımcı fikirlerin bulunması (Alperen, 1999).</a:t>
             </a:r>
           </a:p>
         </p:txBody>
@@ -7528,7 +7594,7 @@
           <a:p>
             <a:fld id="{F302176B-0E47-46AC-8F43-DAB4B8A37D06}" type="slidenum">
               <a:rPr lang="tr-TR" smtClean="0"/>
-              <a:t>9</a:t>
+              <a:t>8</a:t>
             </a:fld>
             <a:endParaRPr lang="tr-TR"/>
           </a:p>
@@ -7571,7 +7637,7 @@
               <a:rPr b="1">
                 <a:latin typeface="Times New Roman"/>
               </a:rPr>
-              <a:t>Amaç, Önem ve Sınırlılıklar</a:t>
+              <a:t>Problem ve Alt Problemler</a:t>
             </a:r>
           </a:p>
         </p:txBody>
@@ -7599,16 +7665,16 @@
               </a:spcAft>
             </a:pPr>
             <a:r>
-              <a:rPr sz="2500" b="1">
-                <a:latin typeface="Times New Roman"/>
-              </a:rPr>
-              <a:t>Amaç: </a:t>
-            </a:r>
-            <a:r>
-              <a:rPr sz="2500" b="0">
-                <a:latin typeface="Times New Roman"/>
-              </a:rPr>
-              <a:t>Öğrencilerin dinlediğini anlama becerilerini ölçmek ve görsel ile işitsel materyal arasındaki etkileşimi belirlemek.</a:t>
+              <a:rPr sz="2400" b="1">
+                <a:latin typeface="Times New Roman"/>
+              </a:rPr>
+              <a:t>Ana problem: </a:t>
+            </a:r>
+            <a:r>
+              <a:rPr sz="2400" b="0">
+                <a:latin typeface="Times New Roman"/>
+              </a:rPr>
+              <a:t>Hafif düzeyde zihinsel yetersizliği olan kaynaştırma öğrencilerinin dinlediğini anlama becerileri nasıldır?</a:t>
             </a:r>
           </a:p>
           <a:p>
@@ -7618,16 +7684,10 @@
               </a:spcAft>
             </a:pPr>
             <a:r>
-              <a:rPr sz="2500" b="1">
-                <a:latin typeface="Times New Roman"/>
-              </a:rPr>
-              <a:t>Önem: </a:t>
-            </a:r>
-            <a:r>
-              <a:rPr sz="2500" b="0">
-                <a:latin typeface="Times New Roman"/>
-              </a:rPr>
-              <a:t>Sonuçlar, hafif düzeyde zihinsel engelli çocukların eğitim ortamı ve materyallerinin düzenlenmesine ve öğretmen yetiştirme programlarına fikir verebilir.</a:t>
+              <a:rPr sz="2400" b="0">
+                <a:latin typeface="Times New Roman"/>
+              </a:rPr>
+              <a:t>Alt problemler: öğrencilerin (1) hikâyeyi ve (2) bilgilendirici metni yalnızca işitsel materyalle; (3) hikâyeyi ve (4) bilgilendirici metni görsel-işitsel materyalle dinlediklerinde anlama düzeyleri nasıldır?</a:t>
             </a:r>
           </a:p>
           <a:p>
@@ -7637,16 +7697,23 @@
               </a:spcAft>
             </a:pPr>
             <a:r>
-              <a:rPr sz="2500" b="1">
-                <a:latin typeface="Times New Roman"/>
-              </a:rPr>
-              <a:t>Sınırlılıklar: </a:t>
-            </a:r>
-            <a:r>
-              <a:rPr sz="2500" b="0">
-                <a:latin typeface="Times New Roman"/>
-              </a:rPr>
-              <a:t>İstanbul’da ilköğretime devam eden 11-12 yaşlarında, 50-70 arası zekâ bölümlü üç öğrenci; yalnızca işitsel ve görsel-işitsel materyaller.</a:t>
+              <a:rPr sz="2400" b="0">
+                <a:latin typeface="Times New Roman"/>
+              </a:rPr>
+              <a:t>(5) İşitsel ve görsel-işitsel materyal kullanımının anlamaya etkisi nedir?</a:t>
+            </a:r>
+          </a:p>
+          <a:p>
+            <a:pPr>
+              <a:spcAft>
+                <a:spcPts val="600"/>
+              </a:spcAft>
+            </a:pPr>
+            <a:r>
+              <a:rPr sz="2400" b="0">
+                <a:latin typeface="Times New Roman"/>
+              </a:rPr>
+              <a:t>(6) Hikâye edici ve bilgi verici metin türlerinin anlamaya etkisi nedir?</a:t>
             </a:r>
           </a:p>
         </p:txBody>
@@ -7668,7 +7735,7 @@
           <a:p>
             <a:fld id="{F302176B-0E47-46AC-8F43-DAB4B8A37D06}" type="slidenum">
               <a:rPr lang="tr-TR" smtClean="0"/>
-              <a:t>10</a:t>
+              <a:t>9</a:t>
             </a:fld>
             <a:endParaRPr lang="tr-TR"/>
           </a:p>

</xml_diff>

<commit_message>
Makale1: black link text and visible URL on last slide
Co-Authored-By: Claude Sonnet 5.5 <noreply@anthropic.com>
Claude-Session: https://claude.ai/code/session_01TyFKmLJqyxNygHvjK9ydxU
</commit_message>
<xml_diff>
--- a/Makale1_Dinledigini_Anlama_Ozet.pptx
+++ b/Makale1_Dinledigini_Anlama_Ozet.pptx
@@ -6741,8 +6741,8 @@
         </p:nvSpPr>
         <p:spPr>
           <a:xfrm>
-            <a:off x="457200" y="5257800"/>
-            <a:ext cx="7543800" cy="1005840"/>
+            <a:off x="457200" y="5074920"/>
+            <a:ext cx="7543800" cy="1234440"/>
           </a:xfrm>
           <a:prstGeom prst="roundRect">
             <a:avLst>
@@ -6780,8 +6780,17 @@
             <a:pPr algn="ctr"/>
             <a:r>
               <a:rPr sz="2200" b="1">
-                <a:latin typeface="Times New Roman"/>
-                <a:hlinkClick r:id="rId2"/>
+                <a:solidFill>
+                  <a:srgbClr val="000000"/>
+                </a:solidFill>
+                <a:latin typeface="Times New Roman"/>
+                <a:hlinkClick r:id="rId2">
+                  <a:extLst>
+                    <a:ext uri="{A12FA001-AC4F-418D-AE19-62706E023703}">
+                      <ahyp:hlinkClr xmlns:ahyp="http://schemas.microsoft.com/office/drawing/2018/hyperlinkcolor" val="tx"/>
+                    </a:ext>
+                  </a:extLst>
+                </a:hlinkClick>
               </a:rPr>
               <a:t>Makalenin tamamına buradan ulaşabilirsiniz</a:t>
             </a:r>
@@ -6790,10 +6799,38 @@
             <a:pPr algn="ctr"/>
             <a:r>
               <a:rPr sz="1600" b="0">
-                <a:latin typeface="Times New Roman"/>
-                <a:hlinkClick r:id="rId2"/>
-              </a:rPr>
-              <a:t>dergipark.org.tr  ›  Makaleyi açmak için tıklayın</a:t>
+                <a:solidFill>
+                  <a:srgbClr val="000000"/>
+                </a:solidFill>
+                <a:latin typeface="Times New Roman"/>
+                <a:hlinkClick r:id="rId2">
+                  <a:extLst>
+                    <a:ext uri="{A12FA001-AC4F-418D-AE19-62706E023703}">
+                      <ahyp:hlinkClr xmlns:ahyp="http://schemas.microsoft.com/office/drawing/2018/hyperlinkcolor" val="tx"/>
+                    </a:ext>
+                  </a:extLst>
+                </a:hlinkClick>
+              </a:rPr>
+              <a:t>Makaleyi açmak için tıklayın  ›</a:t>
+            </a:r>
+          </a:p>
+          <a:p>
+            <a:pPr algn="ctr"/>
+            <a:r>
+              <a:rPr sz="1300">
+                <a:solidFill>
+                  <a:srgbClr val="000000"/>
+                </a:solidFill>
+                <a:latin typeface="Times New Roman"/>
+                <a:hlinkClick r:id="rId2">
+                  <a:extLst>
+                    <a:ext uri="{A12FA001-AC4F-418D-AE19-62706E023703}">
+                      <ahyp:hlinkClr xmlns:ahyp="http://schemas.microsoft.com/office/drawing/2018/hyperlinkcolor" val="tx"/>
+                    </a:ext>
+                  </a:extLst>
+                </a:hlinkClick>
+              </a:rPr>
+              <a:t>https://dergipark.org.tr/tr/pub/abuhsbd/article/366618</a:t>
             </a:r>
           </a:p>
         </p:txBody>

</xml_diff>